<commit_message>
Verkort voice-over en voeg praktijkvoorbeelden toe
</commit_message>
<xml_diff>
--- a/video-handleiding/Live-Diabetes-Quiz-storyboard.pptx
+++ b/video-handleiding/Live-Diabetes-Quiz-storyboard.pptx
@@ -2,24 +2,24 @@
 <file path=ppt/presentation.xml><?xml version="1.0" encoding="utf-8"?>
 <p:presentation xmlns:p="http://schemas.openxmlformats.org/presentationml/2006/main">
   <p:sldMasterIdLst>
-    <p:sldMasterId xmlns:r="http://schemas.openxmlformats.org/officeDocument/2006/relationships" id="2147483648" r:id="Re11949a2400a428d"/>
+    <p:sldMasterId xmlns:r="http://schemas.openxmlformats.org/officeDocument/2006/relationships" id="2147483648" r:id="Rfe37beedebc1477e"/>
   </p:sldMasterIdLst>
   <p:notesMasterIdLst>
-    <p:notesMasterId xmlns:r="http://schemas.openxmlformats.org/officeDocument/2006/relationships" r:id="R01d4e3df2c3841fd"/>
+    <p:notesMasterId xmlns:r="http://schemas.openxmlformats.org/officeDocument/2006/relationships" r:id="R10e1aa8e8b1341a2"/>
   </p:notesMasterIdLst>
   <p:sldIdLst>
-    <p:sldId xmlns:r="http://schemas.openxmlformats.org/officeDocument/2006/relationships" id="256" r:id="R5390eec433b64f83"/>
-    <p:sldId xmlns:r="http://schemas.openxmlformats.org/officeDocument/2006/relationships" id="257" r:id="Rdd2bb86bfd3541b8"/>
-    <p:sldId xmlns:r="http://schemas.openxmlformats.org/officeDocument/2006/relationships" id="258" r:id="R0da8111bcc524a62"/>
-    <p:sldId xmlns:r="http://schemas.openxmlformats.org/officeDocument/2006/relationships" id="259" r:id="Redf4267afbd340c8"/>
-    <p:sldId xmlns:r="http://schemas.openxmlformats.org/officeDocument/2006/relationships" id="260" r:id="R661d3f77771d4e46"/>
-    <p:sldId xmlns:r="http://schemas.openxmlformats.org/officeDocument/2006/relationships" id="261" r:id="R9dd2262ab7cc44aa"/>
-    <p:sldId xmlns:r="http://schemas.openxmlformats.org/officeDocument/2006/relationships" id="262" r:id="R57d690a514c54429"/>
-    <p:sldId xmlns:r="http://schemas.openxmlformats.org/officeDocument/2006/relationships" id="263" r:id="R07bca66f728a4e68"/>
-    <p:sldId xmlns:r="http://schemas.openxmlformats.org/officeDocument/2006/relationships" id="264" r:id="Rda17c0f82d4d4503"/>
-    <p:sldId xmlns:r="http://schemas.openxmlformats.org/officeDocument/2006/relationships" id="265" r:id="R253c3bc08dfa4ef7"/>
-    <p:sldId xmlns:r="http://schemas.openxmlformats.org/officeDocument/2006/relationships" id="266" r:id="R41392fcfcb7c483d"/>
-    <p:sldId xmlns:r="http://schemas.openxmlformats.org/officeDocument/2006/relationships" id="267" r:id="R39df790da4b6475e"/>
+    <p:sldId xmlns:r="http://schemas.openxmlformats.org/officeDocument/2006/relationships" id="256" r:id="Rea4f0e6cf3454102"/>
+    <p:sldId xmlns:r="http://schemas.openxmlformats.org/officeDocument/2006/relationships" id="257" r:id="Rc2db5ee26ddf4f4e"/>
+    <p:sldId xmlns:r="http://schemas.openxmlformats.org/officeDocument/2006/relationships" id="258" r:id="Rb3b49cca6c044439"/>
+    <p:sldId xmlns:r="http://schemas.openxmlformats.org/officeDocument/2006/relationships" id="259" r:id="R47225dbc65fd4f30"/>
+    <p:sldId xmlns:r="http://schemas.openxmlformats.org/officeDocument/2006/relationships" id="260" r:id="R2b7f1a6daa2d4d74"/>
+    <p:sldId xmlns:r="http://schemas.openxmlformats.org/officeDocument/2006/relationships" id="261" r:id="Rad5cf1f6904e41ee"/>
+    <p:sldId xmlns:r="http://schemas.openxmlformats.org/officeDocument/2006/relationships" id="262" r:id="Rea2cfbe7c0d742ed"/>
+    <p:sldId xmlns:r="http://schemas.openxmlformats.org/officeDocument/2006/relationships" id="263" r:id="Rf6d2e44bb9ed4f58"/>
+    <p:sldId xmlns:r="http://schemas.openxmlformats.org/officeDocument/2006/relationships" id="264" r:id="Rd0df45bbd3e74836"/>
+    <p:sldId xmlns:r="http://schemas.openxmlformats.org/officeDocument/2006/relationships" id="265" r:id="Ra25b368239ba4c8b"/>
+    <p:sldId xmlns:r="http://schemas.openxmlformats.org/officeDocument/2006/relationships" id="266" r:id="Ra90de54ab60148eb"/>
+    <p:sldId xmlns:r="http://schemas.openxmlformats.org/officeDocument/2006/relationships" id="267" r:id="R9eac2c164da04587"/>
   </p:sldIdLst>
   <p:sldSz cx="12192000" cy="6858000"/>
   <p:notesSz cx="6858000" cy="9144000"/>
@@ -453,7 +453,7 @@
           <a:lstStyle xmlns:a="http://schemas.openxmlformats.org/drawingml/2006/main"/>
           <a:p xmlns:a="http://schemas.openxmlformats.org/drawingml/2006/main">
             <a:r>
-              <a:t>GESCHATTE DUUR: 20 seconden</a:t>
+              <a:t>DIA 1 — Live Diabetes Quiz</a:t>
             </a:r>
           </a:p>
           <a:p xmlns:a="http://schemas.openxmlformats.org/drawingml/2006/main">
@@ -463,12 +463,22 @@
           </a:p>
           <a:p xmlns:a="http://schemas.openxmlformats.org/drawingml/2006/main">
             <a:r>
+              <a:t>GESCHATTE DUUR: 18 seconden</a:t>
+            </a:r>
+          </a:p>
+          <a:p xmlns:a="http://schemas.openxmlformats.org/drawingml/2006/main">
+            <a:r>
+              <a:t/>
+            </a:r>
+          </a:p>
+          <a:p xmlns:a="http://schemas.openxmlformats.org/drawingml/2006/main">
+            <a:r>
               <a:t>VOICE-OVER:</a:t>
             </a:r>
           </a:p>
           <a:p xmlns:a="http://schemas.openxmlformats.org/drawingml/2006/main">
             <a:r>
-              <a:t>Welkom bij de Live Diabetes Quiz. In deze korte handleiding doorlopen we rustig alle stappen, vanaf het voorbereiden van de quiz tot en met de eindanalyse. U ziet telkens dezelfde schermen en knoppen die u later ook werkelijk gebruikt. Zo kunt u vooraf vertrouwd raken met de werking en zonder haast aan een quiz beginnen.</a:t>
+              <a:t>Welkom bij de Live Diabetes Quiz. In ongeveer vijf minuten ziet u rustig hoe u een quiz voorbereidt, hoe deelnemers antwoorden en hoe u afsluit met de eindanalyse. We gebruiken daarbij dezelfde schermen en knoppen als tijdens een echte quiz.</a:t>
             </a:r>
           </a:p>
           <a:p xmlns:a="http://schemas.openxmlformats.org/drawingml/2006/main">
@@ -498,7 +508,7 @@
           </a:p>
           <a:p xmlns:a="http://schemas.openxmlformats.org/drawingml/2006/main">
             <a:r>
-              <a:t>- Eigen projectbeeld: C:\Users\fredd\Documents\Live quiz\docs\assets\logo-diabetes-liga-midden-limburg.png</a:t>
+              <a:t>- Eigen projectafbeelding: C:/Users/fredd/Documents/Live quiz/docs/assets/logo-diabetes-liga-midden-limburg.png</a:t>
             </a:r>
           </a:p>
         </p:txBody>
@@ -568,7 +578,7 @@
           <a:lstStyle xmlns:a="http://schemas.openxmlformats.org/drawingml/2006/main"/>
           <a:p xmlns:a="http://schemas.openxmlformats.org/drawingml/2006/main">
             <a:r>
-              <a:t>GESCHATTE DUUR: 30 seconden</a:t>
+              <a:t>DIA 10 — Iedere deelnemer krijgt een persoonlijk resultaat</a:t>
             </a:r>
           </a:p>
           <a:p xmlns:a="http://schemas.openxmlformats.org/drawingml/2006/main">
@@ -578,12 +588,22 @@
           </a:p>
           <a:p xmlns:a="http://schemas.openxmlformats.org/drawingml/2006/main">
             <a:r>
+              <a:t>GESCHATTE DUUR: 22 seconden</a:t>
+            </a:r>
+          </a:p>
+          <a:p xmlns:a="http://schemas.openxmlformats.org/drawingml/2006/main">
+            <a:r>
+              <a:t/>
+            </a:r>
+          </a:p>
+          <a:p xmlns:a="http://schemas.openxmlformats.org/drawingml/2006/main">
+            <a:r>
               <a:t>VOICE-OVER:</a:t>
             </a:r>
           </a:p>
           <a:p xmlns:a="http://schemas.openxmlformats.org/drawingml/2006/main">
             <a:r>
-              <a:t>Na de laatste vraag krijgt iedere deelnemer op de eigen gsm een persoonlijk resultaat. De score en de eigen fout beantwoorde vragen worden overzichtelijk weergegeven. Er wordt geen naam gevraagd en er verschijnt geen publieke rangschikking. Andere deelnemers kunnen dit persoonlijke overzicht dus niet zien. Daarna mag de deelnemer het scherm sluiten.</a:t>
+              <a:t>Na de laatste vraag ziet iedere deelnemer alleen op de eigen gsm het persoonlijke resultaat. Acht op tien betekent bijvoorbeeld acht juiste en twee foute antwoorden. Er is geen publieke rangschikking en niemand anders ziet deze score. Daarna mag het scherm worden gesloten.</a:t>
             </a:r>
           </a:p>
           <a:p xmlns:a="http://schemas.openxmlformats.org/drawingml/2006/main">
@@ -613,7 +633,7 @@
           </a:p>
           <a:p xmlns:a="http://schemas.openxmlformats.org/drawingml/2006/main">
             <a:r>
-              <a:t>- Eigen projectbeeld: C:\Users\fredd\Documents\Live quiz\docs\assets\handleiding\deelnemer-resultaat.jpg</a:t>
+              <a:t>- Eigen projectafbeelding: C:/Users/fredd/Documents/Live quiz/docs/assets/handleiding/deelnemer-resultaat.jpg</a:t>
             </a:r>
           </a:p>
         </p:txBody>
@@ -683,7 +703,7 @@
           <a:lstStyle xmlns:a="http://schemas.openxmlformats.org/drawingml/2006/main"/>
           <a:p xmlns:a="http://schemas.openxmlformats.org/drawingml/2006/main">
             <a:r>
-              <a:t>GESCHATTE DUUR: 35 seconden</a:t>
+              <a:t>DIA 11 — De zaal sluit af met drie leerpunten</a:t>
             </a:r>
           </a:p>
           <a:p xmlns:a="http://schemas.openxmlformats.org/drawingml/2006/main">
@@ -693,12 +713,22 @@
           </a:p>
           <a:p xmlns:a="http://schemas.openxmlformats.org/drawingml/2006/main">
             <a:r>
+              <a:t>GESCHATTE DUUR: 25 seconden</a:t>
+            </a:r>
+          </a:p>
+          <a:p xmlns:a="http://schemas.openxmlformats.org/drawingml/2006/main">
+            <a:r>
+              <a:t/>
+            </a:r>
+          </a:p>
+          <a:p xmlns:a="http://schemas.openxmlformats.org/drawingml/2006/main">
+            <a:r>
               <a:t>VOICE-OVER:</a:t>
             </a:r>
           </a:p>
           <a:p xmlns:a="http://schemas.openxmlformats.org/drawingml/2006/main">
             <a:r>
-              <a:t>Op het grote zaalscherm verschijnt de gezamenlijke eindanalyse. Die toont de drie vragen die het vaakst fout werden beantwoord. Bij iedere vraag staat ook het juiste antwoord. Dit is een goed moment om de belangrijkste leerpunten nog eens rustig te herhalen. Persoonlijke scores worden niet op het grote scherm getoond.</a:t>
+              <a:t>De gezamenlijke eindanalyse toont de drie vaakst fout beantwoorde vragen met hun juiste antwoord. Was een vraag bijvoorbeeld fout bij achttien van de dertig deelnemers, dan komt die waarschijnlijk in de top drie. Herhaal deze leerpunten kort. Persoonlijke scores verschijnen nooit op het zaalscherm.</a:t>
             </a:r>
           </a:p>
           <a:p xmlns:a="http://schemas.openxmlformats.org/drawingml/2006/main">
@@ -728,7 +758,7 @@
           </a:p>
           <a:p xmlns:a="http://schemas.openxmlformats.org/drawingml/2006/main">
             <a:r>
-              <a:t>- Eigen projectbeeld: C:\Users\fredd\Documents\Live quiz\docs\assets\handleiding\zaalscherm-eindanalyse.jpg</a:t>
+              <a:t>- Eigen projectafbeelding: C:/Users/fredd/Documents/Live quiz/docs/assets/handleiding/zaalscherm-eindanalyse.jpg</a:t>
             </a:r>
           </a:p>
         </p:txBody>
@@ -798,7 +828,7 @@
           <a:lstStyle xmlns:a="http://schemas.openxmlformats.org/drawingml/2006/main"/>
           <a:p xmlns:a="http://schemas.openxmlformats.org/drawingml/2006/main">
             <a:r>
-              <a:t>GESCHATTE DUUR: 40 seconden</a:t>
+              <a:t>DIA 12 — Afronden of opnieuw beginnen</a:t>
             </a:r>
           </a:p>
           <a:p xmlns:a="http://schemas.openxmlformats.org/drawingml/2006/main">
@@ -808,12 +838,22 @@
           </a:p>
           <a:p xmlns:a="http://schemas.openxmlformats.org/drawingml/2006/main">
             <a:r>
+              <a:t>GESCHATTE DUUR: 25 seconden</a:t>
+            </a:r>
+          </a:p>
+          <a:p xmlns:a="http://schemas.openxmlformats.org/drawingml/2006/main">
+            <a:r>
+              <a:t/>
+            </a:r>
+          </a:p>
+          <a:p xmlns:a="http://schemas.openxmlformats.org/drawingml/2006/main">
+            <a:r>
               <a:t>VOICE-OVER:</a:t>
             </a:r>
           </a:p>
           <a:p xmlns:a="http://schemas.openxmlformats.org/drawingml/2006/main">
             <a:r>
-              <a:t>De quizmaster ziet op de laptop de volledige groepsanalyse. Wilt u nog een quiz spelen, kies dan Nieuwe sessie voorbereiden en selecteer opnieuw het aantal vragen. De gsm’s en het zaalscherm gaan automatisch mee naar de nieuwe sessie. Oefen vóór de eerste echte activiteit gerust eens met vijf vragen en enkele bestuursleden. De volledige handleiding blijft beschikbaar wanneer u later iets opnieuw wilt bekijken.</a:t>
+              <a:t>De quizmaster ziet op de laptop de groepsanalyse. Voor een nieuwe quiz kiest u Nieuwe sessie voorbereiden en opnieuw het aantal vragen. De gsm’s en het zaalscherm volgen automatisch. Oefen vooraf bijvoorbeeld met vijf vragen en enkele bestuursleden. De volledige handleiding blijft altijd beschikbaar.</a:t>
             </a:r>
           </a:p>
           <a:p xmlns:a="http://schemas.openxmlformats.org/drawingml/2006/main">
@@ -843,7 +883,7 @@
           </a:p>
           <a:p xmlns:a="http://schemas.openxmlformats.org/drawingml/2006/main">
             <a:r>
-              <a:t>- Eigen projectbeeld: C:\Users\fredd\Documents\Live quiz\docs\assets\handleiding\quizmaster-eindanalyse.jpg</a:t>
+              <a:t>- Eigen projectafbeelding: C:/Users/fredd/Documents/Live quiz/docs/assets/handleiding/quizmaster-eindanalyse.jpg</a:t>
             </a:r>
           </a:p>
         </p:txBody>
@@ -913,7 +953,7 @@
           <a:lstStyle xmlns:a="http://schemas.openxmlformats.org/drawingml/2006/main"/>
           <a:p xmlns:a="http://schemas.openxmlformats.org/drawingml/2006/main">
             <a:r>
-              <a:t>GESCHATTE DUUR: 35 seconden</a:t>
+              <a:t>DIA 2 — Drie schermen vormen samen één quiz</a:t>
             </a:r>
           </a:p>
           <a:p xmlns:a="http://schemas.openxmlformats.org/drawingml/2006/main">
@@ -923,12 +963,22 @@
           </a:p>
           <a:p xmlns:a="http://schemas.openxmlformats.org/drawingml/2006/main">
             <a:r>
+              <a:t>GESCHATTE DUUR: 30 seconden</a:t>
+            </a:r>
+          </a:p>
+          <a:p xmlns:a="http://schemas.openxmlformats.org/drawingml/2006/main">
+            <a:r>
+              <a:t/>
+            </a:r>
+          </a:p>
+          <a:p xmlns:a="http://schemas.openxmlformats.org/drawingml/2006/main">
+            <a:r>
               <a:t>VOICE-OVER:</a:t>
             </a:r>
           </a:p>
           <a:p xmlns:a="http://schemas.openxmlformats.org/drawingml/2006/main">
             <a:r>
-              <a:t>De quiz gebruikt drie verschillende schermen. De quizmaster bedient de quiz op de laptop. Iedere deelnemer antwoordt anoniem op de eigen gsm. Op het grote zaalscherm ziet iedereen dezelfde vraag en de vier mogelijke antwoorden. Onderaan verschijnen het aantal verbonden deelnemers en het aantal ontvangen antwoorden. Zo kan de quizmaster rustig wachten tot de zaal klaar is.</a:t>
+              <a:t>De quiz gebruikt drie schermen: de laptop van de quizmaster, de gsm van iedere deelnemer en het grote zaalscherm. Onderaan het zaalscherm staan twee tellers. Zijn er bijvoorbeeld dertig deelnemers verbonden en zijn ook dertig antwoorden ontvangen, dan weet de quizmaster dat iedereen heeft geantwoord en kan de quiz verdergaan.</a:t>
             </a:r>
           </a:p>
           <a:p xmlns:a="http://schemas.openxmlformats.org/drawingml/2006/main">
@@ -958,7 +1008,7 @@
           </a:p>
           <a:p xmlns:a="http://schemas.openxmlformats.org/drawingml/2006/main">
             <a:r>
-              <a:t>- Eigen projectbeeld: C:\Users\fredd\Documents\Live quiz\docs\assets\handleiding\zaalscherm-vraag.jpg</a:t>
+              <a:t>- Eigen projectafbeelding: C:/Users/fredd/Documents/Live quiz/docs/assets/handleiding/zaalscherm-vraag.jpg</a:t>
             </a:r>
           </a:p>
         </p:txBody>
@@ -1028,7 +1078,7 @@
           <a:lstStyle xmlns:a="http://schemas.openxmlformats.org/drawingml/2006/main"/>
           <a:p xmlns:a="http://schemas.openxmlformats.org/drawingml/2006/main">
             <a:r>
-              <a:t>GESCHATTE DUUR: 35 seconden</a:t>
+              <a:t>DIA 3 — Begin met een passend aantal vragen</a:t>
             </a:r>
           </a:p>
           <a:p xmlns:a="http://schemas.openxmlformats.org/drawingml/2006/main">
@@ -1038,12 +1088,22 @@
           </a:p>
           <a:p xmlns:a="http://schemas.openxmlformats.org/drawingml/2006/main">
             <a:r>
+              <a:t>GESCHATTE DUUR: 25 seconden</a:t>
+            </a:r>
+          </a:p>
+          <a:p xmlns:a="http://schemas.openxmlformats.org/drawingml/2006/main">
+            <a:r>
+              <a:t/>
+            </a:r>
+          </a:p>
+          <a:p xmlns:a="http://schemas.openxmlformats.org/drawingml/2006/main">
+            <a:r>
               <a:t>VOICE-OVER:</a:t>
             </a:r>
           </a:p>
           <a:p xmlns:a="http://schemas.openxmlformats.org/drawingml/2006/main">
             <a:r>
-              <a:t>Open de startpagina en kies Nieuwe quiz starten. U komt op het scherm Quiz voorbereiden. Kies hier het aantal vragen. Vijf vragen is handig voor een korte demonstratie. Tien vragen is aanbevolen voor een gewone quiz. Twintig vragen is het aanbevolen maximum. Klik daarna op Nieuwe quizsessie maken. De quizcode wordt automatisch aangemaakt.</a:t>
+              <a:t>Kies op de startpagina Nieuwe quiz starten en bepaal het aantal vragen. Vijf vragen is bijvoorbeeld geschikt voor een korte demonstratie met bestuursleden. Tien vragen is aanbevolen voor een gewone activiteit en twintig is het aanbevolen maximum. Klik daarna op Nieuwe quizsessie maken.</a:t>
             </a:r>
           </a:p>
           <a:p xmlns:a="http://schemas.openxmlformats.org/drawingml/2006/main">
@@ -1073,7 +1133,7 @@
           </a:p>
           <a:p xmlns:a="http://schemas.openxmlformats.org/drawingml/2006/main">
             <a:r>
-              <a:t>- Eigen projectbeeld: C:\Users\fredd\Documents\Live quiz\docs\assets\handleiding\quizmaster-voorbereiden.jpg</a:t>
+              <a:t>- Eigen projectafbeelding: C:/Users/fredd/Documents/Live quiz/docs/assets/handleiding/quizmaster-voorbereiden.jpg</a:t>
             </a:r>
           </a:p>
         </p:txBody>
@@ -1143,7 +1203,7 @@
           <a:lstStyle xmlns:a="http://schemas.openxmlformats.org/drawingml/2006/main"/>
           <a:p xmlns:a="http://schemas.openxmlformats.org/drawingml/2006/main">
             <a:r>
-              <a:t>GESCHATTE DUUR: 40 seconden</a:t>
+              <a:t>DIA 4 — Eén sessie maakt de zaal klaar</a:t>
             </a:r>
           </a:p>
           <a:p xmlns:a="http://schemas.openxmlformats.org/drawingml/2006/main">
@@ -1153,12 +1213,22 @@
           </a:p>
           <a:p xmlns:a="http://schemas.openxmlformats.org/drawingml/2006/main">
             <a:r>
+              <a:t>GESCHATTE DUUR: 25 seconden</a:t>
+            </a:r>
+          </a:p>
+          <a:p xmlns:a="http://schemas.openxmlformats.org/drawingml/2006/main">
+            <a:r>
+              <a:t/>
+            </a:r>
+          </a:p>
+          <a:p xmlns:a="http://schemas.openxmlformats.org/drawingml/2006/main">
+            <a:r>
               <a:t>VOICE-OVER:</a:t>
             </a:r>
           </a:p>
           <a:p xmlns:a="http://schemas.openxmlformats.org/drawingml/2006/main">
             <a:r>
-              <a:t>Na het maken van de sessie verschijnt de quizcode. Op dit scherm staan ook de twee belangrijke voorbereidingsknoppen. Open groot zaalscherm opent het venster dat u op de beamer of grote televisie toont. Deelnemersbriefjes afdrukken maakt twee briefjes per A4. De QR-code op dit scherm is alleen een controlevoorbeeld. Deelnemers gebruiken uitsluitend hun vooraf afgedrukte briefje.</a:t>
+              <a:t>Daarna verschijnt de driecijferige quizcode. Met Open groot zaalscherm opent u het beeld voor de beamer of grote televisie. Met Deelnemersbriefjes afdrukken maakt u twee briefjes per A4. De QR-code op de laptop is alleen ter controle; deelnemers gebruiken hun afgedrukte briefje.</a:t>
             </a:r>
           </a:p>
           <a:p xmlns:a="http://schemas.openxmlformats.org/drawingml/2006/main">
@@ -1188,7 +1258,7 @@
           </a:p>
           <a:p xmlns:a="http://schemas.openxmlformats.org/drawingml/2006/main">
             <a:r>
-              <a:t>- Eigen projectbeeld: C:\Users\fredd\Documents\Live quiz\docs\assets\handleiding\quizmaster-wachtkamer.jpg</a:t>
+              <a:t>- Eigen projectafbeelding: C:/Users/fredd/Documents/Live quiz/docs/assets/handleiding/quizmaster-wachtkamer.jpg</a:t>
             </a:r>
           </a:p>
         </p:txBody>
@@ -1258,7 +1328,7 @@
           <a:lstStyle xmlns:a="http://schemas.openxmlformats.org/drawingml/2006/main"/>
           <a:p xmlns:a="http://schemas.openxmlformats.org/drawingml/2006/main">
             <a:r>
-              <a:t>GESCHATTE DUUR: 45 seconden</a:t>
+              <a:t>DIA 5 — Het briefje wijst iedere deelnemer de weg</a:t>
             </a:r>
           </a:p>
           <a:p xmlns:a="http://schemas.openxmlformats.org/drawingml/2006/main">
@@ -1268,12 +1338,22 @@
           </a:p>
           <a:p xmlns:a="http://schemas.openxmlformats.org/drawingml/2006/main">
             <a:r>
+              <a:t>GESCHATTE DUUR: 30 seconden</a:t>
+            </a:r>
+          </a:p>
+          <a:p xmlns:a="http://schemas.openxmlformats.org/drawingml/2006/main">
+            <a:r>
+              <a:t/>
+            </a:r>
+          </a:p>
+          <a:p xmlns:a="http://schemas.openxmlformats.org/drawingml/2006/main">
+            <a:r>
               <a:t>VOICE-OVER:</a:t>
             </a:r>
           </a:p>
           <a:p xmlns:a="http://schemas.openxmlformats.org/drawingml/2006/main">
             <a:r>
-              <a:t>Geef iedere deelnemer bij het binnenkomen een briefje. Bovenaan staat eerst de vraag om de gsm met internet te verbinden. Mobiele data is meestal het eenvoudigst. Wie liever de wifi van de zaal gebruikt, kan de wifi-QR-code scannen. Daarna scant de deelnemer de quiz-QR-code. Lukt scannen niet, dan staan ook de internetlink en de driecijferige quizcode duidelijk op het briefje.</a:t>
+              <a:t>Geef iedere deelnemer bij het binnenkomen een briefje. Mobiele data is meestal het eenvoudigst. Wie de zaalwifi wil gebruiken, scant eerst de wifi-QR-code en daarna de quiz-QR-code. Lukt scannen bijvoorbeeld op een oudere gsm niet, dan typt men de vermelde link in de browser en vult men de quizcode van het briefje in.</a:t>
             </a:r>
           </a:p>
           <a:p xmlns:a="http://schemas.openxmlformats.org/drawingml/2006/main">
@@ -1303,7 +1383,7 @@
           </a:p>
           <a:p xmlns:a="http://schemas.openxmlformats.org/drawingml/2006/main">
             <a:r>
-              <a:t>- Eigen projectbeeld: C:\Users\fredd\Documents\Live quiz\docs\assets\handleiding\deelnemersbriefje.jpg</a:t>
+              <a:t>- Eigen projectafbeelding: C:/Users/fredd/Documents/Live quiz/docs/assets/handleiding/deelnemersbriefje.jpg</a:t>
             </a:r>
           </a:p>
         </p:txBody>
@@ -1373,7 +1453,7 @@
           <a:lstStyle xmlns:a="http://schemas.openxmlformats.org/drawingml/2006/main"/>
           <a:p xmlns:a="http://schemas.openxmlformats.org/drawingml/2006/main">
             <a:r>
-              <a:t>GESCHATTE DUUR: 30 seconden</a:t>
+              <a:t>DIA 6 — Na het verbinden hoeft men alleen te wachten</a:t>
             </a:r>
           </a:p>
           <a:p xmlns:a="http://schemas.openxmlformats.org/drawingml/2006/main">
@@ -1383,12 +1463,22 @@
           </a:p>
           <a:p xmlns:a="http://schemas.openxmlformats.org/drawingml/2006/main">
             <a:r>
+              <a:t>GESCHATTE DUUR: 20 seconden</a:t>
+            </a:r>
+          </a:p>
+          <a:p xmlns:a="http://schemas.openxmlformats.org/drawingml/2006/main">
+            <a:r>
+              <a:t/>
+            </a:r>
+          </a:p>
+          <a:p xmlns:a="http://schemas.openxmlformats.org/drawingml/2006/main">
+            <a:r>
               <a:t>VOICE-OVER:</a:t>
             </a:r>
           </a:p>
           <a:p xmlns:a="http://schemas.openxmlformats.org/drawingml/2006/main">
             <a:r>
-              <a:t>Na het scannen komt de deelnemer op het mobiele deelnemersscherm. Zodra de verbinding gelukt is, ziet hij of zij de quizcode, de status Wachtkamer en de melding U bent verbonden. De pagina moet gewoon open blijven staan. Wanneer de quizmaster de eerste vraag start, verschijnt die automatisch. De deelnemer hoeft niets te vernieuwen en geen naam in te vullen.</a:t>
+              <a:t>Na het verbinden ziet de deelnemer de Wachtkamer en de melding U bent verbonden. Laat deze pagina gewoon openstaan. Zodra de quizmaster start, verschijnt de eerste vraag automatisch. Vernieuwen of een naam invullen is niet nodig.</a:t>
             </a:r>
           </a:p>
           <a:p xmlns:a="http://schemas.openxmlformats.org/drawingml/2006/main">
@@ -1418,7 +1508,7 @@
           </a:p>
           <a:p xmlns:a="http://schemas.openxmlformats.org/drawingml/2006/main">
             <a:r>
-              <a:t>- Eigen projectbeeld: C:\Users\fredd\Documents\Live quiz\docs\assets\handleiding\deelnemer-wachtkamer.jpg</a:t>
+              <a:t>- Eigen projectafbeelding: C:/Users/fredd/Documents/Live quiz/docs/assets/handleiding/deelnemer-wachtkamer.jpg</a:t>
             </a:r>
           </a:p>
         </p:txBody>
@@ -1488,7 +1578,7 @@
           <a:lstStyle xmlns:a="http://schemas.openxmlformats.org/drawingml/2006/main"/>
           <a:p xmlns:a="http://schemas.openxmlformats.org/drawingml/2006/main">
             <a:r>
-              <a:t>GESCHATTE DUUR: 35 seconden</a:t>
+              <a:t>DIA 7 — Iedere deelnemer kiest één antwoord</a:t>
             </a:r>
           </a:p>
           <a:p xmlns:a="http://schemas.openxmlformats.org/drawingml/2006/main">
@@ -1498,12 +1588,22 @@
           </a:p>
           <a:p xmlns:a="http://schemas.openxmlformats.org/drawingml/2006/main">
             <a:r>
+              <a:t>GESCHATTE DUUR: 25 seconden</a:t>
+            </a:r>
+          </a:p>
+          <a:p xmlns:a="http://schemas.openxmlformats.org/drawingml/2006/main">
+            <a:r>
+              <a:t/>
+            </a:r>
+          </a:p>
+          <a:p xmlns:a="http://schemas.openxmlformats.org/drawingml/2006/main">
+            <a:r>
               <a:t>VOICE-OVER:</a:t>
             </a:r>
           </a:p>
           <a:p xmlns:a="http://schemas.openxmlformats.org/drawingml/2006/main">
             <a:r>
-              <a:t>Wanneer de quiz begint, ziet de deelnemer één vraag met vier grote antwoordknoppen. Tik één keer op het gekozen antwoord. Het antwoord wordt onmiddellijk en anoniem bewaard. Daarna verschijnt een bevestiging. Per vraag wordt maar één antwoord aanvaard. De deelnemer wacht vervolgens rustig tot de quizmaster het juiste antwoord toont of de volgende vraag opent.</a:t>
+              <a:t>De deelnemer ziet één vraag met vier grote knoppen. Denkt iemand bijvoorbeeld dat B juist is, dan tikt die persoon één keer op B. Het antwoord wordt anoniem bewaard en er verschijnt een bevestiging. Per vraag telt maar één antwoord; daarna wacht de deelnemer rustig.</a:t>
             </a:r>
           </a:p>
           <a:p xmlns:a="http://schemas.openxmlformats.org/drawingml/2006/main">
@@ -1533,7 +1633,7 @@
           </a:p>
           <a:p xmlns:a="http://schemas.openxmlformats.org/drawingml/2006/main">
             <a:r>
-              <a:t>- Eigen projectbeeld: C:\Users\fredd\Documents\Live quiz\docs\assets\handleiding\deelnemer-vraag.jpg</a:t>
+              <a:t>- Eigen projectafbeelding: C:/Users/fredd/Documents/Live quiz/docs/assets/handleiding/deelnemer-vraag.jpg</a:t>
             </a:r>
           </a:p>
         </p:txBody>
@@ -1603,7 +1703,7 @@
           <a:lstStyle xmlns:a="http://schemas.openxmlformats.org/drawingml/2006/main"/>
           <a:p xmlns:a="http://schemas.openxmlformats.org/drawingml/2006/main">
             <a:r>
-              <a:t>GESCHATTE DUUR: 45 seconden</a:t>
+              <a:t>DIA 8 — De quizmaster houdt het overzicht</a:t>
             </a:r>
           </a:p>
           <a:p xmlns:a="http://schemas.openxmlformats.org/drawingml/2006/main">
@@ -1613,12 +1713,22 @@
           </a:p>
           <a:p xmlns:a="http://schemas.openxmlformats.org/drawingml/2006/main">
             <a:r>
+              <a:t>GESCHATTE DUUR: 30 seconden</a:t>
+            </a:r>
+          </a:p>
+          <a:p xmlns:a="http://schemas.openxmlformats.org/drawingml/2006/main">
+            <a:r>
+              <a:t/>
+            </a:r>
+          </a:p>
+          <a:p xmlns:a="http://schemas.openxmlformats.org/drawingml/2006/main">
+            <a:r>
               <a:t>VOICE-OVER:</a:t>
             </a:r>
           </a:p>
           <a:p xmlns:a="http://schemas.openxmlformats.org/drawingml/2006/main">
             <a:r>
-              <a:t>Op het quizmasterscherm staat dezelfde vraag, maar met extra bedieningsinformatie. U ziet hoeveel deelnemers verbonden zijn en hoeveel antwoorden al ontvangen werden. Wacht rustig tot bijna iedereen geantwoord heeft. Daarna kunt u de antwoorden sluiten. De juiste oplossing is voor de quizmaster al herkenbaar, maar wordt pas aan de zaal getoond wanneer u daar bewust voor kiest.</a:t>
+              <a:t>De quizmaster ziet dezelfde vraag met extra bediening en de twee tellers. Zijn er dertig deelnemers verbonden maar pas achtentwintig antwoorden ontvangen, wacht dan nog even. Bij dertig antwoorden is iedereen klaar en kunt u de antwoorden sluiten. De juiste oplossing verschijnt pas in de zaal wanneer u daarvoor kiest.</a:t>
             </a:r>
           </a:p>
           <a:p xmlns:a="http://schemas.openxmlformats.org/drawingml/2006/main">
@@ -1648,7 +1758,7 @@
           </a:p>
           <a:p xmlns:a="http://schemas.openxmlformats.org/drawingml/2006/main">
             <a:r>
-              <a:t>- Eigen projectbeeld: C:\Users\fredd\Documents\Live quiz\docs\assets\handleiding\quizmaster-vraag-open.jpg</a:t>
+              <a:t>- Eigen projectafbeelding: C:/Users/fredd/Documents/Live quiz/docs/assets/handleiding/quizmaster-vraag-open.jpg</a:t>
             </a:r>
           </a:p>
         </p:txBody>
@@ -1718,7 +1828,7 @@
           <a:lstStyle xmlns:a="http://schemas.openxmlformats.org/drawingml/2006/main"/>
           <a:p xmlns:a="http://schemas.openxmlformats.org/drawingml/2006/main">
             <a:r>
-              <a:t>GESCHATTE DUUR: 40 seconden</a:t>
+              <a:t>DIA 9 — Toon de oplossing en bespreek ze kort</a:t>
             </a:r>
           </a:p>
           <a:p xmlns:a="http://schemas.openxmlformats.org/drawingml/2006/main">
@@ -1728,12 +1838,22 @@
           </a:p>
           <a:p xmlns:a="http://schemas.openxmlformats.org/drawingml/2006/main">
             <a:r>
+              <a:t>GESCHATTE DUUR: 30 seconden</a:t>
+            </a:r>
+          </a:p>
+          <a:p xmlns:a="http://schemas.openxmlformats.org/drawingml/2006/main">
+            <a:r>
+              <a:t/>
+            </a:r>
+          </a:p>
+          <a:p xmlns:a="http://schemas.openxmlformats.org/drawingml/2006/main">
+            <a:r>
               <a:t>VOICE-OVER:</a:t>
             </a:r>
           </a:p>
           <a:p xmlns:a="http://schemas.openxmlformats.org/drawingml/2006/main">
             <a:r>
-              <a:t>Klik op Toon juiste antwoord wanneer de antwoordtijd voorbij is. Het juiste antwoord wordt dan duidelijk zichtbaar op alle schermen. De quizmaster ziet ook hoe de antwoorden over de vier mogelijkheden verdeeld zijn. Neem even tijd om de oplossing kort toe te lichten. Klik daarna op Volgende vraag. De nieuwe vraag verschijnt automatisch bij alle deelnemers en op het grote zaalscherm.</a:t>
+              <a:t>Klik op Toon juiste antwoord. De oplossing en de verdeling verschijnen op alle schermen. Bij dertig deelnemers kan bijvoorbeeld tweeëntwintig bij B, vijf bij A, twee bij C en één bij D staan: samen dertig. Licht het antwoord kort toe en kies daarna Volgende vraag.</a:t>
             </a:r>
           </a:p>
           <a:p xmlns:a="http://schemas.openxmlformats.org/drawingml/2006/main">
@@ -1763,7 +1883,7 @@
           </a:p>
           <a:p xmlns:a="http://schemas.openxmlformats.org/drawingml/2006/main">
             <a:r>
-              <a:t>- Eigen projectbeeld: C:\Users\fredd\Documents\Live quiz\docs\assets\handleiding\quizmaster-oplossing.jpg</a:t>
+              <a:t>- Eigen projectafbeelding: C:/Users/fredd/Documents/Live quiz/docs/assets/handleiding/quizmaster-oplossing.jpg</a:t>
             </a:r>
           </a:p>
         </p:txBody>
@@ -1831,7 +1951,7 @@
   </p:cSld>
   <p:clrMap bg1="lt1" tx1="dk1" bg2="lt2" tx2="dk2" accent1="accent1" accent2="accent2" accent3="accent3" accent4="accent4" accent5="accent5" accent6="accent6" hlink="hlink" folHlink="folHlink"/>
   <p:sldLayoutIdLst>
-    <p:sldLayoutId xmlns:r="http://schemas.openxmlformats.org/officeDocument/2006/relationships" id="2147483649" r:id="R34f70abde92d4955"/>
+    <p:sldLayoutId xmlns:r="http://schemas.openxmlformats.org/officeDocument/2006/relationships" id="2147483649" r:id="R5283625a462b48de"/>
   </p:sldLayoutIdLst>
   <p:txStyles>
     <p:titleStyle>
@@ -2412,14 +2532,14 @@
       </p:sp>
       <p:pic>
         <p:nvPicPr>
-          <p:cNvPr id="11" name=""/>
+          <p:cNvPr id="13" name=""/>
           <p:cNvPicPr>
             <a:picLocks xmlns:a="http://schemas.openxmlformats.org/drawingml/2006/main" noChangeAspect="1"/>
           </p:cNvPicPr>
           <p:nvPr/>
         </p:nvPicPr>
         <p:blipFill>
-          <a:blip xmlns:r="http://schemas.openxmlformats.org/officeDocument/2006/relationships" xmlns:a="http://schemas.openxmlformats.org/drawingml/2006/main" r:embed="Rc8a075ad086d4dd2"/>
+          <a:blip xmlns:r="http://schemas.openxmlformats.org/officeDocument/2006/relationships" xmlns:a="http://schemas.openxmlformats.org/drawingml/2006/main" r:embed="R49c14c1bfbb64014"/>
           <a:stretch xmlns:a="http://schemas.openxmlformats.org/drawingml/2006/main"/>
         </p:blipFill>
         <p:spPr>
@@ -2465,6 +2585,7 @@
           <a:lstStyle xmlns:a="http://schemas.openxmlformats.org/drawingml/2006/main"/>
           <a:p xmlns:a="http://schemas.openxmlformats.org/drawingml/2006/main">
             <a:pPr>
+              <a:buNone/>
               <a:defRPr sz="1200" b="1">
                 <a:solidFill>
                   <a:srgbClr val="BDEFFF"/>
@@ -2515,6 +2636,7 @@
           <a:lstStyle xmlns:a="http://schemas.openxmlformats.org/drawingml/2006/main"/>
           <a:p xmlns:a="http://schemas.openxmlformats.org/drawingml/2006/main">
             <a:pPr>
+              <a:buNone/>
               <a:defRPr sz="4800" b="1">
                 <a:solidFill>
                   <a:srgbClr val="FFFFFF"/>
@@ -2565,6 +2687,7 @@
           <a:lstStyle xmlns:a="http://schemas.openxmlformats.org/drawingml/2006/main"/>
           <a:p xmlns:a="http://schemas.openxmlformats.org/drawingml/2006/main">
             <a:pPr>
+              <a:buNone/>
               <a:defRPr sz="2100">
                 <a:solidFill>
                   <a:srgbClr val="E5F8FF"/>
@@ -2650,6 +2773,7 @@
           <a:lstStyle xmlns:a="http://schemas.openxmlformats.org/drawingml/2006/main"/>
           <a:p xmlns:a="http://schemas.openxmlformats.org/drawingml/2006/main">
             <a:pPr>
+              <a:buNone/>
               <a:defRPr sz="1650" b="1">
                 <a:solidFill>
                   <a:srgbClr val="FFFFFF"/>
@@ -2700,6 +2824,7 @@
           <a:lstStyle xmlns:a="http://schemas.openxmlformats.org/drawingml/2006/main"/>
           <a:p xmlns:a="http://schemas.openxmlformats.org/drawingml/2006/main">
             <a:pPr>
+              <a:buNone/>
               <a:defRPr sz="1200">
                 <a:solidFill>
                   <a:srgbClr val="BDEFFF"/>
@@ -2810,6 +2935,7 @@
           <a:lstStyle xmlns:a="http://schemas.openxmlformats.org/drawingml/2006/main"/>
           <a:p xmlns:a="http://schemas.openxmlformats.org/drawingml/2006/main">
             <a:pPr>
+              <a:buNone/>
               <a:defRPr sz="1125" b="1">
                 <a:solidFill>
                   <a:srgbClr val="086B9C"/>
@@ -2860,6 +2986,7 @@
           <a:lstStyle xmlns:a="http://schemas.openxmlformats.org/drawingml/2006/main"/>
           <a:p xmlns:a="http://schemas.openxmlformats.org/drawingml/2006/main">
             <a:pPr>
+              <a:buNone/>
               <a:defRPr sz="2925" b="1">
                 <a:solidFill>
                   <a:srgbClr val="17212B"/>
@@ -2941,6 +3068,7 @@
           <a:lstStyle xmlns:a="http://schemas.openxmlformats.org/drawingml/2006/main"/>
           <a:p xmlns:a="http://schemas.openxmlformats.org/drawingml/2006/main">
             <a:pPr>
+              <a:buNone/>
               <a:defRPr sz="1725">
                 <a:solidFill>
                   <a:srgbClr val="17212B"/>
@@ -2958,6 +3086,7 @@
           </a:p>
           <a:p xmlns:a="http://schemas.openxmlformats.org/drawingml/2006/main">
             <a:pPr>
+              <a:buNone/>
               <a:defRPr sz="1725">
                 <a:solidFill>
                   <a:srgbClr val="17212B"/>
@@ -2975,6 +3104,7 @@
           </a:p>
           <a:p xmlns:a="http://schemas.openxmlformats.org/drawingml/2006/main">
             <a:pPr>
+              <a:buNone/>
               <a:defRPr sz="1725">
                 <a:solidFill>
                   <a:srgbClr val="17212B"/>
@@ -3091,6 +3221,7 @@
           <a:lstStyle xmlns:a="http://schemas.openxmlformats.org/drawingml/2006/main"/>
           <a:p xmlns:a="http://schemas.openxmlformats.org/drawingml/2006/main">
             <a:pPr>
+              <a:buNone/>
               <a:defRPr sz="1500" b="1">
                 <a:solidFill>
                   <a:srgbClr val="176B3A"/>
@@ -3145,14 +3276,14 @@
       </p:sp>
       <p:pic>
         <p:nvPicPr>
-          <p:cNvPr id="22" name=""/>
+          <p:cNvPr id="24" name=""/>
           <p:cNvPicPr>
             <a:picLocks xmlns:a="http://schemas.openxmlformats.org/drawingml/2006/main" noChangeAspect="1"/>
           </p:cNvPicPr>
           <p:nvPr/>
         </p:nvPicPr>
         <p:blipFill>
-          <a:blip xmlns:r="http://schemas.openxmlformats.org/officeDocument/2006/relationships" xmlns:a="http://schemas.openxmlformats.org/drawingml/2006/main" r:embed="Rb6a23d047d8949fa"/>
+          <a:blip xmlns:r="http://schemas.openxmlformats.org/officeDocument/2006/relationships" xmlns:a="http://schemas.openxmlformats.org/drawingml/2006/main" r:embed="Re91756e5c5f44942"/>
           <a:stretch xmlns:a="http://schemas.openxmlformats.org/drawingml/2006/main"/>
         </p:blipFill>
         <p:spPr>
@@ -3200,6 +3331,7 @@
           <a:lstStyle xmlns:a="http://schemas.openxmlformats.org/drawingml/2006/main"/>
           <a:p xmlns:a="http://schemas.openxmlformats.org/drawingml/2006/main">
             <a:pPr algn="ctr">
+              <a:buNone/>
               <a:defRPr sz="1050" b="1">
                 <a:solidFill>
                   <a:srgbClr val="526273"/>
@@ -3281,6 +3413,7 @@
           <a:lstStyle xmlns:a="http://schemas.openxmlformats.org/drawingml/2006/main"/>
           <a:p xmlns:a="http://schemas.openxmlformats.org/drawingml/2006/main">
             <a:pPr>
+              <a:buNone/>
               <a:defRPr sz="1050">
                 <a:solidFill>
                   <a:srgbClr val="526273"/>
@@ -3331,6 +3464,7 @@
           <a:lstStyle xmlns:a="http://schemas.openxmlformats.org/drawingml/2006/main"/>
           <a:p xmlns:a="http://schemas.openxmlformats.org/drawingml/2006/main">
             <a:pPr algn="r">
+              <a:buNone/>
               <a:defRPr sz="1050">
                 <a:solidFill>
                   <a:srgbClr val="526273"/>
@@ -3410,6 +3544,7 @@
           <a:lstStyle xmlns:a="http://schemas.openxmlformats.org/drawingml/2006/main"/>
           <a:p xmlns:a="http://schemas.openxmlformats.org/drawingml/2006/main">
             <a:pPr>
+              <a:buNone/>
               <a:defRPr sz="1125" b="1">
                 <a:solidFill>
                   <a:srgbClr val="086B9C"/>
@@ -3460,6 +3595,7 @@
           <a:lstStyle xmlns:a="http://schemas.openxmlformats.org/drawingml/2006/main"/>
           <a:p xmlns:a="http://schemas.openxmlformats.org/drawingml/2006/main">
             <a:pPr>
+              <a:buNone/>
               <a:defRPr sz="2925" b="1">
                 <a:solidFill>
                   <a:srgbClr val="17212B"/>
@@ -3541,6 +3677,7 @@
           <a:lstStyle xmlns:a="http://schemas.openxmlformats.org/drawingml/2006/main"/>
           <a:p xmlns:a="http://schemas.openxmlformats.org/drawingml/2006/main">
             <a:pPr>
+              <a:buNone/>
               <a:defRPr sz="1725">
                 <a:solidFill>
                   <a:srgbClr val="17212B"/>
@@ -3558,6 +3695,7 @@
           </a:p>
           <a:p xmlns:a="http://schemas.openxmlformats.org/drawingml/2006/main">
             <a:pPr>
+              <a:buNone/>
               <a:defRPr sz="1725">
                 <a:solidFill>
                   <a:srgbClr val="17212B"/>
@@ -3575,6 +3713,7 @@
           </a:p>
           <a:p xmlns:a="http://schemas.openxmlformats.org/drawingml/2006/main">
             <a:pPr>
+              <a:buNone/>
               <a:defRPr sz="1725">
                 <a:solidFill>
                   <a:srgbClr val="17212B"/>
@@ -3691,6 +3830,7 @@
           <a:lstStyle xmlns:a="http://schemas.openxmlformats.org/drawingml/2006/main"/>
           <a:p xmlns:a="http://schemas.openxmlformats.org/drawingml/2006/main">
             <a:pPr>
+              <a:buNone/>
               <a:defRPr sz="1500" b="1">
                 <a:solidFill>
                   <a:srgbClr val="176B3A"/>
@@ -3745,14 +3885,14 @@
       </p:sp>
       <p:pic>
         <p:nvPicPr>
-          <p:cNvPr id="22" name=""/>
+          <p:cNvPr id="24" name=""/>
           <p:cNvPicPr>
             <a:picLocks xmlns:a="http://schemas.openxmlformats.org/drawingml/2006/main" noChangeAspect="1"/>
           </p:cNvPicPr>
           <p:nvPr/>
         </p:nvPicPr>
         <p:blipFill>
-          <a:blip xmlns:r="http://schemas.openxmlformats.org/officeDocument/2006/relationships" xmlns:a="http://schemas.openxmlformats.org/drawingml/2006/main" r:embed="R09cb10cfad384195"/>
+          <a:blip xmlns:r="http://schemas.openxmlformats.org/officeDocument/2006/relationships" xmlns:a="http://schemas.openxmlformats.org/drawingml/2006/main" r:embed="Reb03f6525feb4ad5"/>
           <a:stretch xmlns:a="http://schemas.openxmlformats.org/drawingml/2006/main"/>
         </p:blipFill>
         <p:spPr>
@@ -3800,6 +3940,7 @@
           <a:lstStyle xmlns:a="http://schemas.openxmlformats.org/drawingml/2006/main"/>
           <a:p xmlns:a="http://schemas.openxmlformats.org/drawingml/2006/main">
             <a:pPr algn="ctr">
+              <a:buNone/>
               <a:defRPr sz="1050" b="1">
                 <a:solidFill>
                   <a:srgbClr val="526273"/>
@@ -3881,6 +4022,7 @@
           <a:lstStyle xmlns:a="http://schemas.openxmlformats.org/drawingml/2006/main"/>
           <a:p xmlns:a="http://schemas.openxmlformats.org/drawingml/2006/main">
             <a:pPr>
+              <a:buNone/>
               <a:defRPr sz="1050">
                 <a:solidFill>
                   <a:srgbClr val="526273"/>
@@ -3931,6 +4073,7 @@
           <a:lstStyle xmlns:a="http://schemas.openxmlformats.org/drawingml/2006/main"/>
           <a:p xmlns:a="http://schemas.openxmlformats.org/drawingml/2006/main">
             <a:pPr algn="r">
+              <a:buNone/>
               <a:defRPr sz="1050">
                 <a:solidFill>
                   <a:srgbClr val="526273"/>
@@ -4010,6 +4153,7 @@
           <a:lstStyle xmlns:a="http://schemas.openxmlformats.org/drawingml/2006/main"/>
           <a:p xmlns:a="http://schemas.openxmlformats.org/drawingml/2006/main">
             <a:pPr>
+              <a:buNone/>
               <a:defRPr sz="1125" b="1">
                 <a:solidFill>
                   <a:srgbClr val="086B9C"/>
@@ -4060,6 +4204,7 @@
           <a:lstStyle xmlns:a="http://schemas.openxmlformats.org/drawingml/2006/main"/>
           <a:p xmlns:a="http://schemas.openxmlformats.org/drawingml/2006/main">
             <a:pPr>
+              <a:buNone/>
               <a:defRPr sz="2925" b="1">
                 <a:solidFill>
                   <a:srgbClr val="17212B"/>
@@ -4141,6 +4286,7 @@
           <a:lstStyle xmlns:a="http://schemas.openxmlformats.org/drawingml/2006/main"/>
           <a:p xmlns:a="http://schemas.openxmlformats.org/drawingml/2006/main">
             <a:pPr>
+              <a:buNone/>
               <a:defRPr sz="1725">
                 <a:solidFill>
                   <a:srgbClr val="17212B"/>
@@ -4158,6 +4304,7 @@
           </a:p>
           <a:p xmlns:a="http://schemas.openxmlformats.org/drawingml/2006/main">
             <a:pPr>
+              <a:buNone/>
               <a:defRPr sz="1725">
                 <a:solidFill>
                   <a:srgbClr val="17212B"/>
@@ -4175,6 +4322,7 @@
           </a:p>
           <a:p xmlns:a="http://schemas.openxmlformats.org/drawingml/2006/main">
             <a:pPr>
+              <a:buNone/>
               <a:defRPr sz="1725">
                 <a:solidFill>
                   <a:srgbClr val="17212B"/>
@@ -4291,6 +4439,7 @@
           <a:lstStyle xmlns:a="http://schemas.openxmlformats.org/drawingml/2006/main"/>
           <a:p xmlns:a="http://schemas.openxmlformats.org/drawingml/2006/main">
             <a:pPr>
+              <a:buNone/>
               <a:defRPr sz="1500" b="1">
                 <a:solidFill>
                   <a:srgbClr val="176B3A"/>
@@ -4345,14 +4494,14 @@
       </p:sp>
       <p:pic>
         <p:nvPicPr>
-          <p:cNvPr id="22" name=""/>
+          <p:cNvPr id="24" name=""/>
           <p:cNvPicPr>
             <a:picLocks xmlns:a="http://schemas.openxmlformats.org/drawingml/2006/main" noChangeAspect="1"/>
           </p:cNvPicPr>
           <p:nvPr/>
         </p:nvPicPr>
         <p:blipFill>
-          <a:blip xmlns:r="http://schemas.openxmlformats.org/officeDocument/2006/relationships" xmlns:a="http://schemas.openxmlformats.org/drawingml/2006/main" r:embed="R763c049e7ceb479a"/>
+          <a:blip xmlns:r="http://schemas.openxmlformats.org/officeDocument/2006/relationships" xmlns:a="http://schemas.openxmlformats.org/drawingml/2006/main" r:embed="Rc7634f51851c4016"/>
           <a:stretch xmlns:a="http://schemas.openxmlformats.org/drawingml/2006/main"/>
         </p:blipFill>
         <p:spPr>
@@ -4400,6 +4549,7 @@
           <a:lstStyle xmlns:a="http://schemas.openxmlformats.org/drawingml/2006/main"/>
           <a:p xmlns:a="http://schemas.openxmlformats.org/drawingml/2006/main">
             <a:pPr algn="ctr">
+              <a:buNone/>
               <a:defRPr sz="1050" b="1">
                 <a:solidFill>
                   <a:srgbClr val="526273"/>
@@ -4481,6 +4631,7 @@
           <a:lstStyle xmlns:a="http://schemas.openxmlformats.org/drawingml/2006/main"/>
           <a:p xmlns:a="http://schemas.openxmlformats.org/drawingml/2006/main">
             <a:pPr>
+              <a:buNone/>
               <a:defRPr sz="1050">
                 <a:solidFill>
                   <a:srgbClr val="526273"/>
@@ -4531,6 +4682,7 @@
           <a:lstStyle xmlns:a="http://schemas.openxmlformats.org/drawingml/2006/main"/>
           <a:p xmlns:a="http://schemas.openxmlformats.org/drawingml/2006/main">
             <a:pPr algn="r">
+              <a:buNone/>
               <a:defRPr sz="1050">
                 <a:solidFill>
                   <a:srgbClr val="526273"/>
@@ -4610,6 +4762,7 @@
           <a:lstStyle xmlns:a="http://schemas.openxmlformats.org/drawingml/2006/main"/>
           <a:p xmlns:a="http://schemas.openxmlformats.org/drawingml/2006/main">
             <a:pPr>
+              <a:buNone/>
               <a:defRPr sz="1125" b="1">
                 <a:solidFill>
                   <a:srgbClr val="086B9C"/>
@@ -4660,6 +4813,7 @@
           <a:lstStyle xmlns:a="http://schemas.openxmlformats.org/drawingml/2006/main"/>
           <a:p xmlns:a="http://schemas.openxmlformats.org/drawingml/2006/main">
             <a:pPr>
+              <a:buNone/>
               <a:defRPr sz="2925" b="1">
                 <a:solidFill>
                   <a:srgbClr val="17212B"/>
@@ -4741,6 +4895,7 @@
           <a:lstStyle xmlns:a="http://schemas.openxmlformats.org/drawingml/2006/main"/>
           <a:p xmlns:a="http://schemas.openxmlformats.org/drawingml/2006/main">
             <a:pPr>
+              <a:buNone/>
               <a:defRPr sz="1725">
                 <a:solidFill>
                   <a:srgbClr val="17212B"/>
@@ -4758,6 +4913,7 @@
           </a:p>
           <a:p xmlns:a="http://schemas.openxmlformats.org/drawingml/2006/main">
             <a:pPr>
+              <a:buNone/>
               <a:defRPr sz="1725">
                 <a:solidFill>
                   <a:srgbClr val="17212B"/>
@@ -4775,6 +4931,7 @@
           </a:p>
           <a:p xmlns:a="http://schemas.openxmlformats.org/drawingml/2006/main">
             <a:pPr>
+              <a:buNone/>
               <a:defRPr sz="1725">
                 <a:solidFill>
                   <a:srgbClr val="17212B"/>
@@ -4891,6 +5048,7 @@
           <a:lstStyle xmlns:a="http://schemas.openxmlformats.org/drawingml/2006/main"/>
           <a:p xmlns:a="http://schemas.openxmlformats.org/drawingml/2006/main">
             <a:pPr>
+              <a:buNone/>
               <a:defRPr sz="1500" b="1">
                 <a:solidFill>
                   <a:srgbClr val="176B3A"/>
@@ -4945,14 +5103,14 @@
       </p:sp>
       <p:pic>
         <p:nvPicPr>
-          <p:cNvPr id="22" name=""/>
+          <p:cNvPr id="24" name=""/>
           <p:cNvPicPr>
             <a:picLocks xmlns:a="http://schemas.openxmlformats.org/drawingml/2006/main" noChangeAspect="1"/>
           </p:cNvPicPr>
           <p:nvPr/>
         </p:nvPicPr>
         <p:blipFill>
-          <a:blip xmlns:r="http://schemas.openxmlformats.org/officeDocument/2006/relationships" xmlns:a="http://schemas.openxmlformats.org/drawingml/2006/main" r:embed="R4af33e8894904abf"/>
+          <a:blip xmlns:r="http://schemas.openxmlformats.org/officeDocument/2006/relationships" xmlns:a="http://schemas.openxmlformats.org/drawingml/2006/main" r:embed="R03ad837264a54bc4"/>
           <a:stretch xmlns:a="http://schemas.openxmlformats.org/drawingml/2006/main"/>
         </p:blipFill>
         <p:spPr>
@@ -5000,6 +5158,7 @@
           <a:lstStyle xmlns:a="http://schemas.openxmlformats.org/drawingml/2006/main"/>
           <a:p xmlns:a="http://schemas.openxmlformats.org/drawingml/2006/main">
             <a:pPr algn="ctr">
+              <a:buNone/>
               <a:defRPr sz="1050" b="1">
                 <a:solidFill>
                   <a:srgbClr val="526273"/>
@@ -5081,6 +5240,7 @@
           <a:lstStyle xmlns:a="http://schemas.openxmlformats.org/drawingml/2006/main"/>
           <a:p xmlns:a="http://schemas.openxmlformats.org/drawingml/2006/main">
             <a:pPr>
+              <a:buNone/>
               <a:defRPr sz="1050">
                 <a:solidFill>
                   <a:srgbClr val="526273"/>
@@ -5131,6 +5291,7 @@
           <a:lstStyle xmlns:a="http://schemas.openxmlformats.org/drawingml/2006/main"/>
           <a:p xmlns:a="http://schemas.openxmlformats.org/drawingml/2006/main">
             <a:pPr algn="r">
+              <a:buNone/>
               <a:defRPr sz="1050">
                 <a:solidFill>
                   <a:srgbClr val="526273"/>
@@ -5210,6 +5371,7 @@
           <a:lstStyle xmlns:a="http://schemas.openxmlformats.org/drawingml/2006/main"/>
           <a:p xmlns:a="http://schemas.openxmlformats.org/drawingml/2006/main">
             <a:pPr>
+              <a:buNone/>
               <a:defRPr sz="1125" b="1">
                 <a:solidFill>
                   <a:srgbClr val="086B9C"/>
@@ -5260,6 +5422,7 @@
           <a:lstStyle xmlns:a="http://schemas.openxmlformats.org/drawingml/2006/main"/>
           <a:p xmlns:a="http://schemas.openxmlformats.org/drawingml/2006/main">
             <a:pPr>
+              <a:buNone/>
               <a:defRPr sz="2925" b="1">
                 <a:solidFill>
                   <a:srgbClr val="17212B"/>
@@ -5341,6 +5504,7 @@
           <a:lstStyle xmlns:a="http://schemas.openxmlformats.org/drawingml/2006/main"/>
           <a:p xmlns:a="http://schemas.openxmlformats.org/drawingml/2006/main">
             <a:pPr>
+              <a:buNone/>
               <a:defRPr sz="1725">
                 <a:solidFill>
                   <a:srgbClr val="17212B"/>
@@ -5358,6 +5522,7 @@
           </a:p>
           <a:p xmlns:a="http://schemas.openxmlformats.org/drawingml/2006/main">
             <a:pPr>
+              <a:buNone/>
               <a:defRPr sz="1725">
                 <a:solidFill>
                   <a:srgbClr val="17212B"/>
@@ -5375,6 +5540,7 @@
           </a:p>
           <a:p xmlns:a="http://schemas.openxmlformats.org/drawingml/2006/main">
             <a:pPr>
+              <a:buNone/>
               <a:defRPr sz="1725">
                 <a:solidFill>
                   <a:srgbClr val="17212B"/>
@@ -5491,6 +5657,7 @@
           <a:lstStyle xmlns:a="http://schemas.openxmlformats.org/drawingml/2006/main"/>
           <a:p xmlns:a="http://schemas.openxmlformats.org/drawingml/2006/main">
             <a:pPr>
+              <a:buNone/>
               <a:defRPr sz="1500" b="1">
                 <a:solidFill>
                   <a:srgbClr val="176B3A"/>
@@ -5545,14 +5712,14 @@
       </p:sp>
       <p:pic>
         <p:nvPicPr>
-          <p:cNvPr id="22" name=""/>
+          <p:cNvPr id="24" name=""/>
           <p:cNvPicPr>
             <a:picLocks xmlns:a="http://schemas.openxmlformats.org/drawingml/2006/main" noChangeAspect="1"/>
           </p:cNvPicPr>
           <p:nvPr/>
         </p:nvPicPr>
         <p:blipFill>
-          <a:blip xmlns:r="http://schemas.openxmlformats.org/officeDocument/2006/relationships" xmlns:a="http://schemas.openxmlformats.org/drawingml/2006/main" r:embed="R3e2174e2610e4f3d"/>
+          <a:blip xmlns:r="http://schemas.openxmlformats.org/officeDocument/2006/relationships" xmlns:a="http://schemas.openxmlformats.org/drawingml/2006/main" r:embed="Rd7de51a221024523"/>
           <a:stretch xmlns:a="http://schemas.openxmlformats.org/drawingml/2006/main"/>
         </p:blipFill>
         <p:spPr>
@@ -5600,6 +5767,7 @@
           <a:lstStyle xmlns:a="http://schemas.openxmlformats.org/drawingml/2006/main"/>
           <a:p xmlns:a="http://schemas.openxmlformats.org/drawingml/2006/main">
             <a:pPr algn="ctr">
+              <a:buNone/>
               <a:defRPr sz="1050" b="1">
                 <a:solidFill>
                   <a:srgbClr val="526273"/>
@@ -5681,6 +5849,7 @@
           <a:lstStyle xmlns:a="http://schemas.openxmlformats.org/drawingml/2006/main"/>
           <a:p xmlns:a="http://schemas.openxmlformats.org/drawingml/2006/main">
             <a:pPr>
+              <a:buNone/>
               <a:defRPr sz="1050">
                 <a:solidFill>
                   <a:srgbClr val="526273"/>
@@ -5731,6 +5900,7 @@
           <a:lstStyle xmlns:a="http://schemas.openxmlformats.org/drawingml/2006/main"/>
           <a:p xmlns:a="http://schemas.openxmlformats.org/drawingml/2006/main">
             <a:pPr algn="r">
+              <a:buNone/>
               <a:defRPr sz="1050">
                 <a:solidFill>
                   <a:srgbClr val="526273"/>
@@ -5810,6 +5980,7 @@
           <a:lstStyle xmlns:a="http://schemas.openxmlformats.org/drawingml/2006/main"/>
           <a:p xmlns:a="http://schemas.openxmlformats.org/drawingml/2006/main">
             <a:pPr>
+              <a:buNone/>
               <a:defRPr sz="1125" b="1">
                 <a:solidFill>
                   <a:srgbClr val="086B9C"/>
@@ -5860,6 +6031,7 @@
           <a:lstStyle xmlns:a="http://schemas.openxmlformats.org/drawingml/2006/main"/>
           <a:p xmlns:a="http://schemas.openxmlformats.org/drawingml/2006/main">
             <a:pPr>
+              <a:buNone/>
               <a:defRPr sz="2925" b="1">
                 <a:solidFill>
                   <a:srgbClr val="17212B"/>
@@ -5941,6 +6113,7 @@
           <a:lstStyle xmlns:a="http://schemas.openxmlformats.org/drawingml/2006/main"/>
           <a:p xmlns:a="http://schemas.openxmlformats.org/drawingml/2006/main">
             <a:pPr>
+              <a:buNone/>
               <a:defRPr sz="1725">
                 <a:solidFill>
                   <a:srgbClr val="17212B"/>
@@ -5958,6 +6131,7 @@
           </a:p>
           <a:p xmlns:a="http://schemas.openxmlformats.org/drawingml/2006/main">
             <a:pPr>
+              <a:buNone/>
               <a:defRPr sz="1725">
                 <a:solidFill>
                   <a:srgbClr val="17212B"/>
@@ -5975,6 +6149,7 @@
           </a:p>
           <a:p xmlns:a="http://schemas.openxmlformats.org/drawingml/2006/main">
             <a:pPr>
+              <a:buNone/>
               <a:defRPr sz="1725">
                 <a:solidFill>
                   <a:srgbClr val="17212B"/>
@@ -6091,6 +6266,7 @@
           <a:lstStyle xmlns:a="http://schemas.openxmlformats.org/drawingml/2006/main"/>
           <a:p xmlns:a="http://schemas.openxmlformats.org/drawingml/2006/main">
             <a:pPr>
+              <a:buNone/>
               <a:defRPr sz="1500" b="1">
                 <a:solidFill>
                   <a:srgbClr val="176B3A"/>
@@ -6145,14 +6321,14 @@
       </p:sp>
       <p:pic>
         <p:nvPicPr>
-          <p:cNvPr id="22" name=""/>
+          <p:cNvPr id="24" name=""/>
           <p:cNvPicPr>
             <a:picLocks xmlns:a="http://schemas.openxmlformats.org/drawingml/2006/main" noChangeAspect="1"/>
           </p:cNvPicPr>
           <p:nvPr/>
         </p:nvPicPr>
         <p:blipFill>
-          <a:blip xmlns:r="http://schemas.openxmlformats.org/officeDocument/2006/relationships" xmlns:a="http://schemas.openxmlformats.org/drawingml/2006/main" r:embed="R766bf5e50de8487a"/>
+          <a:blip xmlns:r="http://schemas.openxmlformats.org/officeDocument/2006/relationships" xmlns:a="http://schemas.openxmlformats.org/drawingml/2006/main" r:embed="R0ed5989493f64a96"/>
           <a:stretch xmlns:a="http://schemas.openxmlformats.org/drawingml/2006/main"/>
         </p:blipFill>
         <p:spPr>
@@ -6200,6 +6376,7 @@
           <a:lstStyle xmlns:a="http://schemas.openxmlformats.org/drawingml/2006/main"/>
           <a:p xmlns:a="http://schemas.openxmlformats.org/drawingml/2006/main">
             <a:pPr algn="ctr">
+              <a:buNone/>
               <a:defRPr sz="1050" b="1">
                 <a:solidFill>
                   <a:srgbClr val="526273"/>
@@ -6281,6 +6458,7 @@
           <a:lstStyle xmlns:a="http://schemas.openxmlformats.org/drawingml/2006/main"/>
           <a:p xmlns:a="http://schemas.openxmlformats.org/drawingml/2006/main">
             <a:pPr>
+              <a:buNone/>
               <a:defRPr sz="1050">
                 <a:solidFill>
                   <a:srgbClr val="526273"/>
@@ -6331,6 +6509,7 @@
           <a:lstStyle xmlns:a="http://schemas.openxmlformats.org/drawingml/2006/main"/>
           <a:p xmlns:a="http://schemas.openxmlformats.org/drawingml/2006/main">
             <a:pPr algn="r">
+              <a:buNone/>
               <a:defRPr sz="1050">
                 <a:solidFill>
                   <a:srgbClr val="526273"/>
@@ -6410,6 +6589,7 @@
           <a:lstStyle xmlns:a="http://schemas.openxmlformats.org/drawingml/2006/main"/>
           <a:p xmlns:a="http://schemas.openxmlformats.org/drawingml/2006/main">
             <a:pPr>
+              <a:buNone/>
               <a:defRPr sz="1125" b="1">
                 <a:solidFill>
                   <a:srgbClr val="086B9C"/>
@@ -6460,6 +6640,7 @@
           <a:lstStyle xmlns:a="http://schemas.openxmlformats.org/drawingml/2006/main"/>
           <a:p xmlns:a="http://schemas.openxmlformats.org/drawingml/2006/main">
             <a:pPr>
+              <a:buNone/>
               <a:defRPr sz="2925" b="1">
                 <a:solidFill>
                   <a:srgbClr val="17212B"/>
@@ -6541,6 +6722,7 @@
           <a:lstStyle xmlns:a="http://schemas.openxmlformats.org/drawingml/2006/main"/>
           <a:p xmlns:a="http://schemas.openxmlformats.org/drawingml/2006/main">
             <a:pPr>
+              <a:buNone/>
               <a:defRPr sz="1725">
                 <a:solidFill>
                   <a:srgbClr val="17212B"/>
@@ -6558,6 +6740,7 @@
           </a:p>
           <a:p xmlns:a="http://schemas.openxmlformats.org/drawingml/2006/main">
             <a:pPr>
+              <a:buNone/>
               <a:defRPr sz="1725">
                 <a:solidFill>
                   <a:srgbClr val="17212B"/>
@@ -6575,6 +6758,7 @@
           </a:p>
           <a:p xmlns:a="http://schemas.openxmlformats.org/drawingml/2006/main">
             <a:pPr>
+              <a:buNone/>
               <a:defRPr sz="1725">
                 <a:solidFill>
                   <a:srgbClr val="17212B"/>
@@ -6691,6 +6875,7 @@
           <a:lstStyle xmlns:a="http://schemas.openxmlformats.org/drawingml/2006/main"/>
           <a:p xmlns:a="http://schemas.openxmlformats.org/drawingml/2006/main">
             <a:pPr>
+              <a:buNone/>
               <a:defRPr sz="1500" b="1">
                 <a:solidFill>
                   <a:srgbClr val="176B3A"/>
@@ -6745,14 +6930,14 @@
       </p:sp>
       <p:pic>
         <p:nvPicPr>
-          <p:cNvPr id="22" name=""/>
+          <p:cNvPr id="24" name=""/>
           <p:cNvPicPr>
             <a:picLocks xmlns:a="http://schemas.openxmlformats.org/drawingml/2006/main" noChangeAspect="1"/>
           </p:cNvPicPr>
           <p:nvPr/>
         </p:nvPicPr>
         <p:blipFill>
-          <a:blip xmlns:r="http://schemas.openxmlformats.org/officeDocument/2006/relationships" xmlns:a="http://schemas.openxmlformats.org/drawingml/2006/main" r:embed="Rd05a30a22b9145a8"/>
+          <a:blip xmlns:r="http://schemas.openxmlformats.org/officeDocument/2006/relationships" xmlns:a="http://schemas.openxmlformats.org/drawingml/2006/main" r:embed="R4534e4a325bc41fc"/>
           <a:stretch xmlns:a="http://schemas.openxmlformats.org/drawingml/2006/main"/>
         </p:blipFill>
         <p:spPr>
@@ -6800,6 +6985,7 @@
           <a:lstStyle xmlns:a="http://schemas.openxmlformats.org/drawingml/2006/main"/>
           <a:p xmlns:a="http://schemas.openxmlformats.org/drawingml/2006/main">
             <a:pPr algn="ctr">
+              <a:buNone/>
               <a:defRPr sz="1050" b="1">
                 <a:solidFill>
                   <a:srgbClr val="526273"/>
@@ -6881,6 +7067,7 @@
           <a:lstStyle xmlns:a="http://schemas.openxmlformats.org/drawingml/2006/main"/>
           <a:p xmlns:a="http://schemas.openxmlformats.org/drawingml/2006/main">
             <a:pPr>
+              <a:buNone/>
               <a:defRPr sz="1050">
                 <a:solidFill>
                   <a:srgbClr val="526273"/>
@@ -6931,6 +7118,7 @@
           <a:lstStyle xmlns:a="http://schemas.openxmlformats.org/drawingml/2006/main"/>
           <a:p xmlns:a="http://schemas.openxmlformats.org/drawingml/2006/main">
             <a:pPr algn="r">
+              <a:buNone/>
               <a:defRPr sz="1050">
                 <a:solidFill>
                   <a:srgbClr val="526273"/>
@@ -7010,6 +7198,7 @@
           <a:lstStyle xmlns:a="http://schemas.openxmlformats.org/drawingml/2006/main"/>
           <a:p xmlns:a="http://schemas.openxmlformats.org/drawingml/2006/main">
             <a:pPr>
+              <a:buNone/>
               <a:defRPr sz="1125" b="1">
                 <a:solidFill>
                   <a:srgbClr val="086B9C"/>
@@ -7060,6 +7249,7 @@
           <a:lstStyle xmlns:a="http://schemas.openxmlformats.org/drawingml/2006/main"/>
           <a:p xmlns:a="http://schemas.openxmlformats.org/drawingml/2006/main">
             <a:pPr>
+              <a:buNone/>
               <a:defRPr sz="2925" b="1">
                 <a:solidFill>
                   <a:srgbClr val="17212B"/>
@@ -7141,6 +7331,7 @@
           <a:lstStyle xmlns:a="http://schemas.openxmlformats.org/drawingml/2006/main"/>
           <a:p xmlns:a="http://schemas.openxmlformats.org/drawingml/2006/main">
             <a:pPr>
+              <a:buNone/>
               <a:defRPr sz="1725">
                 <a:solidFill>
                   <a:srgbClr val="17212B"/>
@@ -7158,6 +7349,7 @@
           </a:p>
           <a:p xmlns:a="http://schemas.openxmlformats.org/drawingml/2006/main">
             <a:pPr>
+              <a:buNone/>
               <a:defRPr sz="1725">
                 <a:solidFill>
                   <a:srgbClr val="17212B"/>
@@ -7175,6 +7367,7 @@
           </a:p>
           <a:p xmlns:a="http://schemas.openxmlformats.org/drawingml/2006/main">
             <a:pPr>
+              <a:buNone/>
               <a:defRPr sz="1725">
                 <a:solidFill>
                   <a:srgbClr val="17212B"/>
@@ -7291,6 +7484,7 @@
           <a:lstStyle xmlns:a="http://schemas.openxmlformats.org/drawingml/2006/main"/>
           <a:p xmlns:a="http://schemas.openxmlformats.org/drawingml/2006/main">
             <a:pPr>
+              <a:buNone/>
               <a:defRPr sz="1500" b="1">
                 <a:solidFill>
                   <a:srgbClr val="176B3A"/>
@@ -7345,14 +7539,14 @@
       </p:sp>
       <p:pic>
         <p:nvPicPr>
-          <p:cNvPr id="22" name=""/>
+          <p:cNvPr id="24" name=""/>
           <p:cNvPicPr>
             <a:picLocks xmlns:a="http://schemas.openxmlformats.org/drawingml/2006/main" noChangeAspect="1"/>
           </p:cNvPicPr>
           <p:nvPr/>
         </p:nvPicPr>
         <p:blipFill>
-          <a:blip xmlns:r="http://schemas.openxmlformats.org/officeDocument/2006/relationships" xmlns:a="http://schemas.openxmlformats.org/drawingml/2006/main" r:embed="Re0226e8aee1049d9"/>
+          <a:blip xmlns:r="http://schemas.openxmlformats.org/officeDocument/2006/relationships" xmlns:a="http://schemas.openxmlformats.org/drawingml/2006/main" r:embed="R88c643d6d03c4a28"/>
           <a:stretch xmlns:a="http://schemas.openxmlformats.org/drawingml/2006/main"/>
         </p:blipFill>
         <p:spPr>
@@ -7400,6 +7594,7 @@
           <a:lstStyle xmlns:a="http://schemas.openxmlformats.org/drawingml/2006/main"/>
           <a:p xmlns:a="http://schemas.openxmlformats.org/drawingml/2006/main">
             <a:pPr algn="ctr">
+              <a:buNone/>
               <a:defRPr sz="1050" b="1">
                 <a:solidFill>
                   <a:srgbClr val="526273"/>
@@ -7481,6 +7676,7 @@
           <a:lstStyle xmlns:a="http://schemas.openxmlformats.org/drawingml/2006/main"/>
           <a:p xmlns:a="http://schemas.openxmlformats.org/drawingml/2006/main">
             <a:pPr>
+              <a:buNone/>
               <a:defRPr sz="1050">
                 <a:solidFill>
                   <a:srgbClr val="526273"/>
@@ -7531,6 +7727,7 @@
           <a:lstStyle xmlns:a="http://schemas.openxmlformats.org/drawingml/2006/main"/>
           <a:p xmlns:a="http://schemas.openxmlformats.org/drawingml/2006/main">
             <a:pPr algn="r">
+              <a:buNone/>
               <a:defRPr sz="1050">
                 <a:solidFill>
                   <a:srgbClr val="526273"/>
@@ -7610,6 +7807,7 @@
           <a:lstStyle xmlns:a="http://schemas.openxmlformats.org/drawingml/2006/main"/>
           <a:p xmlns:a="http://schemas.openxmlformats.org/drawingml/2006/main">
             <a:pPr>
+              <a:buNone/>
               <a:defRPr sz="1125" b="1">
                 <a:solidFill>
                   <a:srgbClr val="086B9C"/>
@@ -7660,6 +7858,7 @@
           <a:lstStyle xmlns:a="http://schemas.openxmlformats.org/drawingml/2006/main"/>
           <a:p xmlns:a="http://schemas.openxmlformats.org/drawingml/2006/main">
             <a:pPr>
+              <a:buNone/>
               <a:defRPr sz="2925" b="1">
                 <a:solidFill>
                   <a:srgbClr val="17212B"/>
@@ -7741,6 +7940,7 @@
           <a:lstStyle xmlns:a="http://schemas.openxmlformats.org/drawingml/2006/main"/>
           <a:p xmlns:a="http://schemas.openxmlformats.org/drawingml/2006/main">
             <a:pPr>
+              <a:buNone/>
               <a:defRPr sz="1725">
                 <a:solidFill>
                   <a:srgbClr val="17212B"/>
@@ -7758,6 +7958,7 @@
           </a:p>
           <a:p xmlns:a="http://schemas.openxmlformats.org/drawingml/2006/main">
             <a:pPr>
+              <a:buNone/>
               <a:defRPr sz="1725">
                 <a:solidFill>
                   <a:srgbClr val="17212B"/>
@@ -7775,6 +7976,7 @@
           </a:p>
           <a:p xmlns:a="http://schemas.openxmlformats.org/drawingml/2006/main">
             <a:pPr>
+              <a:buNone/>
               <a:defRPr sz="1725">
                 <a:solidFill>
                   <a:srgbClr val="17212B"/>
@@ -7891,6 +8093,7 @@
           <a:lstStyle xmlns:a="http://schemas.openxmlformats.org/drawingml/2006/main"/>
           <a:p xmlns:a="http://schemas.openxmlformats.org/drawingml/2006/main">
             <a:pPr>
+              <a:buNone/>
               <a:defRPr sz="1500" b="1">
                 <a:solidFill>
                   <a:srgbClr val="176B3A"/>
@@ -7945,14 +8148,14 @@
       </p:sp>
       <p:pic>
         <p:nvPicPr>
-          <p:cNvPr id="22" name=""/>
+          <p:cNvPr id="24" name=""/>
           <p:cNvPicPr>
             <a:picLocks xmlns:a="http://schemas.openxmlformats.org/drawingml/2006/main" noChangeAspect="1"/>
           </p:cNvPicPr>
           <p:nvPr/>
         </p:nvPicPr>
         <p:blipFill>
-          <a:blip xmlns:r="http://schemas.openxmlformats.org/officeDocument/2006/relationships" xmlns:a="http://schemas.openxmlformats.org/drawingml/2006/main" r:embed="R32c0397d8dd145e8"/>
+          <a:blip xmlns:r="http://schemas.openxmlformats.org/officeDocument/2006/relationships" xmlns:a="http://schemas.openxmlformats.org/drawingml/2006/main" r:embed="R3abc63ad042a48cf"/>
           <a:stretch xmlns:a="http://schemas.openxmlformats.org/drawingml/2006/main"/>
         </p:blipFill>
         <p:spPr>
@@ -8000,6 +8203,7 @@
           <a:lstStyle xmlns:a="http://schemas.openxmlformats.org/drawingml/2006/main"/>
           <a:p xmlns:a="http://schemas.openxmlformats.org/drawingml/2006/main">
             <a:pPr algn="ctr">
+              <a:buNone/>
               <a:defRPr sz="1050" b="1">
                 <a:solidFill>
                   <a:srgbClr val="526273"/>
@@ -8081,6 +8285,7 @@
           <a:lstStyle xmlns:a="http://schemas.openxmlformats.org/drawingml/2006/main"/>
           <a:p xmlns:a="http://schemas.openxmlformats.org/drawingml/2006/main">
             <a:pPr>
+              <a:buNone/>
               <a:defRPr sz="1050">
                 <a:solidFill>
                   <a:srgbClr val="526273"/>
@@ -8131,6 +8336,7 @@
           <a:lstStyle xmlns:a="http://schemas.openxmlformats.org/drawingml/2006/main"/>
           <a:p xmlns:a="http://schemas.openxmlformats.org/drawingml/2006/main">
             <a:pPr algn="r">
+              <a:buNone/>
               <a:defRPr sz="1050">
                 <a:solidFill>
                   <a:srgbClr val="526273"/>
@@ -8210,6 +8416,7 @@
           <a:lstStyle xmlns:a="http://schemas.openxmlformats.org/drawingml/2006/main"/>
           <a:p xmlns:a="http://schemas.openxmlformats.org/drawingml/2006/main">
             <a:pPr>
+              <a:buNone/>
               <a:defRPr sz="1125" b="1">
                 <a:solidFill>
                   <a:srgbClr val="086B9C"/>
@@ -8260,6 +8467,7 @@
           <a:lstStyle xmlns:a="http://schemas.openxmlformats.org/drawingml/2006/main"/>
           <a:p xmlns:a="http://schemas.openxmlformats.org/drawingml/2006/main">
             <a:pPr>
+              <a:buNone/>
               <a:defRPr sz="2925" b="1">
                 <a:solidFill>
                   <a:srgbClr val="17212B"/>
@@ -8341,6 +8549,7 @@
           <a:lstStyle xmlns:a="http://schemas.openxmlformats.org/drawingml/2006/main"/>
           <a:p xmlns:a="http://schemas.openxmlformats.org/drawingml/2006/main">
             <a:pPr>
+              <a:buNone/>
               <a:defRPr sz="1725">
                 <a:solidFill>
                   <a:srgbClr val="17212B"/>
@@ -8358,6 +8567,7 @@
           </a:p>
           <a:p xmlns:a="http://schemas.openxmlformats.org/drawingml/2006/main">
             <a:pPr>
+              <a:buNone/>
               <a:defRPr sz="1725">
                 <a:solidFill>
                   <a:srgbClr val="17212B"/>
@@ -8375,6 +8585,7 @@
           </a:p>
           <a:p xmlns:a="http://schemas.openxmlformats.org/drawingml/2006/main">
             <a:pPr>
+              <a:buNone/>
               <a:defRPr sz="1725">
                 <a:solidFill>
                   <a:srgbClr val="17212B"/>
@@ -8491,6 +8702,7 @@
           <a:lstStyle xmlns:a="http://schemas.openxmlformats.org/drawingml/2006/main"/>
           <a:p xmlns:a="http://schemas.openxmlformats.org/drawingml/2006/main">
             <a:pPr>
+              <a:buNone/>
               <a:defRPr sz="1500" b="1">
                 <a:solidFill>
                   <a:srgbClr val="176B3A"/>
@@ -8545,14 +8757,14 @@
       </p:sp>
       <p:pic>
         <p:nvPicPr>
-          <p:cNvPr id="22" name=""/>
+          <p:cNvPr id="24" name=""/>
           <p:cNvPicPr>
             <a:picLocks xmlns:a="http://schemas.openxmlformats.org/drawingml/2006/main" noChangeAspect="1"/>
           </p:cNvPicPr>
           <p:nvPr/>
         </p:nvPicPr>
         <p:blipFill>
-          <a:blip xmlns:r="http://schemas.openxmlformats.org/officeDocument/2006/relationships" xmlns:a="http://schemas.openxmlformats.org/drawingml/2006/main" r:embed="R4bc31bb3dd264ae2"/>
+          <a:blip xmlns:r="http://schemas.openxmlformats.org/officeDocument/2006/relationships" xmlns:a="http://schemas.openxmlformats.org/drawingml/2006/main" r:embed="Rf6b9606eb8414066"/>
           <a:stretch xmlns:a="http://schemas.openxmlformats.org/drawingml/2006/main"/>
         </p:blipFill>
         <p:spPr>
@@ -8600,6 +8812,7 @@
           <a:lstStyle xmlns:a="http://schemas.openxmlformats.org/drawingml/2006/main"/>
           <a:p xmlns:a="http://schemas.openxmlformats.org/drawingml/2006/main">
             <a:pPr algn="ctr">
+              <a:buNone/>
               <a:defRPr sz="1050" b="1">
                 <a:solidFill>
                   <a:srgbClr val="526273"/>
@@ -8681,6 +8894,7 @@
           <a:lstStyle xmlns:a="http://schemas.openxmlformats.org/drawingml/2006/main"/>
           <a:p xmlns:a="http://schemas.openxmlformats.org/drawingml/2006/main">
             <a:pPr>
+              <a:buNone/>
               <a:defRPr sz="1050">
                 <a:solidFill>
                   <a:srgbClr val="526273"/>
@@ -8731,6 +8945,7 @@
           <a:lstStyle xmlns:a="http://schemas.openxmlformats.org/drawingml/2006/main"/>
           <a:p xmlns:a="http://schemas.openxmlformats.org/drawingml/2006/main">
             <a:pPr algn="r">
+              <a:buNone/>
               <a:defRPr sz="1050">
                 <a:solidFill>
                   <a:srgbClr val="526273"/>
@@ -8810,6 +9025,7 @@
           <a:lstStyle xmlns:a="http://schemas.openxmlformats.org/drawingml/2006/main"/>
           <a:p xmlns:a="http://schemas.openxmlformats.org/drawingml/2006/main">
             <a:pPr>
+              <a:buNone/>
               <a:defRPr sz="1125" b="1">
                 <a:solidFill>
                   <a:srgbClr val="086B9C"/>
@@ -8860,6 +9076,7 @@
           <a:lstStyle xmlns:a="http://schemas.openxmlformats.org/drawingml/2006/main"/>
           <a:p xmlns:a="http://schemas.openxmlformats.org/drawingml/2006/main">
             <a:pPr>
+              <a:buNone/>
               <a:defRPr sz="2925" b="1">
                 <a:solidFill>
                   <a:srgbClr val="17212B"/>
@@ -8941,6 +9158,7 @@
           <a:lstStyle xmlns:a="http://schemas.openxmlformats.org/drawingml/2006/main"/>
           <a:p xmlns:a="http://schemas.openxmlformats.org/drawingml/2006/main">
             <a:pPr>
+              <a:buNone/>
               <a:defRPr sz="1725">
                 <a:solidFill>
                   <a:srgbClr val="17212B"/>
@@ -8958,6 +9176,7 @@
           </a:p>
           <a:p xmlns:a="http://schemas.openxmlformats.org/drawingml/2006/main">
             <a:pPr>
+              <a:buNone/>
               <a:defRPr sz="1725">
                 <a:solidFill>
                   <a:srgbClr val="17212B"/>
@@ -8975,6 +9194,7 @@
           </a:p>
           <a:p xmlns:a="http://schemas.openxmlformats.org/drawingml/2006/main">
             <a:pPr>
+              <a:buNone/>
               <a:defRPr sz="1725">
                 <a:solidFill>
                   <a:srgbClr val="17212B"/>
@@ -9091,6 +9311,7 @@
           <a:lstStyle xmlns:a="http://schemas.openxmlformats.org/drawingml/2006/main"/>
           <a:p xmlns:a="http://schemas.openxmlformats.org/drawingml/2006/main">
             <a:pPr>
+              <a:buNone/>
               <a:defRPr sz="1500" b="1">
                 <a:solidFill>
                   <a:srgbClr val="176B3A"/>
@@ -9145,14 +9366,14 @@
       </p:sp>
       <p:pic>
         <p:nvPicPr>
-          <p:cNvPr id="22" name=""/>
+          <p:cNvPr id="24" name=""/>
           <p:cNvPicPr>
             <a:picLocks xmlns:a="http://schemas.openxmlformats.org/drawingml/2006/main" noChangeAspect="1"/>
           </p:cNvPicPr>
           <p:nvPr/>
         </p:nvPicPr>
         <p:blipFill>
-          <a:blip xmlns:r="http://schemas.openxmlformats.org/officeDocument/2006/relationships" xmlns:a="http://schemas.openxmlformats.org/drawingml/2006/main" r:embed="R8898d8dc3386417b"/>
+          <a:blip xmlns:r="http://schemas.openxmlformats.org/officeDocument/2006/relationships" xmlns:a="http://schemas.openxmlformats.org/drawingml/2006/main" r:embed="R055831e8c7c44c5a"/>
           <a:stretch xmlns:a="http://schemas.openxmlformats.org/drawingml/2006/main"/>
         </p:blipFill>
         <p:spPr>
@@ -9200,6 +9421,7 @@
           <a:lstStyle xmlns:a="http://schemas.openxmlformats.org/drawingml/2006/main"/>
           <a:p xmlns:a="http://schemas.openxmlformats.org/drawingml/2006/main">
             <a:pPr algn="ctr">
+              <a:buNone/>
               <a:defRPr sz="1050" b="1">
                 <a:solidFill>
                   <a:srgbClr val="526273"/>
@@ -9281,6 +9503,7 @@
           <a:lstStyle xmlns:a="http://schemas.openxmlformats.org/drawingml/2006/main"/>
           <a:p xmlns:a="http://schemas.openxmlformats.org/drawingml/2006/main">
             <a:pPr>
+              <a:buNone/>
               <a:defRPr sz="1050">
                 <a:solidFill>
                   <a:srgbClr val="526273"/>
@@ -9331,6 +9554,7 @@
           <a:lstStyle xmlns:a="http://schemas.openxmlformats.org/drawingml/2006/main"/>
           <a:p xmlns:a="http://schemas.openxmlformats.org/drawingml/2006/main">
             <a:pPr algn="r">
+              <a:buNone/>
               <a:defRPr sz="1050">
                 <a:solidFill>
                   <a:srgbClr val="526273"/>

</xml_diff>

<commit_message>
Verduidelijk vooraf afdrukken en verbinding maken
</commit_message>
<xml_diff>
--- a/video-handleiding/Live-Diabetes-Quiz-storyboard.pptx
+++ b/video-handleiding/Live-Diabetes-Quiz-storyboard.pptx
@@ -2,29 +2,29 @@
 <file path=ppt/presentation.xml><?xml version="1.0" encoding="utf-8"?>
 <p:presentation xmlns:p="http://schemas.openxmlformats.org/presentationml/2006/main">
   <p:sldMasterIdLst>
-    <p:sldMasterId xmlns:r="http://schemas.openxmlformats.org/officeDocument/2006/relationships" id="2147483648" r:id="R69929c957f70499f"/>
+    <p:sldMasterId xmlns:r="http://schemas.openxmlformats.org/officeDocument/2006/relationships" id="2147483648" r:id="R89f5e1c621164a9c"/>
   </p:sldMasterIdLst>
   <p:notesMasterIdLst>
-    <p:notesMasterId xmlns:r="http://schemas.openxmlformats.org/officeDocument/2006/relationships" r:id="R71937ce2bd584f60"/>
+    <p:notesMasterId xmlns:r="http://schemas.openxmlformats.org/officeDocument/2006/relationships" r:id="R65ac3fee5d974f49"/>
   </p:notesMasterIdLst>
   <p:sldIdLst>
-    <p:sldId xmlns:r="http://schemas.openxmlformats.org/officeDocument/2006/relationships" id="256" r:id="Rc4d60d2613f842c9"/>
-    <p:sldId xmlns:r="http://schemas.openxmlformats.org/officeDocument/2006/relationships" id="257" r:id="Re9cb06094061456b"/>
-    <p:sldId xmlns:r="http://schemas.openxmlformats.org/officeDocument/2006/relationships" id="258" r:id="Rd2344305dca44b91"/>
-    <p:sldId xmlns:r="http://schemas.openxmlformats.org/officeDocument/2006/relationships" id="259" r:id="Rceca9c07e2db424f"/>
-    <p:sldId xmlns:r="http://schemas.openxmlformats.org/officeDocument/2006/relationships" id="260" r:id="Rf498130d98f14137"/>
-    <p:sldId xmlns:r="http://schemas.openxmlformats.org/officeDocument/2006/relationships" id="261" r:id="Rc0017e757590434b"/>
-    <p:sldId xmlns:r="http://schemas.openxmlformats.org/officeDocument/2006/relationships" id="262" r:id="R001614afcc8f4952"/>
-    <p:sldId xmlns:r="http://schemas.openxmlformats.org/officeDocument/2006/relationships" id="263" r:id="R910d3329307f4bc5"/>
-    <p:sldId xmlns:r="http://schemas.openxmlformats.org/officeDocument/2006/relationships" id="264" r:id="R903a80ebda1e4899"/>
-    <p:sldId xmlns:r="http://schemas.openxmlformats.org/officeDocument/2006/relationships" id="265" r:id="R26528624a0a24637"/>
-    <p:sldId xmlns:r="http://schemas.openxmlformats.org/officeDocument/2006/relationships" id="266" r:id="R3035dcc44dd8404b"/>
-    <p:sldId xmlns:r="http://schemas.openxmlformats.org/officeDocument/2006/relationships" id="267" r:id="Re0b54b7a75ec4e86"/>
-    <p:sldId xmlns:r="http://schemas.openxmlformats.org/officeDocument/2006/relationships" id="268" r:id="R1ab07a98e487400f"/>
-    <p:sldId xmlns:r="http://schemas.openxmlformats.org/officeDocument/2006/relationships" id="269" r:id="Rae309063fa2f4763"/>
-    <p:sldId xmlns:r="http://schemas.openxmlformats.org/officeDocument/2006/relationships" id="270" r:id="R61a844193a7a4f68"/>
-    <p:sldId xmlns:r="http://schemas.openxmlformats.org/officeDocument/2006/relationships" id="271" r:id="R94ac0f91015741c1"/>
-    <p:sldId xmlns:r="http://schemas.openxmlformats.org/officeDocument/2006/relationships" id="272" r:id="R5ba281cb16474622"/>
+    <p:sldId xmlns:r="http://schemas.openxmlformats.org/officeDocument/2006/relationships" id="256" r:id="R95df7eb5fc4d42f4"/>
+    <p:sldId xmlns:r="http://schemas.openxmlformats.org/officeDocument/2006/relationships" id="257" r:id="R846cc80e5c804e45"/>
+    <p:sldId xmlns:r="http://schemas.openxmlformats.org/officeDocument/2006/relationships" id="258" r:id="R6750400bc3dc42fd"/>
+    <p:sldId xmlns:r="http://schemas.openxmlformats.org/officeDocument/2006/relationships" id="259" r:id="Rd6fcfc265ce049d9"/>
+    <p:sldId xmlns:r="http://schemas.openxmlformats.org/officeDocument/2006/relationships" id="260" r:id="Rec7a8bed4e3b469a"/>
+    <p:sldId xmlns:r="http://schemas.openxmlformats.org/officeDocument/2006/relationships" id="261" r:id="R758f6b12180744bd"/>
+    <p:sldId xmlns:r="http://schemas.openxmlformats.org/officeDocument/2006/relationships" id="262" r:id="R42ecba3a760f4dbd"/>
+    <p:sldId xmlns:r="http://schemas.openxmlformats.org/officeDocument/2006/relationships" id="263" r:id="R8ab21760150243a7"/>
+    <p:sldId xmlns:r="http://schemas.openxmlformats.org/officeDocument/2006/relationships" id="264" r:id="Rb7113273f23e4e45"/>
+    <p:sldId xmlns:r="http://schemas.openxmlformats.org/officeDocument/2006/relationships" id="265" r:id="Raf8ba042359b4844"/>
+    <p:sldId xmlns:r="http://schemas.openxmlformats.org/officeDocument/2006/relationships" id="266" r:id="R3fe01386c1224782"/>
+    <p:sldId xmlns:r="http://schemas.openxmlformats.org/officeDocument/2006/relationships" id="267" r:id="R1d217f75b88948f5"/>
+    <p:sldId xmlns:r="http://schemas.openxmlformats.org/officeDocument/2006/relationships" id="268" r:id="R45d01c6235ca45b4"/>
+    <p:sldId xmlns:r="http://schemas.openxmlformats.org/officeDocument/2006/relationships" id="269" r:id="R4a0334ddea2541e1"/>
+    <p:sldId xmlns:r="http://schemas.openxmlformats.org/officeDocument/2006/relationships" id="270" r:id="Rdebb20f05a414e37"/>
+    <p:sldId xmlns:r="http://schemas.openxmlformats.org/officeDocument/2006/relationships" id="271" r:id="R2629c4d359144b1c"/>
+    <p:sldId xmlns:r="http://schemas.openxmlformats.org/officeDocument/2006/relationships" id="272" r:id="R059a0109cc14473b"/>
   </p:sldIdLst>
   <p:sldSz cx="12192000" cy="6858000"/>
   <p:notesSz cx="6858000" cy="9144000"/>
@@ -608,7 +608,7 @@
           </a:p>
           <a:p xmlns:a="http://schemas.openxmlformats.org/drawingml/2006/main">
             <a:r>
-              <a:t>De gemakkelijkste keuze is meestal de eigen mobiele data van de deelnemer. Wie liever de zaalwifi gebruikt, scant eerst de wifi-QR-code met de gewone camera-app of een vertrouwde QR-app en tikt op Verbinden. Er hoeft geen foto gemaakt te worden. Lukt de QR-code niet, open dan Instellingen, kies Wifi, selecteer de naam van het briefje en typ het wachtwoord precies over. Test eventueel kort of een gewone website opent. Pas daarna wordt de quiz geopend.</a:t>
+              <a:t>Kijk eerst wat werkelijk op het briefje staat. Zonder zaalwifi vermeldt stap één uitsluitend dat mobiele data moet worden aangezet. Is vooraf zaalwifi ingevuld, dan kan de deelnemer kiezen: de eigen mobiele data gebruiken of eerst de wifi-QR-code scannen en op Verbinden tikken. Lukt die QR-code niet, open dan Instellingen, kies Wifi, selecteer de vermelde naam en typ het wachtwoord precies over. Test eventueel kort of een gewone website opent. Pas daarna wordt de quiz geopend.</a:t>
             </a:r>
           </a:p>
           <a:p xmlns:a="http://schemas.openxmlformats.org/drawingml/2006/main">
@@ -1463,7 +1463,7 @@
           <a:lstStyle xmlns:a="http://schemas.openxmlformats.org/drawingml/2006/main"/>
           <a:p xmlns:a="http://schemas.openxmlformats.org/drawingml/2006/main">
             <a:r>
-              <a:t>DIA 17 — Opnieuw beginnen en de briefjes bewaren of vervangen</a:t>
+              <a:t>DIA 17 — Dezelfde activiteit of een volledig nieuwe activiteit</a:t>
             </a:r>
           </a:p>
           <a:p xmlns:a="http://schemas.openxmlformats.org/drawingml/2006/main">
@@ -1488,7 +1488,7 @@
           </a:p>
           <a:p xmlns:a="http://schemas.openxmlformats.org/drawingml/2006/main">
             <a:r>
-              <a:t>De quizmaster kan na afloop de groepsanalyse bekijken of Nieuwe sessie voorbereiden kiezen. De gsm’s en het zaalscherm volgen automatisch wanneer dezelfde deelnemers aangesloten blijven. Maakt u later een volledig nieuwe activiteit met een nieuwe code, druk dan ook nieuwe briefjes af. Bewaar voor de organisator altijd enkele blanco A4-vellen, de zaalgegevens en deze handleiding. Oefen vóór de eerste echte zaalquiz eenmaal met vijf vragen en enkele bestuursleden.</a:t>
+              <a:t>De quizmaster kan na afloop de groepsanalyse bekijken of binnen dezelfde activiteit Nieuwe sessie voorbereiden kiezen. De gsm’s en het zaalscherm volgen automatisch wanneer de deelnemers verbonden blijven; daarvoor hoeft u niet opnieuw uit te delen. Voor een volledig nieuwe activiteit op een andere dag maakt u vooraf thuis een nieuwe definitieve sessie en drukt u de bijbehorende briefjes af. Bewaar de zaalgegevens, neem reserves mee en oefen vóór de eerste echte zaalquiz eenmaal met vijf vragen en enkele bestuursleden.</a:t>
             </a:r>
           </a:p>
           <a:p xmlns:a="http://schemas.openxmlformats.org/drawingml/2006/main">
@@ -1713,7 +1713,7 @@
           <a:lstStyle xmlns:a="http://schemas.openxmlformats.org/drawingml/2006/main"/>
           <a:p xmlns:a="http://schemas.openxmlformats.org/drawingml/2006/main">
             <a:r>
-              <a:t>DIA 3 — Controleer de zaal vóór het publiek binnenkomt</a:t>
+              <a:t>DIA 3 — Bereid materiaal en briefjes liefst vooraf thuis voor</a:t>
             </a:r>
           </a:p>
           <a:p xmlns:a="http://schemas.openxmlformats.org/drawingml/2006/main">
@@ -1723,7 +1723,7 @@
           </a:p>
           <a:p xmlns:a="http://schemas.openxmlformats.org/drawingml/2006/main">
             <a:r>
-              <a:t>DUUR: 40 SECONDEN</a:t>
+              <a:t>DUUR: 60 SECONDEN</a:t>
             </a:r>
           </a:p>
           <a:p xmlns:a="http://schemas.openxmlformats.org/drawingml/2006/main">
@@ -1738,7 +1738,7 @@
           </a:p>
           <a:p xmlns:a="http://schemas.openxmlformats.org/drawingml/2006/main">
             <a:r>
-              <a:t>Voorzie een laptop met oplader en internet, een beamer of groot televisiescherm en de juiste kabels. Vraag vooraf de naam en het wachtwoord van de gastenwifi als u die wilt aanbieden. Maak ook één korte testsessie met uw eigen gsm. Controleer of het zaalscherm goed leesbaar is, of antwoorden aankomen en of de printer werkt. Leg voldoende papier en enkele reservebriefjes klaar. Deze proef voorkomt tijdsdruk wanneer de deelnemers binnenkomen.</a:t>
+              <a:t>Vraag ruim vooraf de naam en het wachtwoord van de gastenwifi wanneer u die wilt aanbieden. Is er geen wifi, test dan vóór de activiteit in de zaal of mobiele ontvangst goed werkt, liefst met meer dan één mobiel netwerk. Vermeld zo mogelijk al in de uitnodiging dat deelnemers een gsm met actieve mobiele internetverbinding nodig hebben. Zodra de zaalgegevens en het verwachte aantal deelnemers bekend zijn, maakt u thuis of op kantoor de definitieve quizsessie en drukt u daar de briefjes af. Zo gebruikt u de grotere printer zonder hem mee te nemen. Neem dezelfde laptop, gesneden briefjes en reserves mee. In de zaal controleert u alleen nog internet, projectie en één proef met de eigen gsm.</a:t>
             </a:r>
           </a:p>
           <a:p xmlns:a="http://schemas.openxmlformats.org/drawingml/2006/main">
@@ -1963,7 +1963,7 @@
           <a:lstStyle xmlns:a="http://schemas.openxmlformats.org/drawingml/2006/main"/>
           <a:p xmlns:a="http://schemas.openxmlformats.org/drawingml/2006/main">
             <a:r>
-              <a:t>DIA 5 — De sessiecode bepaalt welke briefjes u nodig hebt</a:t>
+              <a:t>DIA 5 — Maak thuis de definitieve sessie vóór het afdrukken</a:t>
             </a:r>
           </a:p>
           <a:p xmlns:a="http://schemas.openxmlformats.org/drawingml/2006/main">
@@ -1973,7 +1973,7 @@
           </a:p>
           <a:p xmlns:a="http://schemas.openxmlformats.org/drawingml/2006/main">
             <a:r>
-              <a:t>DUUR: 35 SECONDEN</a:t>
+              <a:t>DUUR: 50 SECONDEN</a:t>
             </a:r>
           </a:p>
           <a:p xmlns:a="http://schemas.openxmlformats.org/drawingml/2006/main">
@@ -1988,7 +1988,7 @@
           </a:p>
           <a:p xmlns:a="http://schemas.openxmlformats.org/drawingml/2006/main">
             <a:r>
-              <a:t>Na het maken van de sessie verschijnt de quizcode. Open nu het grote zaalscherm en laat dat venster op de beamer zien. Kies daarna Deelnemersbriefjes afdrukken. Druk de definitieve briefjes pas af nadat deze sessie is gemaakt, want de juiste quizcode wordt automatisch op ieder briefje gezet. Zo komt niemand per ongeluk in een oude sessie terecht. De QR-code op de laptop is alleen een controlevoorbeeld.</a:t>
+              <a:t>Na het maken van de sessie verschijnt de quizcode. Deze stap mag gerust thuis gebeuren, bijvoorbeeld enkele dagen of de avond vooraf. Kies daarna Deelnemersbriefjes afdrukken, want de juiste code wordt automatisch op ieder exemplaar gezet. Gebruik in de zaal dezelfde laptop en dezelfde gewone browser waarmee u de sessie hebt gemaakt. Wis geen browsergegevens en maak daar niet opnieuw een sessie, want dan ontstaat een andere code die niet meer overeenkomt met de reeds afgedrukte briefjes. Open in de zaal gewoon opnieuw het quizmasterscherm en daarna het grote zaalscherm.</a:t>
             </a:r>
           </a:p>
           <a:p xmlns:a="http://schemas.openxmlformats.org/drawingml/2006/main">
@@ -2113,7 +2113,7 @@
           </a:p>
           <a:p xmlns:a="http://schemas.openxmlformats.org/drawingml/2006/main">
             <a:r>
-              <a:t>Op de afdrukpagina ziet u bovenaan de voorbereiding. Wilt u de wifi van de zaal aanbieden, vul dan exact de wifinaam en het wachtwoord in. Het systeem maakt daarvan automatisch een wifi-QR-code. Gebruikt u alleen mobiele data, laat beide velden dan leeg. Controleer in het voorbeeld of de quizcode klopt en of de quizlink en QR-code zichtbaar zijn. Klik daarna op Nu afdrukken. Er verschijnen twee verticale deelnemersbriefjes op één A4.</a:t>
+              <a:t>Op de afdrukpagina ziet u bovenaan de voorbereiding. Wilt u de wifi van de zaal aanbieden, vraag dan vooraf de juiste gegevens op en vul de wifinaam en het wachtwoord exact in. Het systeem maakt automatisch een wifi-QR-code. Is er geen zaalwifi, laat dan beide velden leeg. De wifi-keuze en wifi-QR-code verdwijnen dan volledig van het briefje en stap één vermeldt alleen mobiele data. Zo krijgen deelnemers geen onmogelijke of verwarrende keuze. Controleer daarna het voorbeeld en klik op Nu afdrukken.</a:t>
             </a:r>
           </a:p>
           <a:p xmlns:a="http://schemas.openxmlformats.org/drawingml/2006/main">
@@ -2213,7 +2213,7 @@
           <a:lstStyle xmlns:a="http://schemas.openxmlformats.org/drawingml/2006/main"/>
           <a:p xmlns:a="http://schemas.openxmlformats.org/drawingml/2006/main">
             <a:r>
-              <a:t>DIA 7 — Controleer de afdruk vóór u alle exemplaren maakt</a:t>
+              <a:t>DIA 7 — Gebruik vooraf de geschikte printer voor de hele oplage</a:t>
             </a:r>
           </a:p>
           <a:p xmlns:a="http://schemas.openxmlformats.org/drawingml/2006/main">
@@ -2223,7 +2223,7 @@
           </a:p>
           <a:p xmlns:a="http://schemas.openxmlformats.org/drawingml/2006/main">
             <a:r>
-              <a:t>DUUR: 40 SECONDEN</a:t>
+              <a:t>DUUR: 50 SECONDEN</a:t>
             </a:r>
           </a:p>
           <a:p xmlns:a="http://schemas.openxmlformats.org/drawingml/2006/main">
@@ -2238,7 +2238,7 @@
           </a:p>
           <a:p xmlns:a="http://schemas.openxmlformats.org/drawingml/2006/main">
             <a:r>
-              <a:t>Maak eerst één proefafdruk. Gebruik A4 in staande richting en laat de schaal op honderd procent of standaard staan. Controleer of beide QR-codes volledig scherp zijn en nergens worden afgesneden. Scan beide codes zelf met een gsm en vergelijk de drie cijfers met de quizcode op de laptop. Druk daarna voldoende A4-vellen af, snijd ieder vel in twee en maak enkele reservebriefjes voor onverwachte deelnemers of een beschadigd exemplaar.</a:t>
+              <a:t>Maak thuis of op kantoor eerst één proefafdruk. Gebruik A4 in staande richting en laat de schaal op honderd procent of standaard staan. Controleer of beide QR-codes volledig scherp zijn en nergens worden afgesneden. Scan beide codes zelf met een gsm en vergelijk de drie cijfers met de quizcode op de laptop. Druk daarna met de grotere printer de volledige oplage af. Twee briefjes staan op één A4: voor zestig deelnemers zijn dus dertig vellen nodig, plus enkele reservevellen. Snijd de briefjes vooraf en neem ze in een map of bundel mee naar de zaal.</a:t>
             </a:r>
           </a:p>
           <a:p xmlns:a="http://schemas.openxmlformats.org/drawingml/2006/main">
@@ -2338,7 +2338,7 @@
           <a:lstStyle xmlns:a="http://schemas.openxmlformats.org/drawingml/2006/main"/>
           <a:p xmlns:a="http://schemas.openxmlformats.org/drawingml/2006/main">
             <a:r>
-              <a:t>DIA 8 — Waarom iedere deelnemer een papieren briefje krijgt</a:t>
+              <a:t>DIA 8 — Waarom iedere deelnemer een vooraf gedrukt briefje krijgt</a:t>
             </a:r>
           </a:p>
           <a:p xmlns:a="http://schemas.openxmlformats.org/drawingml/2006/main">
@@ -2348,7 +2348,7 @@
           </a:p>
           <a:p xmlns:a="http://schemas.openxmlformats.org/drawingml/2006/main">
             <a:r>
-              <a:t>DUUR: 40 SECONDEN</a:t>
+              <a:t>DUUR: 50 SECONDEN</a:t>
             </a:r>
           </a:p>
           <a:p xmlns:a="http://schemas.openxmlformats.org/drawingml/2006/main">
@@ -2363,7 +2363,7 @@
           </a:p>
           <a:p xmlns:a="http://schemas.openxmlformats.org/drawingml/2006/main">
             <a:r>
-              <a:t>Het briefje is bewust de vaste toegang tot de quiz. Oudere deelnemers hoeven geen QR-code op een ver zaalscherm te richten en niemand hoeft een lange uitleg te onthouden. Op papier staan de gemakkelijkste route én een reserveweg: eerst internet, daarna de quiz-QR-code, en bij problemen de link met de driecijferige code. Het briefje vermeldt ook dat deelname anoniem is en dat men een hand mag opsteken. Dat geeft rust en maakt persoonlijke hulp mogelijk.</a:t>
+              <a:t>Het vooraf gedrukte briefje is bewust de vaste toegang tot de quiz. Deelnemers hoeven geen QR-code van een ver zaalscherm te scannen en de organisator hoeft tijdens het binnenkomen niet telkens dezelfde technische uitleg te herhalen. Iedereen heeft de stappen letterlijk in handen: eerst internet, daarna de quiz-QR-code, en bij problemen de link met de driecijferige code. Het briefje werkt dus als instructie, toegangsbewijs en reserveoplossing tegelijk. Het vermeldt ook dat deelname anoniem is en dat men hulp mag vragen. Dat geeft vooral onzekere of oudere deelnemers rust.</a:t>
             </a:r>
           </a:p>
           <a:p xmlns:a="http://schemas.openxmlformats.org/drawingml/2006/main">
@@ -2463,7 +2463,7 @@
           <a:lstStyle xmlns:a="http://schemas.openxmlformats.org/drawingml/2006/main"/>
           <a:p xmlns:a="http://schemas.openxmlformats.org/drawingml/2006/main">
             <a:r>
-              <a:t>DIA 9 — Deel de briefjes uit vóór iedereen plaatsneemt</a:t>
+              <a:t>DIA 9 — Plan verbinding maken als een apart onthaalmoment</a:t>
             </a:r>
           </a:p>
           <a:p xmlns:a="http://schemas.openxmlformats.org/drawingml/2006/main">
@@ -2473,7 +2473,7 @@
           </a:p>
           <a:p xmlns:a="http://schemas.openxmlformats.org/drawingml/2006/main">
             <a:r>
-              <a:t>DUUR: 35 SECONDEN</a:t>
+              <a:t>DUUR: 60 SECONDEN</a:t>
             </a:r>
           </a:p>
           <a:p xmlns:a="http://schemas.openxmlformats.org/drawingml/2006/main">
@@ -2488,7 +2488,7 @@
           </a:p>
           <a:p xmlns:a="http://schemas.openxmlformats.org/drawingml/2006/main">
             <a:r>
-              <a:t>Geef bij de ingang één briefje aan iedere deelnemer en vraag om het meteen bij de hand te houden. Zeg kort: zet eerst internet aan, scan daarna de quizcode en laat de geopende pagina staan. Laat één of twee begeleiders in de zaal rondlopen. Zij kunnen helpen zonder namen of antwoorden te vragen. Begin de quiz pas wanneer de teller met verbonden deelnemers overeenkomt met het aantal mensen dat wil meespelen.</a:t>
+              <a:t>Verbinding maken zal waarschijnlijk het meeste oponthoud geven. Plan dit daarom als een afzonderlijk onthaalmoment en voorzie bij een grotere zaal ongeveer vijftien tot twintig minuten vóór de geplande quizstart. Leg de thuis afgedrukte briefjes bij de ingang klaar en geef één vaste instructie: zet eerst internet aan, scan daarna de quizcode en laat de pagina openstaan. Laat minstens één helper bij de ingang uitleg geven en één helper in de zaal rondlopen. Wie U bent verbonden ziet, hoeft niets meer te doen. Begin niet op het aangekondigde uur omdat u haast krijgt, maar pas wanneer de verbindingsteller overeenkomt met het aantal deelnemers dat wil meespelen.</a:t>
             </a:r>
           </a:p>
           <a:p xmlns:a="http://schemas.openxmlformats.org/drawingml/2006/main">
@@ -2586,7 +2586,7 @@
   </p:cSld>
   <p:clrMap bg1="lt1" tx1="dk1" bg2="lt2" tx2="dk2" accent1="accent1" accent2="accent2" accent3="accent3" accent4="accent4" accent5="accent5" accent6="accent6" hlink="hlink" folHlink="folHlink"/>
   <p:sldLayoutIdLst>
-    <p:sldLayoutId xmlns:r="http://schemas.openxmlformats.org/officeDocument/2006/relationships" id="2147483649" r:id="R39250f34171f488c"/>
+    <p:sldLayoutId xmlns:r="http://schemas.openxmlformats.org/officeDocument/2006/relationships" id="2147483649" r:id="R956d59fcdbe4459d"/>
   </p:sldLayoutIdLst>
   <p:txStyles>
     <p:titleStyle>
@@ -3198,14 +3198,14 @@
       </p:sp>
       <p:pic>
         <p:nvPicPr>
-          <p:cNvPr id="12" name=""/>
+          <p:cNvPr id="14" name=""/>
           <p:cNvPicPr>
             <a:picLocks xmlns:a="http://schemas.openxmlformats.org/drawingml/2006/main" noChangeAspect="1"/>
           </p:cNvPicPr>
           <p:nvPr/>
         </p:nvPicPr>
         <p:blipFill>
-          <a:blip xmlns:r="http://schemas.openxmlformats.org/officeDocument/2006/relationships" xmlns:a="http://schemas.openxmlformats.org/drawingml/2006/main" r:embed="R0c2126e122104e83"/>
+          <a:blip xmlns:r="http://schemas.openxmlformats.org/officeDocument/2006/relationships" xmlns:a="http://schemas.openxmlformats.org/drawingml/2006/main" r:embed="R385d770c8fc1496a"/>
           <a:stretch xmlns:a="http://schemas.openxmlformats.org/drawingml/2006/main"/>
         </p:blipFill>
         <p:spPr>
@@ -3251,6 +3251,7 @@
           <a:lstStyle xmlns:a="http://schemas.openxmlformats.org/drawingml/2006/main"/>
           <a:p xmlns:a="http://schemas.openxmlformats.org/drawingml/2006/main">
             <a:pPr>
+              <a:buNone/>
               <a:defRPr sz="1350" b="1">
                 <a:solidFill>
                   <a:srgbClr val="BFE8F2"/>
@@ -3301,6 +3302,7 @@
           <a:lstStyle xmlns:a="http://schemas.openxmlformats.org/drawingml/2006/main"/>
           <a:p xmlns:a="http://schemas.openxmlformats.org/drawingml/2006/main">
             <a:pPr>
+              <a:buNone/>
               <a:defRPr sz="4050" b="1">
                 <a:solidFill>
                   <a:srgbClr val="FFFFFF"/>
@@ -3351,6 +3353,7 @@
           <a:lstStyle xmlns:a="http://schemas.openxmlformats.org/drawingml/2006/main"/>
           <a:p xmlns:a="http://schemas.openxmlformats.org/drawingml/2006/main">
             <a:pPr>
+              <a:buNone/>
               <a:defRPr sz="1950">
                 <a:solidFill>
                   <a:srgbClr val="D9EEF4"/>
@@ -3436,6 +3439,7 @@
           <a:lstStyle xmlns:a="http://schemas.openxmlformats.org/drawingml/2006/main"/>
           <a:p xmlns:a="http://schemas.openxmlformats.org/drawingml/2006/main">
             <a:pPr>
+              <a:buNone/>
               <a:defRPr sz="1575" b="1">
                 <a:solidFill>
                   <a:srgbClr val="FFFFFF"/>
@@ -3486,6 +3490,7 @@
           <a:lstStyle xmlns:a="http://schemas.openxmlformats.org/drawingml/2006/main"/>
           <a:p xmlns:a="http://schemas.openxmlformats.org/drawingml/2006/main">
             <a:pPr>
+              <a:buNone/>
               <a:defRPr sz="1050">
                 <a:solidFill>
                   <a:srgbClr val="BFE8F2"/>
@@ -3565,6 +3570,7 @@
           <a:lstStyle xmlns:a="http://schemas.openxmlformats.org/drawingml/2006/main"/>
           <a:p xmlns:a="http://schemas.openxmlformats.org/drawingml/2006/main">
             <a:pPr>
+              <a:buNone/>
               <a:defRPr sz="1200" b="1">
                 <a:solidFill>
                   <a:srgbClr val="075678"/>
@@ -3615,6 +3621,7 @@
           <a:lstStyle xmlns:a="http://schemas.openxmlformats.org/drawingml/2006/main"/>
           <a:p xmlns:a="http://schemas.openxmlformats.org/drawingml/2006/main">
             <a:pPr>
+              <a:buNone/>
               <a:defRPr sz="2700" b="1">
                 <a:solidFill>
                   <a:srgbClr val="17212D"/>
@@ -3627,7 +3634,7 @@
                   <a:srgbClr val="17212D"/>
                 </a:solidFill>
               </a:rPr>
-              <a:t>Zorg eerst dat de gsm internet heeft</a:t>
+              <a:t>Gebruik alleen de verbinding die op het briefje staat</a:t>
             </a:r>
           </a:p>
         </p:txBody>
@@ -3696,6 +3703,7 @@
           <a:lstStyle xmlns:a="http://schemas.openxmlformats.org/drawingml/2006/main"/>
           <a:p xmlns:a="http://schemas.openxmlformats.org/drawingml/2006/main">
             <a:pPr>
+              <a:buNone/>
               <a:defRPr sz="1575">
                 <a:solidFill>
                   <a:srgbClr val="17212D"/>
@@ -3708,11 +3716,12 @@
                   <a:srgbClr val="17212D"/>
                 </a:solidFill>
               </a:rPr>
-              <a:t>• Mobiele data is meestal het eenvoudigst</a:t>
+              <a:t>• Zonder zaalwifi: mobiele data aanzetten</a:t>
             </a:r>
           </a:p>
           <a:p xmlns:a="http://schemas.openxmlformats.org/drawingml/2006/main">
             <a:pPr>
+              <a:buNone/>
               <a:defRPr sz="1575">
                 <a:solidFill>
                   <a:srgbClr val="17212D"/>
@@ -3725,11 +3734,12 @@
                   <a:srgbClr val="17212D"/>
                 </a:solidFill>
               </a:rPr>
-              <a:t>• Zaalwifi: scan eerst de wifi-QR-code</a:t>
+              <a:t>• Met zaalwifi: mobiele data of wifi-QR-code</a:t>
             </a:r>
           </a:p>
           <a:p xmlns:a="http://schemas.openxmlformats.org/drawingml/2006/main">
             <a:pPr>
+              <a:buNone/>
               <a:defRPr sz="1575">
                 <a:solidFill>
                   <a:srgbClr val="17212D"/>
@@ -3742,7 +3752,7 @@
                   <a:srgbClr val="17212D"/>
                 </a:solidFill>
               </a:rPr>
-              <a:t>• Bij problemen handmatig verbinden via Instellingen</a:t>
+              <a:t>• Daarna kort controleren of internet werkt</a:t>
             </a:r>
           </a:p>
         </p:txBody>
@@ -3846,6 +3856,7 @@
           <a:lstStyle xmlns:a="http://schemas.openxmlformats.org/drawingml/2006/main"/>
           <a:p xmlns:a="http://schemas.openxmlformats.org/drawingml/2006/main">
             <a:pPr>
+              <a:buNone/>
               <a:defRPr sz="1425" b="1">
                 <a:solidFill>
                   <a:srgbClr val="168044"/>
@@ -3858,7 +3869,7 @@
                   <a:srgbClr val="168044"/>
                 </a:solidFill>
               </a:rPr>
-              <a:t>Controleer zo nodig of een gewone website opent.</a:t>
+              <a:t>Niet-beschikbare wifi wordt nooit op het briefje getoond.</a:t>
             </a:r>
           </a:p>
         </p:txBody>
@@ -3900,14 +3911,14 @@
       </p:sp>
       <p:pic>
         <p:nvPicPr>
-          <p:cNvPr id="22" name=""/>
+          <p:cNvPr id="24" name=""/>
           <p:cNvPicPr>
             <a:picLocks xmlns:a="http://schemas.openxmlformats.org/drawingml/2006/main" noChangeAspect="1"/>
           </p:cNvPicPr>
           <p:nvPr/>
         </p:nvPicPr>
         <p:blipFill>
-          <a:blip xmlns:r="http://schemas.openxmlformats.org/officeDocument/2006/relationships" xmlns:a="http://schemas.openxmlformats.org/drawingml/2006/main" r:embed="R3b0275d942df42e2"/>
+          <a:blip xmlns:r="http://schemas.openxmlformats.org/officeDocument/2006/relationships" xmlns:a="http://schemas.openxmlformats.org/drawingml/2006/main" r:embed="R928d912a4dc24b1c"/>
           <a:stretch xmlns:a="http://schemas.openxmlformats.org/drawingml/2006/main"/>
         </p:blipFill>
         <p:spPr>
@@ -3955,6 +3966,7 @@
           <a:lstStyle xmlns:a="http://schemas.openxmlformats.org/drawingml/2006/main"/>
           <a:p xmlns:a="http://schemas.openxmlformats.org/drawingml/2006/main">
             <a:pPr algn="ctr">
+              <a:buNone/>
               <a:defRPr sz="975">
                 <a:solidFill>
                   <a:srgbClr val="5B6B7F"/>
@@ -4036,6 +4048,7 @@
           <a:lstStyle xmlns:a="http://schemas.openxmlformats.org/drawingml/2006/main"/>
           <a:p xmlns:a="http://schemas.openxmlformats.org/drawingml/2006/main">
             <a:pPr>
+              <a:buNone/>
               <a:defRPr sz="975">
                 <a:solidFill>
                   <a:srgbClr val="5B6B7F"/>
@@ -4086,6 +4099,7 @@
           <a:lstStyle xmlns:a="http://schemas.openxmlformats.org/drawingml/2006/main"/>
           <a:p xmlns:a="http://schemas.openxmlformats.org/drawingml/2006/main">
             <a:pPr algn="r">
+              <a:buNone/>
               <a:defRPr sz="975">
                 <a:solidFill>
                   <a:srgbClr val="5B6B7F"/>
@@ -4165,6 +4179,7 @@
           <a:lstStyle xmlns:a="http://schemas.openxmlformats.org/drawingml/2006/main"/>
           <a:p xmlns:a="http://schemas.openxmlformats.org/drawingml/2006/main">
             <a:pPr>
+              <a:buNone/>
               <a:defRPr sz="1200" b="1">
                 <a:solidFill>
                   <a:srgbClr val="075678"/>
@@ -4215,6 +4230,7 @@
           <a:lstStyle xmlns:a="http://schemas.openxmlformats.org/drawingml/2006/main"/>
           <a:p xmlns:a="http://schemas.openxmlformats.org/drawingml/2006/main">
             <a:pPr>
+              <a:buNone/>
               <a:defRPr sz="2700" b="1">
                 <a:solidFill>
                   <a:srgbClr val="17212D"/>
@@ -4296,6 +4312,7 @@
           <a:lstStyle xmlns:a="http://schemas.openxmlformats.org/drawingml/2006/main"/>
           <a:p xmlns:a="http://schemas.openxmlformats.org/drawingml/2006/main">
             <a:pPr>
+              <a:buNone/>
               <a:defRPr sz="1575">
                 <a:solidFill>
                   <a:srgbClr val="17212D"/>
@@ -4313,6 +4330,7 @@
           </a:p>
           <a:p xmlns:a="http://schemas.openxmlformats.org/drawingml/2006/main">
             <a:pPr>
+              <a:buNone/>
               <a:defRPr sz="1575">
                 <a:solidFill>
                   <a:srgbClr val="17212D"/>
@@ -4330,6 +4348,7 @@
           </a:p>
           <a:p xmlns:a="http://schemas.openxmlformats.org/drawingml/2006/main">
             <a:pPr>
+              <a:buNone/>
               <a:defRPr sz="1575">
                 <a:solidFill>
                   <a:srgbClr val="17212D"/>
@@ -4446,6 +4465,7 @@
           <a:lstStyle xmlns:a="http://schemas.openxmlformats.org/drawingml/2006/main"/>
           <a:p xmlns:a="http://schemas.openxmlformats.org/drawingml/2006/main">
             <a:pPr>
+              <a:buNone/>
               <a:defRPr sz="1425" b="1">
                 <a:solidFill>
                   <a:srgbClr val="168044"/>
@@ -4500,14 +4520,14 @@
       </p:sp>
       <p:pic>
         <p:nvPicPr>
-          <p:cNvPr id="22" name=""/>
+          <p:cNvPr id="24" name=""/>
           <p:cNvPicPr>
             <a:picLocks xmlns:a="http://schemas.openxmlformats.org/drawingml/2006/main" noChangeAspect="1"/>
           </p:cNvPicPr>
           <p:nvPr/>
         </p:nvPicPr>
         <p:blipFill>
-          <a:blip xmlns:r="http://schemas.openxmlformats.org/officeDocument/2006/relationships" xmlns:a="http://schemas.openxmlformats.org/drawingml/2006/main" r:embed="Rb5518dc812194a45"/>
+          <a:blip xmlns:r="http://schemas.openxmlformats.org/officeDocument/2006/relationships" xmlns:a="http://schemas.openxmlformats.org/drawingml/2006/main" r:embed="R247a9cb7b5784943"/>
           <a:stretch xmlns:a="http://schemas.openxmlformats.org/drawingml/2006/main"/>
         </p:blipFill>
         <p:spPr>
@@ -4555,6 +4575,7 @@
           <a:lstStyle xmlns:a="http://schemas.openxmlformats.org/drawingml/2006/main"/>
           <a:p xmlns:a="http://schemas.openxmlformats.org/drawingml/2006/main">
             <a:pPr algn="ctr">
+              <a:buNone/>
               <a:defRPr sz="975">
                 <a:solidFill>
                   <a:srgbClr val="5B6B7F"/>
@@ -4636,6 +4657,7 @@
           <a:lstStyle xmlns:a="http://schemas.openxmlformats.org/drawingml/2006/main"/>
           <a:p xmlns:a="http://schemas.openxmlformats.org/drawingml/2006/main">
             <a:pPr>
+              <a:buNone/>
               <a:defRPr sz="975">
                 <a:solidFill>
                   <a:srgbClr val="5B6B7F"/>
@@ -4686,6 +4708,7 @@
           <a:lstStyle xmlns:a="http://schemas.openxmlformats.org/drawingml/2006/main"/>
           <a:p xmlns:a="http://schemas.openxmlformats.org/drawingml/2006/main">
             <a:pPr algn="r">
+              <a:buNone/>
               <a:defRPr sz="975">
                 <a:solidFill>
                   <a:srgbClr val="5B6B7F"/>
@@ -4765,6 +4788,7 @@
           <a:lstStyle xmlns:a="http://schemas.openxmlformats.org/drawingml/2006/main"/>
           <a:p xmlns:a="http://schemas.openxmlformats.org/drawingml/2006/main">
             <a:pPr>
+              <a:buNone/>
               <a:defRPr sz="1200" b="1">
                 <a:solidFill>
                   <a:srgbClr val="075678"/>
@@ -4815,6 +4839,7 @@
           <a:lstStyle xmlns:a="http://schemas.openxmlformats.org/drawingml/2006/main"/>
           <a:p xmlns:a="http://schemas.openxmlformats.org/drawingml/2006/main">
             <a:pPr>
+              <a:buNone/>
               <a:defRPr sz="2700" b="1">
                 <a:solidFill>
                   <a:srgbClr val="17212D"/>
@@ -4896,6 +4921,7 @@
           <a:lstStyle xmlns:a="http://schemas.openxmlformats.org/drawingml/2006/main"/>
           <a:p xmlns:a="http://schemas.openxmlformats.org/drawingml/2006/main">
             <a:pPr>
+              <a:buNone/>
               <a:defRPr sz="1575">
                 <a:solidFill>
                   <a:srgbClr val="17212D"/>
@@ -4913,6 +4939,7 @@
           </a:p>
           <a:p xmlns:a="http://schemas.openxmlformats.org/drawingml/2006/main">
             <a:pPr>
+              <a:buNone/>
               <a:defRPr sz="1575">
                 <a:solidFill>
                   <a:srgbClr val="17212D"/>
@@ -4930,6 +4957,7 @@
           </a:p>
           <a:p xmlns:a="http://schemas.openxmlformats.org/drawingml/2006/main">
             <a:pPr>
+              <a:buNone/>
               <a:defRPr sz="1575">
                 <a:solidFill>
                   <a:srgbClr val="17212D"/>
@@ -5046,6 +5074,7 @@
           <a:lstStyle xmlns:a="http://schemas.openxmlformats.org/drawingml/2006/main"/>
           <a:p xmlns:a="http://schemas.openxmlformats.org/drawingml/2006/main">
             <a:pPr>
+              <a:buNone/>
               <a:defRPr sz="1425" b="1">
                 <a:solidFill>
                   <a:srgbClr val="168044"/>
@@ -5100,14 +5129,14 @@
       </p:sp>
       <p:pic>
         <p:nvPicPr>
-          <p:cNvPr id="22" name=""/>
+          <p:cNvPr id="24" name=""/>
           <p:cNvPicPr>
             <a:picLocks xmlns:a="http://schemas.openxmlformats.org/drawingml/2006/main" noChangeAspect="1"/>
           </p:cNvPicPr>
           <p:nvPr/>
         </p:nvPicPr>
         <p:blipFill>
-          <a:blip xmlns:r="http://schemas.openxmlformats.org/officeDocument/2006/relationships" xmlns:a="http://schemas.openxmlformats.org/drawingml/2006/main" r:embed="R6c0f7d2c242e4e9d"/>
+          <a:blip xmlns:r="http://schemas.openxmlformats.org/officeDocument/2006/relationships" xmlns:a="http://schemas.openxmlformats.org/drawingml/2006/main" r:embed="Rbf04edfd043b4fe5"/>
           <a:stretch xmlns:a="http://schemas.openxmlformats.org/drawingml/2006/main"/>
         </p:blipFill>
         <p:spPr>
@@ -5155,6 +5184,7 @@
           <a:lstStyle xmlns:a="http://schemas.openxmlformats.org/drawingml/2006/main"/>
           <a:p xmlns:a="http://schemas.openxmlformats.org/drawingml/2006/main">
             <a:pPr algn="ctr">
+              <a:buNone/>
               <a:defRPr sz="975">
                 <a:solidFill>
                   <a:srgbClr val="5B6B7F"/>
@@ -5236,6 +5266,7 @@
           <a:lstStyle xmlns:a="http://schemas.openxmlformats.org/drawingml/2006/main"/>
           <a:p xmlns:a="http://schemas.openxmlformats.org/drawingml/2006/main">
             <a:pPr>
+              <a:buNone/>
               <a:defRPr sz="975">
                 <a:solidFill>
                   <a:srgbClr val="5B6B7F"/>
@@ -5286,6 +5317,7 @@
           <a:lstStyle xmlns:a="http://schemas.openxmlformats.org/drawingml/2006/main"/>
           <a:p xmlns:a="http://schemas.openxmlformats.org/drawingml/2006/main">
             <a:pPr algn="r">
+              <a:buNone/>
               <a:defRPr sz="975">
                 <a:solidFill>
                   <a:srgbClr val="5B6B7F"/>
@@ -5365,6 +5397,7 @@
           <a:lstStyle xmlns:a="http://schemas.openxmlformats.org/drawingml/2006/main"/>
           <a:p xmlns:a="http://schemas.openxmlformats.org/drawingml/2006/main">
             <a:pPr>
+              <a:buNone/>
               <a:defRPr sz="1200" b="1">
                 <a:solidFill>
                   <a:srgbClr val="075678"/>
@@ -5415,6 +5448,7 @@
           <a:lstStyle xmlns:a="http://schemas.openxmlformats.org/drawingml/2006/main"/>
           <a:p xmlns:a="http://schemas.openxmlformats.org/drawingml/2006/main">
             <a:pPr>
+              <a:buNone/>
               <a:defRPr sz="2700" b="1">
                 <a:solidFill>
                   <a:srgbClr val="17212D"/>
@@ -5496,6 +5530,7 @@
           <a:lstStyle xmlns:a="http://schemas.openxmlformats.org/drawingml/2006/main"/>
           <a:p xmlns:a="http://schemas.openxmlformats.org/drawingml/2006/main">
             <a:pPr>
+              <a:buNone/>
               <a:defRPr sz="1575">
                 <a:solidFill>
                   <a:srgbClr val="17212D"/>
@@ -5513,6 +5548,7 @@
           </a:p>
           <a:p xmlns:a="http://schemas.openxmlformats.org/drawingml/2006/main">
             <a:pPr>
+              <a:buNone/>
               <a:defRPr sz="1575">
                 <a:solidFill>
                   <a:srgbClr val="17212D"/>
@@ -5530,6 +5566,7 @@
           </a:p>
           <a:p xmlns:a="http://schemas.openxmlformats.org/drawingml/2006/main">
             <a:pPr>
+              <a:buNone/>
               <a:defRPr sz="1575">
                 <a:solidFill>
                   <a:srgbClr val="17212D"/>
@@ -5646,6 +5683,7 @@
           <a:lstStyle xmlns:a="http://schemas.openxmlformats.org/drawingml/2006/main"/>
           <a:p xmlns:a="http://schemas.openxmlformats.org/drawingml/2006/main">
             <a:pPr>
+              <a:buNone/>
               <a:defRPr sz="1425" b="1">
                 <a:solidFill>
                   <a:srgbClr val="168044"/>
@@ -5700,14 +5738,14 @@
       </p:sp>
       <p:pic>
         <p:nvPicPr>
-          <p:cNvPr id="22" name=""/>
+          <p:cNvPr id="24" name=""/>
           <p:cNvPicPr>
             <a:picLocks xmlns:a="http://schemas.openxmlformats.org/drawingml/2006/main" noChangeAspect="1"/>
           </p:cNvPicPr>
           <p:nvPr/>
         </p:nvPicPr>
         <p:blipFill>
-          <a:blip xmlns:r="http://schemas.openxmlformats.org/officeDocument/2006/relationships" xmlns:a="http://schemas.openxmlformats.org/drawingml/2006/main" r:embed="Rb3b437824a28455e"/>
+          <a:blip xmlns:r="http://schemas.openxmlformats.org/officeDocument/2006/relationships" xmlns:a="http://schemas.openxmlformats.org/drawingml/2006/main" r:embed="R6fc368bf259e4cd4"/>
           <a:stretch xmlns:a="http://schemas.openxmlformats.org/drawingml/2006/main"/>
         </p:blipFill>
         <p:spPr>
@@ -5755,6 +5793,7 @@
           <a:lstStyle xmlns:a="http://schemas.openxmlformats.org/drawingml/2006/main"/>
           <a:p xmlns:a="http://schemas.openxmlformats.org/drawingml/2006/main">
             <a:pPr algn="ctr">
+              <a:buNone/>
               <a:defRPr sz="975">
                 <a:solidFill>
                   <a:srgbClr val="5B6B7F"/>
@@ -5836,6 +5875,7 @@
           <a:lstStyle xmlns:a="http://schemas.openxmlformats.org/drawingml/2006/main"/>
           <a:p xmlns:a="http://schemas.openxmlformats.org/drawingml/2006/main">
             <a:pPr>
+              <a:buNone/>
               <a:defRPr sz="975">
                 <a:solidFill>
                   <a:srgbClr val="5B6B7F"/>
@@ -5886,6 +5926,7 @@
           <a:lstStyle xmlns:a="http://schemas.openxmlformats.org/drawingml/2006/main"/>
           <a:p xmlns:a="http://schemas.openxmlformats.org/drawingml/2006/main">
             <a:pPr algn="r">
+              <a:buNone/>
               <a:defRPr sz="975">
                 <a:solidFill>
                   <a:srgbClr val="5B6B7F"/>
@@ -5965,6 +6006,7 @@
           <a:lstStyle xmlns:a="http://schemas.openxmlformats.org/drawingml/2006/main"/>
           <a:p xmlns:a="http://schemas.openxmlformats.org/drawingml/2006/main">
             <a:pPr>
+              <a:buNone/>
               <a:defRPr sz="1200" b="1">
                 <a:solidFill>
                   <a:srgbClr val="075678"/>
@@ -6015,6 +6057,7 @@
           <a:lstStyle xmlns:a="http://schemas.openxmlformats.org/drawingml/2006/main"/>
           <a:p xmlns:a="http://schemas.openxmlformats.org/drawingml/2006/main">
             <a:pPr>
+              <a:buNone/>
               <a:defRPr sz="2700" b="1">
                 <a:solidFill>
                   <a:srgbClr val="17212D"/>
@@ -6096,6 +6139,7 @@
           <a:lstStyle xmlns:a="http://schemas.openxmlformats.org/drawingml/2006/main"/>
           <a:p xmlns:a="http://schemas.openxmlformats.org/drawingml/2006/main">
             <a:pPr>
+              <a:buNone/>
               <a:defRPr sz="1575">
                 <a:solidFill>
                   <a:srgbClr val="17212D"/>
@@ -6113,6 +6157,7 @@
           </a:p>
           <a:p xmlns:a="http://schemas.openxmlformats.org/drawingml/2006/main">
             <a:pPr>
+              <a:buNone/>
               <a:defRPr sz="1575">
                 <a:solidFill>
                   <a:srgbClr val="17212D"/>
@@ -6130,6 +6175,7 @@
           </a:p>
           <a:p xmlns:a="http://schemas.openxmlformats.org/drawingml/2006/main">
             <a:pPr>
+              <a:buNone/>
               <a:defRPr sz="1575">
                 <a:solidFill>
                   <a:srgbClr val="17212D"/>
@@ -6246,6 +6292,7 @@
           <a:lstStyle xmlns:a="http://schemas.openxmlformats.org/drawingml/2006/main"/>
           <a:p xmlns:a="http://schemas.openxmlformats.org/drawingml/2006/main">
             <a:pPr>
+              <a:buNone/>
               <a:defRPr sz="1425" b="1">
                 <a:solidFill>
                   <a:srgbClr val="168044"/>
@@ -6300,14 +6347,14 @@
       </p:sp>
       <p:pic>
         <p:nvPicPr>
-          <p:cNvPr id="22" name=""/>
+          <p:cNvPr id="24" name=""/>
           <p:cNvPicPr>
             <a:picLocks xmlns:a="http://schemas.openxmlformats.org/drawingml/2006/main" noChangeAspect="1"/>
           </p:cNvPicPr>
           <p:nvPr/>
         </p:nvPicPr>
         <p:blipFill>
-          <a:blip xmlns:r="http://schemas.openxmlformats.org/officeDocument/2006/relationships" xmlns:a="http://schemas.openxmlformats.org/drawingml/2006/main" r:embed="R3973bb51fddc44df"/>
+          <a:blip xmlns:r="http://schemas.openxmlformats.org/officeDocument/2006/relationships" xmlns:a="http://schemas.openxmlformats.org/drawingml/2006/main" r:embed="R71f7e1f51a284a40"/>
           <a:stretch xmlns:a="http://schemas.openxmlformats.org/drawingml/2006/main"/>
         </p:blipFill>
         <p:spPr>
@@ -6355,6 +6402,7 @@
           <a:lstStyle xmlns:a="http://schemas.openxmlformats.org/drawingml/2006/main"/>
           <a:p xmlns:a="http://schemas.openxmlformats.org/drawingml/2006/main">
             <a:pPr algn="ctr">
+              <a:buNone/>
               <a:defRPr sz="975">
                 <a:solidFill>
                   <a:srgbClr val="5B6B7F"/>
@@ -6436,6 +6484,7 @@
           <a:lstStyle xmlns:a="http://schemas.openxmlformats.org/drawingml/2006/main"/>
           <a:p xmlns:a="http://schemas.openxmlformats.org/drawingml/2006/main">
             <a:pPr>
+              <a:buNone/>
               <a:defRPr sz="975">
                 <a:solidFill>
                   <a:srgbClr val="5B6B7F"/>
@@ -6486,6 +6535,7 @@
           <a:lstStyle xmlns:a="http://schemas.openxmlformats.org/drawingml/2006/main"/>
           <a:p xmlns:a="http://schemas.openxmlformats.org/drawingml/2006/main">
             <a:pPr algn="r">
+              <a:buNone/>
               <a:defRPr sz="975">
                 <a:solidFill>
                   <a:srgbClr val="5B6B7F"/>
@@ -6565,6 +6615,7 @@
           <a:lstStyle xmlns:a="http://schemas.openxmlformats.org/drawingml/2006/main"/>
           <a:p xmlns:a="http://schemas.openxmlformats.org/drawingml/2006/main">
             <a:pPr>
+              <a:buNone/>
               <a:defRPr sz="1200" b="1">
                 <a:solidFill>
                   <a:srgbClr val="075678"/>
@@ -6615,6 +6666,7 @@
           <a:lstStyle xmlns:a="http://schemas.openxmlformats.org/drawingml/2006/main"/>
           <a:p xmlns:a="http://schemas.openxmlformats.org/drawingml/2006/main">
             <a:pPr>
+              <a:buNone/>
               <a:defRPr sz="2700" b="1">
                 <a:solidFill>
                   <a:srgbClr val="17212D"/>
@@ -6696,6 +6748,7 @@
           <a:lstStyle xmlns:a="http://schemas.openxmlformats.org/drawingml/2006/main"/>
           <a:p xmlns:a="http://schemas.openxmlformats.org/drawingml/2006/main">
             <a:pPr>
+              <a:buNone/>
               <a:defRPr sz="1575">
                 <a:solidFill>
                   <a:srgbClr val="17212D"/>
@@ -6713,6 +6766,7 @@
           </a:p>
           <a:p xmlns:a="http://schemas.openxmlformats.org/drawingml/2006/main">
             <a:pPr>
+              <a:buNone/>
               <a:defRPr sz="1575">
                 <a:solidFill>
                   <a:srgbClr val="17212D"/>
@@ -6730,6 +6784,7 @@
           </a:p>
           <a:p xmlns:a="http://schemas.openxmlformats.org/drawingml/2006/main">
             <a:pPr>
+              <a:buNone/>
               <a:defRPr sz="1575">
                 <a:solidFill>
                   <a:srgbClr val="17212D"/>
@@ -6846,6 +6901,7 @@
           <a:lstStyle xmlns:a="http://schemas.openxmlformats.org/drawingml/2006/main"/>
           <a:p xmlns:a="http://schemas.openxmlformats.org/drawingml/2006/main">
             <a:pPr>
+              <a:buNone/>
               <a:defRPr sz="1425" b="1">
                 <a:solidFill>
                   <a:srgbClr val="168044"/>
@@ -6900,14 +6956,14 @@
       </p:sp>
       <p:pic>
         <p:nvPicPr>
-          <p:cNvPr id="22" name=""/>
+          <p:cNvPr id="24" name=""/>
           <p:cNvPicPr>
             <a:picLocks xmlns:a="http://schemas.openxmlformats.org/drawingml/2006/main" noChangeAspect="1"/>
           </p:cNvPicPr>
           <p:nvPr/>
         </p:nvPicPr>
         <p:blipFill>
-          <a:blip xmlns:r="http://schemas.openxmlformats.org/officeDocument/2006/relationships" xmlns:a="http://schemas.openxmlformats.org/drawingml/2006/main" r:embed="R15e9322fceec4adf"/>
+          <a:blip xmlns:r="http://schemas.openxmlformats.org/officeDocument/2006/relationships" xmlns:a="http://schemas.openxmlformats.org/drawingml/2006/main" r:embed="R35d7980dbbcb4659"/>
           <a:stretch xmlns:a="http://schemas.openxmlformats.org/drawingml/2006/main"/>
         </p:blipFill>
         <p:spPr>
@@ -6955,6 +7011,7 @@
           <a:lstStyle xmlns:a="http://schemas.openxmlformats.org/drawingml/2006/main"/>
           <a:p xmlns:a="http://schemas.openxmlformats.org/drawingml/2006/main">
             <a:pPr algn="ctr">
+              <a:buNone/>
               <a:defRPr sz="975">
                 <a:solidFill>
                   <a:srgbClr val="5B6B7F"/>
@@ -7036,6 +7093,7 @@
           <a:lstStyle xmlns:a="http://schemas.openxmlformats.org/drawingml/2006/main"/>
           <a:p xmlns:a="http://schemas.openxmlformats.org/drawingml/2006/main">
             <a:pPr>
+              <a:buNone/>
               <a:defRPr sz="975">
                 <a:solidFill>
                   <a:srgbClr val="5B6B7F"/>
@@ -7086,6 +7144,7 @@
           <a:lstStyle xmlns:a="http://schemas.openxmlformats.org/drawingml/2006/main"/>
           <a:p xmlns:a="http://schemas.openxmlformats.org/drawingml/2006/main">
             <a:pPr algn="r">
+              <a:buNone/>
               <a:defRPr sz="975">
                 <a:solidFill>
                   <a:srgbClr val="5B6B7F"/>
@@ -7165,6 +7224,7 @@
           <a:lstStyle xmlns:a="http://schemas.openxmlformats.org/drawingml/2006/main"/>
           <a:p xmlns:a="http://schemas.openxmlformats.org/drawingml/2006/main">
             <a:pPr>
+              <a:buNone/>
               <a:defRPr sz="1200" b="1">
                 <a:solidFill>
                   <a:srgbClr val="075678"/>
@@ -7215,6 +7275,7 @@
           <a:lstStyle xmlns:a="http://schemas.openxmlformats.org/drawingml/2006/main"/>
           <a:p xmlns:a="http://schemas.openxmlformats.org/drawingml/2006/main">
             <a:pPr>
+              <a:buNone/>
               <a:defRPr sz="2700" b="1">
                 <a:solidFill>
                   <a:srgbClr val="17212D"/>
@@ -7296,6 +7357,7 @@
           <a:lstStyle xmlns:a="http://schemas.openxmlformats.org/drawingml/2006/main"/>
           <a:p xmlns:a="http://schemas.openxmlformats.org/drawingml/2006/main">
             <a:pPr>
+              <a:buNone/>
               <a:defRPr sz="1575">
                 <a:solidFill>
                   <a:srgbClr val="17212D"/>
@@ -7313,6 +7375,7 @@
           </a:p>
           <a:p xmlns:a="http://schemas.openxmlformats.org/drawingml/2006/main">
             <a:pPr>
+              <a:buNone/>
               <a:defRPr sz="1575">
                 <a:solidFill>
                   <a:srgbClr val="17212D"/>
@@ -7330,6 +7393,7 @@
           </a:p>
           <a:p xmlns:a="http://schemas.openxmlformats.org/drawingml/2006/main">
             <a:pPr>
+              <a:buNone/>
               <a:defRPr sz="1575">
                 <a:solidFill>
                   <a:srgbClr val="17212D"/>
@@ -7446,6 +7510,7 @@
           <a:lstStyle xmlns:a="http://schemas.openxmlformats.org/drawingml/2006/main"/>
           <a:p xmlns:a="http://schemas.openxmlformats.org/drawingml/2006/main">
             <a:pPr>
+              <a:buNone/>
               <a:defRPr sz="1425" b="1">
                 <a:solidFill>
                   <a:srgbClr val="168044"/>
@@ -7500,14 +7565,14 @@
       </p:sp>
       <p:pic>
         <p:nvPicPr>
-          <p:cNvPr id="24" name=""/>
+          <p:cNvPr id="27" name=""/>
           <p:cNvPicPr>
             <a:picLocks xmlns:a="http://schemas.openxmlformats.org/drawingml/2006/main" noChangeAspect="1"/>
           </p:cNvPicPr>
           <p:nvPr/>
         </p:nvPicPr>
         <p:blipFill>
-          <a:blip xmlns:r="http://schemas.openxmlformats.org/officeDocument/2006/relationships" xmlns:a="http://schemas.openxmlformats.org/drawingml/2006/main" r:embed="R8e7e2f315f174d85"/>
+          <a:blip xmlns:r="http://schemas.openxmlformats.org/officeDocument/2006/relationships" xmlns:a="http://schemas.openxmlformats.org/drawingml/2006/main" r:embed="R365c9931bb304516"/>
           <a:stretch xmlns:a="http://schemas.openxmlformats.org/drawingml/2006/main"/>
         </p:blipFill>
         <p:spPr>
@@ -7559,14 +7624,14 @@
       </p:sp>
       <p:pic>
         <p:nvPicPr>
-          <p:cNvPr id="26" name=""/>
+          <p:cNvPr id="29" name=""/>
           <p:cNvPicPr>
             <a:picLocks xmlns:a="http://schemas.openxmlformats.org/drawingml/2006/main" noChangeAspect="1"/>
           </p:cNvPicPr>
           <p:nvPr/>
         </p:nvPicPr>
         <p:blipFill>
-          <a:blip xmlns:r="http://schemas.openxmlformats.org/officeDocument/2006/relationships" xmlns:a="http://schemas.openxmlformats.org/drawingml/2006/main" r:embed="R8ef725a296024c68"/>
+          <a:blip xmlns:r="http://schemas.openxmlformats.org/officeDocument/2006/relationships" xmlns:a="http://schemas.openxmlformats.org/drawingml/2006/main" r:embed="Rbbe5a6234cbb4f9b"/>
           <a:stretch xmlns:a="http://schemas.openxmlformats.org/drawingml/2006/main"/>
         </p:blipFill>
         <p:spPr>
@@ -7614,6 +7679,7 @@
           <a:lstStyle xmlns:a="http://schemas.openxmlformats.org/drawingml/2006/main"/>
           <a:p xmlns:a="http://schemas.openxmlformats.org/drawingml/2006/main">
             <a:pPr algn="ctr">
+              <a:buNone/>
               <a:defRPr sz="975">
                 <a:solidFill>
                   <a:srgbClr val="5B6B7F"/>
@@ -7695,6 +7761,7 @@
           <a:lstStyle xmlns:a="http://schemas.openxmlformats.org/drawingml/2006/main"/>
           <a:p xmlns:a="http://schemas.openxmlformats.org/drawingml/2006/main">
             <a:pPr>
+              <a:buNone/>
               <a:defRPr sz="975">
                 <a:solidFill>
                   <a:srgbClr val="5B6B7F"/>
@@ -7745,6 +7812,7 @@
           <a:lstStyle xmlns:a="http://schemas.openxmlformats.org/drawingml/2006/main"/>
           <a:p xmlns:a="http://schemas.openxmlformats.org/drawingml/2006/main">
             <a:pPr algn="r">
+              <a:buNone/>
               <a:defRPr sz="975">
                 <a:solidFill>
                   <a:srgbClr val="5B6B7F"/>
@@ -7824,6 +7892,7 @@
           <a:lstStyle xmlns:a="http://schemas.openxmlformats.org/drawingml/2006/main"/>
           <a:p xmlns:a="http://schemas.openxmlformats.org/drawingml/2006/main">
             <a:pPr>
+              <a:buNone/>
               <a:defRPr sz="1200" b="1">
                 <a:solidFill>
                   <a:srgbClr val="075678"/>
@@ -7836,7 +7905,7 @@
                   <a:srgbClr val="075678"/>
                 </a:solidFill>
               </a:rPr>
-              <a:t>TOT SLOT</a:t>
+              <a:t>DEZELFDE OF EEN NIEUWE ACTIVITEIT</a:t>
             </a:r>
           </a:p>
         </p:txBody>
@@ -7874,6 +7943,7 @@
           <a:lstStyle xmlns:a="http://schemas.openxmlformats.org/drawingml/2006/main"/>
           <a:p xmlns:a="http://schemas.openxmlformats.org/drawingml/2006/main">
             <a:pPr>
+              <a:buNone/>
               <a:defRPr sz="2700" b="1">
                 <a:solidFill>
                   <a:srgbClr val="17212D"/>
@@ -7886,7 +7956,7 @@
                   <a:srgbClr val="17212D"/>
                 </a:solidFill>
               </a:rPr>
-              <a:t>Opnieuw beginnen en briefjes juist vervangen</a:t>
+              <a:t>Een nieuwe dag vraagt nieuwe voorbereiding</a:t>
             </a:r>
           </a:p>
         </p:txBody>
@@ -7955,6 +8025,7 @@
           <a:lstStyle xmlns:a="http://schemas.openxmlformats.org/drawingml/2006/main"/>
           <a:p xmlns:a="http://schemas.openxmlformats.org/drawingml/2006/main">
             <a:pPr>
+              <a:buNone/>
               <a:defRPr sz="1575">
                 <a:solidFill>
                   <a:srgbClr val="17212D"/>
@@ -7967,11 +8038,12 @@
                   <a:srgbClr val="17212D"/>
                 </a:solidFill>
               </a:rPr>
-              <a:t>• Nieuwe sessie voorbereiden indien gewenst</a:t>
+              <a:t>• Binnen dezelfde activiteit volgen gsm's automatisch</a:t>
             </a:r>
           </a:p>
           <a:p xmlns:a="http://schemas.openxmlformats.org/drawingml/2006/main">
             <a:pPr>
+              <a:buNone/>
               <a:defRPr sz="1575">
                 <a:solidFill>
                   <a:srgbClr val="17212D"/>
@@ -7984,11 +8056,12 @@
                   <a:srgbClr val="17212D"/>
                 </a:solidFill>
               </a:rPr>
-              <a:t>• Bij een nieuwe code ook nieuwe briefjes afdrukken</a:t>
+              <a:t>• Voor een andere dag thuis een nieuwe sessie maken</a:t>
             </a:r>
           </a:p>
           <a:p xmlns:a="http://schemas.openxmlformats.org/drawingml/2006/main">
             <a:pPr>
+              <a:buNone/>
               <a:defRPr sz="1575">
                 <a:solidFill>
                   <a:srgbClr val="17212D"/>
@@ -8001,7 +8074,7 @@
                   <a:srgbClr val="17212D"/>
                 </a:solidFill>
               </a:rPr>
-              <a:t>• Oefen vooraf met 5 vragen en bestuursleden</a:t>
+              <a:t>• Bij de nieuwe code nieuwe briefjes afdrukken</a:t>
             </a:r>
           </a:p>
         </p:txBody>
@@ -8105,6 +8178,7 @@
           <a:lstStyle xmlns:a="http://schemas.openxmlformats.org/drawingml/2006/main"/>
           <a:p xmlns:a="http://schemas.openxmlformats.org/drawingml/2006/main">
             <a:pPr>
+              <a:buNone/>
               <a:defRPr sz="1425" b="1">
                 <a:solidFill>
                   <a:srgbClr val="168044"/>
@@ -8117,7 +8191,7 @@
                   <a:srgbClr val="168044"/>
                 </a:solidFill>
               </a:rPr>
-              <a:t>Met een proef, reserves en de handleiding bent u klaar voor de zaal.</a:t>
+              <a:t>Vooraf voorbereiden houdt de start in de zaal rustig.</a:t>
             </a:r>
           </a:p>
         </p:txBody>
@@ -8159,14 +8233,14 @@
       </p:sp>
       <p:pic>
         <p:nvPicPr>
-          <p:cNvPr id="22" name=""/>
+          <p:cNvPr id="24" name=""/>
           <p:cNvPicPr>
             <a:picLocks xmlns:a="http://schemas.openxmlformats.org/drawingml/2006/main" noChangeAspect="1"/>
           </p:cNvPicPr>
           <p:nvPr/>
         </p:nvPicPr>
         <p:blipFill>
-          <a:blip xmlns:r="http://schemas.openxmlformats.org/officeDocument/2006/relationships" xmlns:a="http://schemas.openxmlformats.org/drawingml/2006/main" r:embed="R371a4407b5ff4ed2"/>
+          <a:blip xmlns:r="http://schemas.openxmlformats.org/officeDocument/2006/relationships" xmlns:a="http://schemas.openxmlformats.org/drawingml/2006/main" r:embed="R1912c379e8b04d94"/>
           <a:stretch xmlns:a="http://schemas.openxmlformats.org/drawingml/2006/main"/>
         </p:blipFill>
         <p:spPr>
@@ -8214,6 +8288,7 @@
           <a:lstStyle xmlns:a="http://schemas.openxmlformats.org/drawingml/2006/main"/>
           <a:p xmlns:a="http://schemas.openxmlformats.org/drawingml/2006/main">
             <a:pPr algn="ctr">
+              <a:buNone/>
               <a:defRPr sz="975">
                 <a:solidFill>
                   <a:srgbClr val="5B6B7F"/>
@@ -8295,6 +8370,7 @@
           <a:lstStyle xmlns:a="http://schemas.openxmlformats.org/drawingml/2006/main"/>
           <a:p xmlns:a="http://schemas.openxmlformats.org/drawingml/2006/main">
             <a:pPr>
+              <a:buNone/>
               <a:defRPr sz="975">
                 <a:solidFill>
                   <a:srgbClr val="5B6B7F"/>
@@ -8345,6 +8421,7 @@
           <a:lstStyle xmlns:a="http://schemas.openxmlformats.org/drawingml/2006/main"/>
           <a:p xmlns:a="http://schemas.openxmlformats.org/drawingml/2006/main">
             <a:pPr algn="r">
+              <a:buNone/>
               <a:defRPr sz="975">
                 <a:solidFill>
                   <a:srgbClr val="5B6B7F"/>
@@ -8424,6 +8501,7 @@
           <a:lstStyle xmlns:a="http://schemas.openxmlformats.org/drawingml/2006/main"/>
           <a:p xmlns:a="http://schemas.openxmlformats.org/drawingml/2006/main">
             <a:pPr>
+              <a:buNone/>
               <a:defRPr sz="1200" b="1">
                 <a:solidFill>
                   <a:srgbClr val="075678"/>
@@ -8474,6 +8552,7 @@
           <a:lstStyle xmlns:a="http://schemas.openxmlformats.org/drawingml/2006/main"/>
           <a:p xmlns:a="http://schemas.openxmlformats.org/drawingml/2006/main">
             <a:pPr>
+              <a:buNone/>
               <a:defRPr sz="2700" b="1">
                 <a:solidFill>
                   <a:srgbClr val="17212D"/>
@@ -8555,6 +8634,7 @@
           <a:lstStyle xmlns:a="http://schemas.openxmlformats.org/drawingml/2006/main"/>
           <a:p xmlns:a="http://schemas.openxmlformats.org/drawingml/2006/main">
             <a:pPr>
+              <a:buNone/>
               <a:defRPr sz="1575">
                 <a:solidFill>
                   <a:srgbClr val="17212D"/>
@@ -8572,6 +8652,7 @@
           </a:p>
           <a:p xmlns:a="http://schemas.openxmlformats.org/drawingml/2006/main">
             <a:pPr>
+              <a:buNone/>
               <a:defRPr sz="1575">
                 <a:solidFill>
                   <a:srgbClr val="17212D"/>
@@ -8589,6 +8670,7 @@
           </a:p>
           <a:p xmlns:a="http://schemas.openxmlformats.org/drawingml/2006/main">
             <a:pPr>
+              <a:buNone/>
               <a:defRPr sz="1575">
                 <a:solidFill>
                   <a:srgbClr val="17212D"/>
@@ -8705,6 +8787,7 @@
           <a:lstStyle xmlns:a="http://schemas.openxmlformats.org/drawingml/2006/main"/>
           <a:p xmlns:a="http://schemas.openxmlformats.org/drawingml/2006/main">
             <a:pPr>
+              <a:buNone/>
               <a:defRPr sz="1425" b="1">
                 <a:solidFill>
                   <a:srgbClr val="168044"/>
@@ -8759,14 +8842,14 @@
       </p:sp>
       <p:pic>
         <p:nvPicPr>
-          <p:cNvPr id="22" name=""/>
+          <p:cNvPr id="24" name=""/>
           <p:cNvPicPr>
             <a:picLocks xmlns:a="http://schemas.openxmlformats.org/drawingml/2006/main" noChangeAspect="1"/>
           </p:cNvPicPr>
           <p:nvPr/>
         </p:nvPicPr>
         <p:blipFill>
-          <a:blip xmlns:r="http://schemas.openxmlformats.org/officeDocument/2006/relationships" xmlns:a="http://schemas.openxmlformats.org/drawingml/2006/main" r:embed="R38dc7643424d44e7"/>
+          <a:blip xmlns:r="http://schemas.openxmlformats.org/officeDocument/2006/relationships" xmlns:a="http://schemas.openxmlformats.org/drawingml/2006/main" r:embed="R0af7e2a8a860442e"/>
           <a:stretch xmlns:a="http://schemas.openxmlformats.org/drawingml/2006/main"/>
         </p:blipFill>
         <p:spPr>
@@ -8814,6 +8897,7 @@
           <a:lstStyle xmlns:a="http://schemas.openxmlformats.org/drawingml/2006/main"/>
           <a:p xmlns:a="http://schemas.openxmlformats.org/drawingml/2006/main">
             <a:pPr algn="ctr">
+              <a:buNone/>
               <a:defRPr sz="975">
                 <a:solidFill>
                   <a:srgbClr val="5B6B7F"/>
@@ -8895,6 +8979,7 @@
           <a:lstStyle xmlns:a="http://schemas.openxmlformats.org/drawingml/2006/main"/>
           <a:p xmlns:a="http://schemas.openxmlformats.org/drawingml/2006/main">
             <a:pPr>
+              <a:buNone/>
               <a:defRPr sz="975">
                 <a:solidFill>
                   <a:srgbClr val="5B6B7F"/>
@@ -8945,6 +9030,7 @@
           <a:lstStyle xmlns:a="http://schemas.openxmlformats.org/drawingml/2006/main"/>
           <a:p xmlns:a="http://schemas.openxmlformats.org/drawingml/2006/main">
             <a:pPr algn="r">
+              <a:buNone/>
               <a:defRPr sz="975">
                 <a:solidFill>
                   <a:srgbClr val="5B6B7F"/>
@@ -9024,6 +9110,7 @@
           <a:lstStyle xmlns:a="http://schemas.openxmlformats.org/drawingml/2006/main"/>
           <a:p xmlns:a="http://schemas.openxmlformats.org/drawingml/2006/main">
             <a:pPr>
+              <a:buNone/>
               <a:defRPr sz="1200" b="1">
                 <a:solidFill>
                   <a:srgbClr val="075678"/>
@@ -9036,7 +9123,7 @@
                   <a:srgbClr val="075678"/>
                 </a:solidFill>
               </a:rPr>
-              <a:t>VOOR DE DEUREN OPENGAAN</a:t>
+              <a:t>RUIM VOOR DE ACTIVITEIT</a:t>
             </a:r>
           </a:p>
         </p:txBody>
@@ -9074,6 +9161,7 @@
           <a:lstStyle xmlns:a="http://schemas.openxmlformats.org/drawingml/2006/main"/>
           <a:p xmlns:a="http://schemas.openxmlformats.org/drawingml/2006/main">
             <a:pPr>
+              <a:buNone/>
               <a:defRPr sz="2700" b="1">
                 <a:solidFill>
                   <a:srgbClr val="17212D"/>
@@ -9086,7 +9174,7 @@
                   <a:srgbClr val="17212D"/>
                 </a:solidFill>
               </a:rPr>
-              <a:t>Controleer de zaal vóór het publiek binnenkomt</a:t>
+              <a:t>Bereid verbinding en briefjes thuis voor</a:t>
             </a:r>
           </a:p>
         </p:txBody>
@@ -9155,6 +9243,7 @@
           <a:lstStyle xmlns:a="http://schemas.openxmlformats.org/drawingml/2006/main"/>
           <a:p xmlns:a="http://schemas.openxmlformats.org/drawingml/2006/main">
             <a:pPr>
+              <a:buNone/>
               <a:defRPr sz="1575">
                 <a:solidFill>
                   <a:srgbClr val="17212D"/>
@@ -9167,11 +9256,12 @@
                   <a:srgbClr val="17212D"/>
                 </a:solidFill>
               </a:rPr>
-              <a:t>• Laptop, internet, oplader en projectie</a:t>
+              <a:t>• Zaalwifi opvragen óf mobiele ontvangst testen</a:t>
             </a:r>
           </a:p>
           <a:p xmlns:a="http://schemas.openxmlformats.org/drawingml/2006/main">
             <a:pPr>
+              <a:buNone/>
               <a:defRPr sz="1575">
                 <a:solidFill>
                   <a:srgbClr val="17212D"/>
@@ -9184,11 +9274,12 @@
                   <a:srgbClr val="17212D"/>
                 </a:solidFill>
               </a:rPr>
-              <a:t>• Wifi-gegevens en printer controleren</a:t>
+              <a:t>• Internetvereiste vooraf aan deelnemers melden</a:t>
             </a:r>
           </a:p>
           <a:p xmlns:a="http://schemas.openxmlformats.org/drawingml/2006/main">
             <a:pPr>
+              <a:buNone/>
               <a:defRPr sz="1575">
                 <a:solidFill>
                   <a:srgbClr val="17212D"/>
@@ -9201,7 +9292,7 @@
                   <a:srgbClr val="17212D"/>
                 </a:solidFill>
               </a:rPr>
-              <a:t>• Eén volledige proef met de eigen gsm</a:t>
+              <a:t>• Definitieve sessie thuis maken en afdrukken</a:t>
             </a:r>
           </a:p>
         </p:txBody>
@@ -9305,6 +9396,7 @@
           <a:lstStyle xmlns:a="http://schemas.openxmlformats.org/drawingml/2006/main"/>
           <a:p xmlns:a="http://schemas.openxmlformats.org/drawingml/2006/main">
             <a:pPr>
+              <a:buNone/>
               <a:defRPr sz="1425" b="1">
                 <a:solidFill>
                   <a:srgbClr val="168044"/>
@@ -9317,7 +9409,7 @@
                   <a:srgbClr val="168044"/>
                 </a:solidFill>
               </a:rPr>
-              <a:t>Een korte proef voorkomt tijdsdruk bij het binnenkomen.</a:t>
+              <a:t>Neem dezelfde laptop, briefjes en reserves mee.</a:t>
             </a:r>
           </a:p>
         </p:txBody>
@@ -9359,14 +9451,14 @@
       </p:sp>
       <p:pic>
         <p:nvPicPr>
-          <p:cNvPr id="22" name=""/>
+          <p:cNvPr id="24" name=""/>
           <p:cNvPicPr>
             <a:picLocks xmlns:a="http://schemas.openxmlformats.org/drawingml/2006/main" noChangeAspect="1"/>
           </p:cNvPicPr>
           <p:nvPr/>
         </p:nvPicPr>
         <p:blipFill>
-          <a:blip xmlns:r="http://schemas.openxmlformats.org/officeDocument/2006/relationships" xmlns:a="http://schemas.openxmlformats.org/drawingml/2006/main" r:embed="R5dd568887e484cc7"/>
+          <a:blip xmlns:r="http://schemas.openxmlformats.org/officeDocument/2006/relationships" xmlns:a="http://schemas.openxmlformats.org/drawingml/2006/main" r:embed="R8669fe744f8b46a0"/>
           <a:stretch xmlns:a="http://schemas.openxmlformats.org/drawingml/2006/main"/>
         </p:blipFill>
         <p:spPr>
@@ -9414,6 +9506,7 @@
           <a:lstStyle xmlns:a="http://schemas.openxmlformats.org/drawingml/2006/main"/>
           <a:p xmlns:a="http://schemas.openxmlformats.org/drawingml/2006/main">
             <a:pPr algn="ctr">
+              <a:buNone/>
               <a:defRPr sz="975">
                 <a:solidFill>
                   <a:srgbClr val="5B6B7F"/>
@@ -9495,6 +9588,7 @@
           <a:lstStyle xmlns:a="http://schemas.openxmlformats.org/drawingml/2006/main"/>
           <a:p xmlns:a="http://schemas.openxmlformats.org/drawingml/2006/main">
             <a:pPr>
+              <a:buNone/>
               <a:defRPr sz="975">
                 <a:solidFill>
                   <a:srgbClr val="5B6B7F"/>
@@ -9545,6 +9639,7 @@
           <a:lstStyle xmlns:a="http://schemas.openxmlformats.org/drawingml/2006/main"/>
           <a:p xmlns:a="http://schemas.openxmlformats.org/drawingml/2006/main">
             <a:pPr algn="r">
+              <a:buNone/>
               <a:defRPr sz="975">
                 <a:solidFill>
                   <a:srgbClr val="5B6B7F"/>
@@ -9624,6 +9719,7 @@
           <a:lstStyle xmlns:a="http://schemas.openxmlformats.org/drawingml/2006/main"/>
           <a:p xmlns:a="http://schemas.openxmlformats.org/drawingml/2006/main">
             <a:pPr>
+              <a:buNone/>
               <a:defRPr sz="1200" b="1">
                 <a:solidFill>
                   <a:srgbClr val="075678"/>
@@ -9674,6 +9770,7 @@
           <a:lstStyle xmlns:a="http://schemas.openxmlformats.org/drawingml/2006/main"/>
           <a:p xmlns:a="http://schemas.openxmlformats.org/drawingml/2006/main">
             <a:pPr>
+              <a:buNone/>
               <a:defRPr sz="2700" b="1">
                 <a:solidFill>
                   <a:srgbClr val="17212D"/>
@@ -9755,6 +9852,7 @@
           <a:lstStyle xmlns:a="http://schemas.openxmlformats.org/drawingml/2006/main"/>
           <a:p xmlns:a="http://schemas.openxmlformats.org/drawingml/2006/main">
             <a:pPr>
+              <a:buNone/>
               <a:defRPr sz="1575">
                 <a:solidFill>
                   <a:srgbClr val="17212D"/>
@@ -9772,6 +9870,7 @@
           </a:p>
           <a:p xmlns:a="http://schemas.openxmlformats.org/drawingml/2006/main">
             <a:pPr>
+              <a:buNone/>
               <a:defRPr sz="1575">
                 <a:solidFill>
                   <a:srgbClr val="17212D"/>
@@ -9789,6 +9888,7 @@
           </a:p>
           <a:p xmlns:a="http://schemas.openxmlformats.org/drawingml/2006/main">
             <a:pPr>
+              <a:buNone/>
               <a:defRPr sz="1575">
                 <a:solidFill>
                   <a:srgbClr val="17212D"/>
@@ -9905,6 +10005,7 @@
           <a:lstStyle xmlns:a="http://schemas.openxmlformats.org/drawingml/2006/main"/>
           <a:p xmlns:a="http://schemas.openxmlformats.org/drawingml/2006/main">
             <a:pPr>
+              <a:buNone/>
               <a:defRPr sz="1425" b="1">
                 <a:solidFill>
                   <a:srgbClr val="168044"/>
@@ -9959,14 +10060,14 @@
       </p:sp>
       <p:pic>
         <p:nvPicPr>
-          <p:cNvPr id="22" name=""/>
+          <p:cNvPr id="24" name=""/>
           <p:cNvPicPr>
             <a:picLocks xmlns:a="http://schemas.openxmlformats.org/drawingml/2006/main" noChangeAspect="1"/>
           </p:cNvPicPr>
           <p:nvPr/>
         </p:nvPicPr>
         <p:blipFill>
-          <a:blip xmlns:r="http://schemas.openxmlformats.org/officeDocument/2006/relationships" xmlns:a="http://schemas.openxmlformats.org/drawingml/2006/main" r:embed="R205baa6ffdde4c9c"/>
+          <a:blip xmlns:r="http://schemas.openxmlformats.org/officeDocument/2006/relationships" xmlns:a="http://schemas.openxmlformats.org/drawingml/2006/main" r:embed="R02f765dbaf0244c1"/>
           <a:stretch xmlns:a="http://schemas.openxmlformats.org/drawingml/2006/main"/>
         </p:blipFill>
         <p:spPr>
@@ -10014,6 +10115,7 @@
           <a:lstStyle xmlns:a="http://schemas.openxmlformats.org/drawingml/2006/main"/>
           <a:p xmlns:a="http://schemas.openxmlformats.org/drawingml/2006/main">
             <a:pPr algn="ctr">
+              <a:buNone/>
               <a:defRPr sz="975">
                 <a:solidFill>
                   <a:srgbClr val="5B6B7F"/>
@@ -10095,6 +10197,7 @@
           <a:lstStyle xmlns:a="http://schemas.openxmlformats.org/drawingml/2006/main"/>
           <a:p xmlns:a="http://schemas.openxmlformats.org/drawingml/2006/main">
             <a:pPr>
+              <a:buNone/>
               <a:defRPr sz="975">
                 <a:solidFill>
                   <a:srgbClr val="5B6B7F"/>
@@ -10145,6 +10248,7 @@
           <a:lstStyle xmlns:a="http://schemas.openxmlformats.org/drawingml/2006/main"/>
           <a:p xmlns:a="http://schemas.openxmlformats.org/drawingml/2006/main">
             <a:pPr algn="r">
+              <a:buNone/>
               <a:defRPr sz="975">
                 <a:solidFill>
                   <a:srgbClr val="5B6B7F"/>
@@ -10224,6 +10328,7 @@
           <a:lstStyle xmlns:a="http://schemas.openxmlformats.org/drawingml/2006/main"/>
           <a:p xmlns:a="http://schemas.openxmlformats.org/drawingml/2006/main">
             <a:pPr>
+              <a:buNone/>
               <a:defRPr sz="1200" b="1">
                 <a:solidFill>
                   <a:srgbClr val="075678"/>
@@ -10236,7 +10341,7 @@
                   <a:srgbClr val="075678"/>
                 </a:solidFill>
               </a:rPr>
-              <a:t>STAP 2 · ZAAL KLAARZETTEN</a:t>
+              <a:t>DEFINITIEVE SESSIE EN CODE</a:t>
             </a:r>
           </a:p>
         </p:txBody>
@@ -10274,6 +10379,7 @@
           <a:lstStyle xmlns:a="http://schemas.openxmlformats.org/drawingml/2006/main"/>
           <a:p xmlns:a="http://schemas.openxmlformats.org/drawingml/2006/main">
             <a:pPr>
+              <a:buNone/>
               <a:defRPr sz="2700" b="1">
                 <a:solidFill>
                   <a:srgbClr val="17212D"/>
@@ -10286,7 +10392,7 @@
                   <a:srgbClr val="17212D"/>
                 </a:solidFill>
               </a:rPr>
-              <a:t>De sessiecode bepaalt de juiste briefjes</a:t>
+              <a:t>Maak thuis de sessie vóór u de briefjes afdrukt</a:t>
             </a:r>
           </a:p>
         </p:txBody>
@@ -10355,6 +10461,7 @@
           <a:lstStyle xmlns:a="http://schemas.openxmlformats.org/drawingml/2006/main"/>
           <a:p xmlns:a="http://schemas.openxmlformats.org/drawingml/2006/main">
             <a:pPr>
+              <a:buNone/>
               <a:defRPr sz="1575">
                 <a:solidFill>
                   <a:srgbClr val="17212D"/>
@@ -10367,11 +10474,12 @@
                   <a:srgbClr val="17212D"/>
                 </a:solidFill>
               </a:rPr>
-              <a:t>• Open eerst het grote zaalscherm</a:t>
+              <a:t>• Sessie en code mogen dagen vooraf worden gemaakt</a:t>
             </a:r>
           </a:p>
           <a:p xmlns:a="http://schemas.openxmlformats.org/drawingml/2006/main">
             <a:pPr>
+              <a:buNone/>
               <a:defRPr sz="1575">
                 <a:solidFill>
                   <a:srgbClr val="17212D"/>
@@ -10384,11 +10492,12 @@
                   <a:srgbClr val="17212D"/>
                 </a:solidFill>
               </a:rPr>
-              <a:t>• Kies daarna Deelnemersbriefjes afdrukken</a:t>
+              <a:t>• Gebruik in de zaal dezelfde laptop en browser</a:t>
             </a:r>
           </a:p>
           <a:p xmlns:a="http://schemas.openxmlformats.org/drawingml/2006/main">
             <a:pPr>
+              <a:buNone/>
               <a:defRPr sz="1575">
                 <a:solidFill>
                   <a:srgbClr val="17212D"/>
@@ -10401,7 +10510,7 @@
                   <a:srgbClr val="17212D"/>
                 </a:solidFill>
               </a:rPr>
-              <a:t>• Druk af met de code van deze sessie</a:t>
+              <a:t>• Maak na het afdrukken geen nieuwe sessie</a:t>
             </a:r>
           </a:p>
         </p:txBody>
@@ -10505,6 +10614,7 @@
           <a:lstStyle xmlns:a="http://schemas.openxmlformats.org/drawingml/2006/main"/>
           <a:p xmlns:a="http://schemas.openxmlformats.org/drawingml/2006/main">
             <a:pPr>
+              <a:buNone/>
               <a:defRPr sz="1425" b="1">
                 <a:solidFill>
                   <a:srgbClr val="168044"/>
@@ -10517,7 +10627,7 @@
                   <a:srgbClr val="168044"/>
                 </a:solidFill>
               </a:rPr>
-              <a:t>Een nieuwe sessiecode betekent ook nieuwe deelnemersbriefjes.</a:t>
+              <a:t>De code op papier moet dezelfde code blijven.</a:t>
             </a:r>
           </a:p>
         </p:txBody>
@@ -10559,14 +10669,14 @@
       </p:sp>
       <p:pic>
         <p:nvPicPr>
-          <p:cNvPr id="22" name=""/>
+          <p:cNvPr id="24" name=""/>
           <p:cNvPicPr>
             <a:picLocks xmlns:a="http://schemas.openxmlformats.org/drawingml/2006/main" noChangeAspect="1"/>
           </p:cNvPicPr>
           <p:nvPr/>
         </p:nvPicPr>
         <p:blipFill>
-          <a:blip xmlns:r="http://schemas.openxmlformats.org/officeDocument/2006/relationships" xmlns:a="http://schemas.openxmlformats.org/drawingml/2006/main" r:embed="Rd62c190b32804d72"/>
+          <a:blip xmlns:r="http://schemas.openxmlformats.org/officeDocument/2006/relationships" xmlns:a="http://schemas.openxmlformats.org/drawingml/2006/main" r:embed="R7f4a25d4e6ad4266"/>
           <a:stretch xmlns:a="http://schemas.openxmlformats.org/drawingml/2006/main"/>
         </p:blipFill>
         <p:spPr>
@@ -10614,6 +10724,7 @@
           <a:lstStyle xmlns:a="http://schemas.openxmlformats.org/drawingml/2006/main"/>
           <a:p xmlns:a="http://schemas.openxmlformats.org/drawingml/2006/main">
             <a:pPr algn="ctr">
+              <a:buNone/>
               <a:defRPr sz="975">
                 <a:solidFill>
                   <a:srgbClr val="5B6B7F"/>
@@ -10695,6 +10806,7 @@
           <a:lstStyle xmlns:a="http://schemas.openxmlformats.org/drawingml/2006/main"/>
           <a:p xmlns:a="http://schemas.openxmlformats.org/drawingml/2006/main">
             <a:pPr>
+              <a:buNone/>
               <a:defRPr sz="975">
                 <a:solidFill>
                   <a:srgbClr val="5B6B7F"/>
@@ -10745,6 +10857,7 @@
           <a:lstStyle xmlns:a="http://schemas.openxmlformats.org/drawingml/2006/main"/>
           <a:p xmlns:a="http://schemas.openxmlformats.org/drawingml/2006/main">
             <a:pPr algn="r">
+              <a:buNone/>
               <a:defRPr sz="975">
                 <a:solidFill>
                   <a:srgbClr val="5B6B7F"/>
@@ -10824,6 +10937,7 @@
           <a:lstStyle xmlns:a="http://schemas.openxmlformats.org/drawingml/2006/main"/>
           <a:p xmlns:a="http://schemas.openxmlformats.org/drawingml/2006/main">
             <a:pPr>
+              <a:buNone/>
               <a:defRPr sz="1200" b="1">
                 <a:solidFill>
                   <a:srgbClr val="075678"/>
@@ -10836,7 +10950,7 @@
                   <a:srgbClr val="075678"/>
                 </a:solidFill>
               </a:rPr>
-              <a:t>STAP 3 · BRIEFJES VOORBEREIDEN</a:t>
+              <a:t>WIFI ALLEEN ALS DIE BESTAAT</a:t>
             </a:r>
           </a:p>
         </p:txBody>
@@ -10874,6 +10988,7 @@
           <a:lstStyle xmlns:a="http://schemas.openxmlformats.org/drawingml/2006/main"/>
           <a:p xmlns:a="http://schemas.openxmlformats.org/drawingml/2006/main">
             <a:pPr>
+              <a:buNone/>
               <a:defRPr sz="2700" b="1">
                 <a:solidFill>
                   <a:srgbClr val="17212D"/>
@@ -10886,7 +11001,7 @@
                   <a:srgbClr val="17212D"/>
                 </a:solidFill>
               </a:rPr>
-              <a:t>Vul alleen de zaalwifi in als u die aanbiedt</a:t>
+              <a:t>Het briefje toont alleen beschikbare verbindingen</a:t>
             </a:r>
           </a:p>
         </p:txBody>
@@ -10955,6 +11070,7 @@
           <a:lstStyle xmlns:a="http://schemas.openxmlformats.org/drawingml/2006/main"/>
           <a:p xmlns:a="http://schemas.openxmlformats.org/drawingml/2006/main">
             <a:pPr>
+              <a:buNone/>
               <a:defRPr sz="1575">
                 <a:solidFill>
                   <a:srgbClr val="17212D"/>
@@ -10967,11 +11083,12 @@
                   <a:srgbClr val="17212D"/>
                 </a:solidFill>
               </a:rPr>
-              <a:t>• Wifinaam en wachtwoord exact overnemen</a:t>
+              <a:t>• Zaalwifi: gegevens vooraf exact invullen</a:t>
             </a:r>
           </a:p>
           <a:p xmlns:a="http://schemas.openxmlformats.org/drawingml/2006/main">
             <a:pPr>
+              <a:buNone/>
               <a:defRPr sz="1575">
                 <a:solidFill>
                   <a:srgbClr val="17212D"/>
@@ -10984,11 +11101,12 @@
                   <a:srgbClr val="17212D"/>
                 </a:solidFill>
               </a:rPr>
-              <a:t>• Leeg laten wanneer mobiele data volstaat</a:t>
+              <a:t>• Geen zaalwifi: beide velden leeg laten</a:t>
             </a:r>
           </a:p>
           <a:p xmlns:a="http://schemas.openxmlformats.org/drawingml/2006/main">
             <a:pPr>
+              <a:buNone/>
               <a:defRPr sz="1575">
                 <a:solidFill>
                   <a:srgbClr val="17212D"/>
@@ -11001,7 +11119,7 @@
                   <a:srgbClr val="17212D"/>
                 </a:solidFill>
               </a:rPr>
-              <a:t>• Quizcode en afdrukvoorbeeld controleren</a:t>
+              <a:t>• De wifi-keuze verdwijnt dan van het briefje</a:t>
             </a:r>
           </a:p>
         </p:txBody>
@@ -11105,6 +11223,7 @@
           <a:lstStyle xmlns:a="http://schemas.openxmlformats.org/drawingml/2006/main"/>
           <a:p xmlns:a="http://schemas.openxmlformats.org/drawingml/2006/main">
             <a:pPr>
+              <a:buNone/>
               <a:defRPr sz="1425" b="1">
                 <a:solidFill>
                   <a:srgbClr val="168044"/>
@@ -11117,7 +11236,7 @@
                   <a:srgbClr val="168044"/>
                 </a:solidFill>
               </a:rPr>
-              <a:t>De wifi-QR-code wordt automatisch op beide briefjes geplaatst.</a:t>
+              <a:t>Zonder zaalwifi ziet de deelnemer alleen mobiele data.</a:t>
             </a:r>
           </a:p>
         </p:txBody>
@@ -11159,14 +11278,14 @@
       </p:sp>
       <p:pic>
         <p:nvPicPr>
-          <p:cNvPr id="22" name=""/>
+          <p:cNvPr id="24" name=""/>
           <p:cNvPicPr>
             <a:picLocks xmlns:a="http://schemas.openxmlformats.org/drawingml/2006/main" noChangeAspect="1"/>
           </p:cNvPicPr>
           <p:nvPr/>
         </p:nvPicPr>
         <p:blipFill>
-          <a:blip xmlns:r="http://schemas.openxmlformats.org/officeDocument/2006/relationships" xmlns:a="http://schemas.openxmlformats.org/drawingml/2006/main" r:embed="Rc419093362d84030"/>
+          <a:blip xmlns:r="http://schemas.openxmlformats.org/officeDocument/2006/relationships" xmlns:a="http://schemas.openxmlformats.org/drawingml/2006/main" r:embed="R8f3c2127261f4f14"/>
           <a:stretch xmlns:a="http://schemas.openxmlformats.org/drawingml/2006/main"/>
         </p:blipFill>
         <p:spPr>
@@ -11214,6 +11333,7 @@
           <a:lstStyle xmlns:a="http://schemas.openxmlformats.org/drawingml/2006/main"/>
           <a:p xmlns:a="http://schemas.openxmlformats.org/drawingml/2006/main">
             <a:pPr algn="ctr">
+              <a:buNone/>
               <a:defRPr sz="975">
                 <a:solidFill>
                   <a:srgbClr val="5B6B7F"/>
@@ -11295,6 +11415,7 @@
           <a:lstStyle xmlns:a="http://schemas.openxmlformats.org/drawingml/2006/main"/>
           <a:p xmlns:a="http://schemas.openxmlformats.org/drawingml/2006/main">
             <a:pPr>
+              <a:buNone/>
               <a:defRPr sz="975">
                 <a:solidFill>
                   <a:srgbClr val="5B6B7F"/>
@@ -11345,6 +11466,7 @@
           <a:lstStyle xmlns:a="http://schemas.openxmlformats.org/drawingml/2006/main"/>
           <a:p xmlns:a="http://schemas.openxmlformats.org/drawingml/2006/main">
             <a:pPr algn="r">
+              <a:buNone/>
               <a:defRPr sz="975">
                 <a:solidFill>
                   <a:srgbClr val="5B6B7F"/>
@@ -11424,6 +11546,7 @@
           <a:lstStyle xmlns:a="http://schemas.openxmlformats.org/drawingml/2006/main"/>
           <a:p xmlns:a="http://schemas.openxmlformats.org/drawingml/2006/main">
             <a:pPr>
+              <a:buNone/>
               <a:defRPr sz="1200" b="1">
                 <a:solidFill>
                   <a:srgbClr val="075678"/>
@@ -11436,7 +11559,7 @@
                   <a:srgbClr val="075678"/>
                 </a:solidFill>
               </a:rPr>
-              <a:t>STAP 4 · PROEFAFDRUK</a:t>
+              <a:t>AFDRUKKEN THUIS OF OP KANTOOR</a:t>
             </a:r>
           </a:p>
         </p:txBody>
@@ -11474,6 +11597,7 @@
           <a:lstStyle xmlns:a="http://schemas.openxmlformats.org/drawingml/2006/main"/>
           <a:p xmlns:a="http://schemas.openxmlformats.org/drawingml/2006/main">
             <a:pPr>
+              <a:buNone/>
               <a:defRPr sz="2700" b="1">
                 <a:solidFill>
                   <a:srgbClr val="17212D"/>
@@ -11486,7 +11610,7 @@
                   <a:srgbClr val="17212D"/>
                 </a:solidFill>
               </a:rPr>
-              <a:t>Controleer één afdruk vóór de volledige oplage</a:t>
+              <a:t>Druk de volledige oplage vooraf af</a:t>
             </a:r>
           </a:p>
         </p:txBody>
@@ -11555,6 +11679,7 @@
           <a:lstStyle xmlns:a="http://schemas.openxmlformats.org/drawingml/2006/main"/>
           <a:p xmlns:a="http://schemas.openxmlformats.org/drawingml/2006/main">
             <a:pPr>
+              <a:buNone/>
               <a:defRPr sz="1575">
                 <a:solidFill>
                   <a:srgbClr val="17212D"/>
@@ -11567,11 +11692,12 @@
                   <a:srgbClr val="17212D"/>
                 </a:solidFill>
               </a:rPr>
-              <a:t>• A4 staand en standaard schaal</a:t>
+              <a:t>• Eerst één A4 testen en beide QR-codes scannen</a:t>
             </a:r>
           </a:p>
           <a:p xmlns:a="http://schemas.openxmlformats.org/drawingml/2006/main">
             <a:pPr>
+              <a:buNone/>
               <a:defRPr sz="1575">
                 <a:solidFill>
                   <a:srgbClr val="17212D"/>
@@ -11584,11 +11710,12 @@
                   <a:srgbClr val="17212D"/>
                 </a:solidFill>
               </a:rPr>
-              <a:t>• Twee verticale briefjes per vel</a:t>
+              <a:t>• Daarna de geschikte grotere printer gebruiken</a:t>
             </a:r>
           </a:p>
           <a:p xmlns:a="http://schemas.openxmlformats.org/drawingml/2006/main">
             <a:pPr>
+              <a:buNone/>
               <a:defRPr sz="1575">
                 <a:solidFill>
                   <a:srgbClr val="17212D"/>
@@ -11601,7 +11728,7 @@
                   <a:srgbClr val="17212D"/>
                 </a:solidFill>
               </a:rPr>
-              <a:t>• Beide QR-codes met een gsm testen</a:t>
+              <a:t>• 60 deelnemers = 30 vellen plus reserves</a:t>
             </a:r>
           </a:p>
         </p:txBody>
@@ -11705,6 +11832,7 @@
           <a:lstStyle xmlns:a="http://schemas.openxmlformats.org/drawingml/2006/main"/>
           <a:p xmlns:a="http://schemas.openxmlformats.org/drawingml/2006/main">
             <a:pPr>
+              <a:buNone/>
               <a:defRPr sz="1425" b="1">
                 <a:solidFill>
                   <a:srgbClr val="168044"/>
@@ -11717,7 +11845,7 @@
                   <a:srgbClr val="168044"/>
                 </a:solidFill>
               </a:rPr>
-              <a:t>Druk daarna voldoende exemplaren én enkele reserves af.</a:t>
+              <a:t>Snijd en bundel alle briefjes vóór het vertrek.</a:t>
             </a:r>
           </a:p>
         </p:txBody>
@@ -11759,14 +11887,14 @@
       </p:sp>
       <p:pic>
         <p:nvPicPr>
-          <p:cNvPr id="22" name=""/>
+          <p:cNvPr id="24" name=""/>
           <p:cNvPicPr>
             <a:picLocks xmlns:a="http://schemas.openxmlformats.org/drawingml/2006/main" noChangeAspect="1"/>
           </p:cNvPicPr>
           <p:nvPr/>
         </p:nvPicPr>
         <p:blipFill>
-          <a:blip xmlns:r="http://schemas.openxmlformats.org/officeDocument/2006/relationships" xmlns:a="http://schemas.openxmlformats.org/drawingml/2006/main" r:embed="Rb4ab1e9ef4294ca4"/>
+          <a:blip xmlns:r="http://schemas.openxmlformats.org/officeDocument/2006/relationships" xmlns:a="http://schemas.openxmlformats.org/drawingml/2006/main" r:embed="R2f05dd28594c4cb8"/>
           <a:stretch xmlns:a="http://schemas.openxmlformats.org/drawingml/2006/main"/>
         </p:blipFill>
         <p:spPr>
@@ -11814,6 +11942,7 @@
           <a:lstStyle xmlns:a="http://schemas.openxmlformats.org/drawingml/2006/main"/>
           <a:p xmlns:a="http://schemas.openxmlformats.org/drawingml/2006/main">
             <a:pPr algn="ctr">
+              <a:buNone/>
               <a:defRPr sz="975">
                 <a:solidFill>
                   <a:srgbClr val="5B6B7F"/>
@@ -11895,6 +12024,7 @@
           <a:lstStyle xmlns:a="http://schemas.openxmlformats.org/drawingml/2006/main"/>
           <a:p xmlns:a="http://schemas.openxmlformats.org/drawingml/2006/main">
             <a:pPr>
+              <a:buNone/>
               <a:defRPr sz="975">
                 <a:solidFill>
                   <a:srgbClr val="5B6B7F"/>
@@ -11945,6 +12075,7 @@
           <a:lstStyle xmlns:a="http://schemas.openxmlformats.org/drawingml/2006/main"/>
           <a:p xmlns:a="http://schemas.openxmlformats.org/drawingml/2006/main">
             <a:pPr algn="r">
+              <a:buNone/>
               <a:defRPr sz="975">
                 <a:solidFill>
                   <a:srgbClr val="5B6B7F"/>
@@ -12024,6 +12155,7 @@
           <a:lstStyle xmlns:a="http://schemas.openxmlformats.org/drawingml/2006/main"/>
           <a:p xmlns:a="http://schemas.openxmlformats.org/drawingml/2006/main">
             <a:pPr>
+              <a:buNone/>
               <a:defRPr sz="1200" b="1">
                 <a:solidFill>
                   <a:srgbClr val="075678"/>
@@ -12036,7 +12168,7 @@
                   <a:srgbClr val="075678"/>
                 </a:solidFill>
               </a:rPr>
-              <a:t>WAAROM EEN PAPIEREN BRIEFJE?</a:t>
+              <a:t>WAAROM VOORAF GEDRUKT PAPIER?</a:t>
             </a:r>
           </a:p>
         </p:txBody>
@@ -12074,6 +12206,7 @@
           <a:lstStyle xmlns:a="http://schemas.openxmlformats.org/drawingml/2006/main"/>
           <a:p xmlns:a="http://schemas.openxmlformats.org/drawingml/2006/main">
             <a:pPr>
+              <a:buNone/>
               <a:defRPr sz="2700" b="1">
                 <a:solidFill>
                   <a:srgbClr val="17212D"/>
@@ -12086,7 +12219,7 @@
                   <a:srgbClr val="17212D"/>
                 </a:solidFill>
               </a:rPr>
-              <a:t>Het briefje geeft rust en altijd een reserveweg</a:t>
+              <a:t>Vooraf gedrukte briefjes geven rust</a:t>
             </a:r>
           </a:p>
         </p:txBody>
@@ -12155,6 +12288,7 @@
           <a:lstStyle xmlns:a="http://schemas.openxmlformats.org/drawingml/2006/main"/>
           <a:p xmlns:a="http://schemas.openxmlformats.org/drawingml/2006/main">
             <a:pPr>
+              <a:buNone/>
               <a:defRPr sz="1575">
                 <a:solidFill>
                   <a:srgbClr val="17212D"/>
@@ -12167,11 +12301,12 @@
                   <a:srgbClr val="17212D"/>
                 </a:solidFill>
               </a:rPr>
-              <a:t>• Geen QR-code scannen van een ver scherm</a:t>
+              <a:t>• Geen QR-code van een ver scherm scannen</a:t>
             </a:r>
           </a:p>
           <a:p xmlns:a="http://schemas.openxmlformats.org/drawingml/2006/main">
             <a:pPr>
+              <a:buNone/>
               <a:defRPr sz="1575">
                 <a:solidFill>
                   <a:srgbClr val="17212D"/>
@@ -12184,11 +12319,12 @@
                   <a:srgbClr val="17212D"/>
                 </a:solidFill>
               </a:rPr>
-              <a:t>• Alle stappen blijven in de hand van de deelnemer</a:t>
+              <a:t>• Iedereen houdt alle stappen zelf bij de hand</a:t>
             </a:r>
           </a:p>
           <a:p xmlns:a="http://schemas.openxmlformats.org/drawingml/2006/main">
             <a:pPr>
+              <a:buNone/>
               <a:defRPr sz="1575">
                 <a:solidFill>
                   <a:srgbClr val="17212D"/>
@@ -12201,7 +12337,7 @@
                   <a:srgbClr val="17212D"/>
                 </a:solidFill>
               </a:rPr>
-              <a:t>• QR-code én link met quizcode beschikbaar</a:t>
+              <a:t>• QR-code, link en quizcode bieden een reserveweg</a:t>
             </a:r>
           </a:p>
         </p:txBody>
@@ -12305,6 +12441,7 @@
           <a:lstStyle xmlns:a="http://schemas.openxmlformats.org/drawingml/2006/main"/>
           <a:p xmlns:a="http://schemas.openxmlformats.org/drawingml/2006/main">
             <a:pPr>
+              <a:buNone/>
               <a:defRPr sz="1425" b="1">
                 <a:solidFill>
                   <a:srgbClr val="168044"/>
@@ -12317,7 +12454,7 @@
                   <a:srgbClr val="168044"/>
                 </a:solidFill>
               </a:rPr>
-              <a:t>Het briefje maakt zelfstandig starten én persoonlijke hulp mogelijk.</a:t>
+              <a:t>Instructie, toegang en hulp staan samen op één briefje.</a:t>
             </a:r>
           </a:p>
         </p:txBody>
@@ -12359,14 +12496,14 @@
       </p:sp>
       <p:pic>
         <p:nvPicPr>
-          <p:cNvPr id="22" name=""/>
+          <p:cNvPr id="24" name=""/>
           <p:cNvPicPr>
             <a:picLocks xmlns:a="http://schemas.openxmlformats.org/drawingml/2006/main" noChangeAspect="1"/>
           </p:cNvPicPr>
           <p:nvPr/>
         </p:nvPicPr>
         <p:blipFill>
-          <a:blip xmlns:r="http://schemas.openxmlformats.org/officeDocument/2006/relationships" xmlns:a="http://schemas.openxmlformats.org/drawingml/2006/main" r:embed="Rcb993cece3e14477"/>
+          <a:blip xmlns:r="http://schemas.openxmlformats.org/officeDocument/2006/relationships" xmlns:a="http://schemas.openxmlformats.org/drawingml/2006/main" r:embed="Rd2d7c3da82294c70"/>
           <a:stretch xmlns:a="http://schemas.openxmlformats.org/drawingml/2006/main"/>
         </p:blipFill>
         <p:spPr>
@@ -12414,6 +12551,7 @@
           <a:lstStyle xmlns:a="http://schemas.openxmlformats.org/drawingml/2006/main"/>
           <a:p xmlns:a="http://schemas.openxmlformats.org/drawingml/2006/main">
             <a:pPr algn="ctr">
+              <a:buNone/>
               <a:defRPr sz="975">
                 <a:solidFill>
                   <a:srgbClr val="5B6B7F"/>
@@ -12495,6 +12633,7 @@
           <a:lstStyle xmlns:a="http://schemas.openxmlformats.org/drawingml/2006/main"/>
           <a:p xmlns:a="http://schemas.openxmlformats.org/drawingml/2006/main">
             <a:pPr>
+              <a:buNone/>
               <a:defRPr sz="975">
                 <a:solidFill>
                   <a:srgbClr val="5B6B7F"/>
@@ -12545,6 +12684,7 @@
           <a:lstStyle xmlns:a="http://schemas.openxmlformats.org/drawingml/2006/main"/>
           <a:p xmlns:a="http://schemas.openxmlformats.org/drawingml/2006/main">
             <a:pPr algn="r">
+              <a:buNone/>
               <a:defRPr sz="975">
                 <a:solidFill>
                   <a:srgbClr val="5B6B7F"/>
@@ -12624,6 +12764,7 @@
           <a:lstStyle xmlns:a="http://schemas.openxmlformats.org/drawingml/2006/main"/>
           <a:p xmlns:a="http://schemas.openxmlformats.org/drawingml/2006/main">
             <a:pPr>
+              <a:buNone/>
               <a:defRPr sz="1200" b="1">
                 <a:solidFill>
                   <a:srgbClr val="075678"/>
@@ -12636,7 +12777,7 @@
                   <a:srgbClr val="075678"/>
                 </a:solidFill>
               </a:rPr>
-              <a:t>BIJ HET BINNENKOMEN</a:t>
+              <a:t>VERWACHT HIER HET MEESTE OPONTHOUD</a:t>
             </a:r>
           </a:p>
         </p:txBody>
@@ -12674,6 +12815,7 @@
           <a:lstStyle xmlns:a="http://schemas.openxmlformats.org/drawingml/2006/main"/>
           <a:p xmlns:a="http://schemas.openxmlformats.org/drawingml/2006/main">
             <a:pPr>
+              <a:buNone/>
               <a:defRPr sz="2700" b="1">
                 <a:solidFill>
                   <a:srgbClr val="17212D"/>
@@ -12686,7 +12828,7 @@
                   <a:srgbClr val="17212D"/>
                 </a:solidFill>
               </a:rPr>
-              <a:t>Deel één briefje per deelnemer uit</a:t>
+              <a:t>Maak van verbinden een apart onthaalmoment</a:t>
             </a:r>
           </a:p>
         </p:txBody>
@@ -12755,6 +12897,7 @@
           <a:lstStyle xmlns:a="http://schemas.openxmlformats.org/drawingml/2006/main"/>
           <a:p xmlns:a="http://schemas.openxmlformats.org/drawingml/2006/main">
             <a:pPr>
+              <a:buNone/>
               <a:defRPr sz="1575">
                 <a:solidFill>
                   <a:srgbClr val="17212D"/>
@@ -12767,11 +12910,12 @@
                   <a:srgbClr val="17212D"/>
                 </a:solidFill>
               </a:rPr>
-              <a:t>• Uitdelen vóór iedereen plaatsneemt</a:t>
+              <a:t>• Voorzie 15–20 minuten vóór de quizstart</a:t>
             </a:r>
           </a:p>
           <a:p xmlns:a="http://schemas.openxmlformats.org/drawingml/2006/main">
             <a:pPr>
+              <a:buNone/>
               <a:defRPr sz="1575">
                 <a:solidFill>
                   <a:srgbClr val="17212D"/>
@@ -12784,11 +12928,12 @@
                   <a:srgbClr val="17212D"/>
                 </a:solidFill>
               </a:rPr>
-              <a:t>• Vraag de pagina na verbinden open te laten</a:t>
+              <a:t>• Geef aan de ingang één vaste korte instructie</a:t>
             </a:r>
           </a:p>
           <a:p xmlns:a="http://schemas.openxmlformats.org/drawingml/2006/main">
             <a:pPr>
+              <a:buNone/>
               <a:defRPr sz="1575">
                 <a:solidFill>
                   <a:srgbClr val="17212D"/>
@@ -12801,7 +12946,7 @@
                   <a:srgbClr val="17212D"/>
                 </a:solidFill>
               </a:rPr>
-              <a:t>• Voorzie één of twee helpers in de zaal</a:t>
+              <a:t>• Zet helpers bij de ingang én in de zaal</a:t>
             </a:r>
           </a:p>
         </p:txBody>
@@ -12905,6 +13050,7 @@
           <a:lstStyle xmlns:a="http://schemas.openxmlformats.org/drawingml/2006/main"/>
           <a:p xmlns:a="http://schemas.openxmlformats.org/drawingml/2006/main">
             <a:pPr>
+              <a:buNone/>
               <a:defRPr sz="1425" b="1">
                 <a:solidFill>
                   <a:srgbClr val="168044"/>
@@ -12917,7 +13063,7 @@
                   <a:srgbClr val="168044"/>
                 </a:solidFill>
               </a:rPr>
-              <a:t>Start pas wanneer alle deelnemers in de verbindingsteller staan.</a:t>
+              <a:t>Begin pas wanneer de verbindingsteller klopt.</a:t>
             </a:r>
           </a:p>
         </p:txBody>
@@ -12959,14 +13105,14 @@
       </p:sp>
       <p:pic>
         <p:nvPicPr>
-          <p:cNvPr id="22" name=""/>
+          <p:cNvPr id="24" name=""/>
           <p:cNvPicPr>
             <a:picLocks xmlns:a="http://schemas.openxmlformats.org/drawingml/2006/main" noChangeAspect="1"/>
           </p:cNvPicPr>
           <p:nvPr/>
         </p:nvPicPr>
         <p:blipFill>
-          <a:blip xmlns:r="http://schemas.openxmlformats.org/officeDocument/2006/relationships" xmlns:a="http://schemas.openxmlformats.org/drawingml/2006/main" r:embed="R2c88684e9e7147b2"/>
+          <a:blip xmlns:r="http://schemas.openxmlformats.org/officeDocument/2006/relationships" xmlns:a="http://schemas.openxmlformats.org/drawingml/2006/main" r:embed="Rea49e0bc55d84ca8"/>
           <a:stretch xmlns:a="http://schemas.openxmlformats.org/drawingml/2006/main"/>
         </p:blipFill>
         <p:spPr>
@@ -13014,6 +13160,7 @@
           <a:lstStyle xmlns:a="http://schemas.openxmlformats.org/drawingml/2006/main"/>
           <a:p xmlns:a="http://schemas.openxmlformats.org/drawingml/2006/main">
             <a:pPr algn="ctr">
+              <a:buNone/>
               <a:defRPr sz="975">
                 <a:solidFill>
                   <a:srgbClr val="5B6B7F"/>
@@ -13095,6 +13242,7 @@
           <a:lstStyle xmlns:a="http://schemas.openxmlformats.org/drawingml/2006/main"/>
           <a:p xmlns:a="http://schemas.openxmlformats.org/drawingml/2006/main">
             <a:pPr>
+              <a:buNone/>
               <a:defRPr sz="975">
                 <a:solidFill>
                   <a:srgbClr val="5B6B7F"/>
@@ -13145,6 +13293,7 @@
           <a:lstStyle xmlns:a="http://schemas.openxmlformats.org/drawingml/2006/main"/>
           <a:p xmlns:a="http://schemas.openxmlformats.org/drawingml/2006/main">
             <a:pPr algn="r">
+              <a:buNone/>
               <a:defRPr sz="975">
                 <a:solidFill>
                   <a:srgbClr val="5B6B7F"/>

</xml_diff>

<commit_message>
Benadruk mobiele data als voorkeursverbinding
</commit_message>
<xml_diff>
--- a/video-handleiding/Live-Diabetes-Quiz-storyboard.pptx
+++ b/video-handleiding/Live-Diabetes-Quiz-storyboard.pptx
@@ -2,29 +2,29 @@
 <file path=ppt/presentation.xml><?xml version="1.0" encoding="utf-8"?>
 <p:presentation xmlns:p="http://schemas.openxmlformats.org/presentationml/2006/main">
   <p:sldMasterIdLst>
-    <p:sldMasterId xmlns:r="http://schemas.openxmlformats.org/officeDocument/2006/relationships" id="2147483648" r:id="R59dc468609f44992"/>
+    <p:sldMasterId xmlns:r="http://schemas.openxmlformats.org/officeDocument/2006/relationships" id="2147483648" r:id="R98579b2fc6564d4f"/>
   </p:sldMasterIdLst>
   <p:notesMasterIdLst>
-    <p:notesMasterId xmlns:r="http://schemas.openxmlformats.org/officeDocument/2006/relationships" r:id="Reb8cafaa2dee444c"/>
+    <p:notesMasterId xmlns:r="http://schemas.openxmlformats.org/officeDocument/2006/relationships" r:id="R5c8a452ddf874720"/>
   </p:notesMasterIdLst>
   <p:sldIdLst>
-    <p:sldId xmlns:r="http://schemas.openxmlformats.org/officeDocument/2006/relationships" id="256" r:id="Rf03291bf81204915"/>
-    <p:sldId xmlns:r="http://schemas.openxmlformats.org/officeDocument/2006/relationships" id="257" r:id="Ra6a51b7c199a4e8b"/>
-    <p:sldId xmlns:r="http://schemas.openxmlformats.org/officeDocument/2006/relationships" id="258" r:id="R9199490869f24022"/>
-    <p:sldId xmlns:r="http://schemas.openxmlformats.org/officeDocument/2006/relationships" id="259" r:id="R1f1b47a0d66847dc"/>
-    <p:sldId xmlns:r="http://schemas.openxmlformats.org/officeDocument/2006/relationships" id="260" r:id="Raafa023758914a91"/>
-    <p:sldId xmlns:r="http://schemas.openxmlformats.org/officeDocument/2006/relationships" id="261" r:id="R27b99e78bbe64ad6"/>
-    <p:sldId xmlns:r="http://schemas.openxmlformats.org/officeDocument/2006/relationships" id="262" r:id="R68e0a49e942a456d"/>
-    <p:sldId xmlns:r="http://schemas.openxmlformats.org/officeDocument/2006/relationships" id="263" r:id="Rb2b202a368c043a9"/>
-    <p:sldId xmlns:r="http://schemas.openxmlformats.org/officeDocument/2006/relationships" id="264" r:id="R60f248b5a8b04d92"/>
-    <p:sldId xmlns:r="http://schemas.openxmlformats.org/officeDocument/2006/relationships" id="265" r:id="Rd91ce729a3e74b11"/>
-    <p:sldId xmlns:r="http://schemas.openxmlformats.org/officeDocument/2006/relationships" id="266" r:id="R3401523ae04b4e65"/>
-    <p:sldId xmlns:r="http://schemas.openxmlformats.org/officeDocument/2006/relationships" id="267" r:id="R49ff4b6c513a4c9a"/>
-    <p:sldId xmlns:r="http://schemas.openxmlformats.org/officeDocument/2006/relationships" id="268" r:id="R3447976f75474a6b"/>
-    <p:sldId xmlns:r="http://schemas.openxmlformats.org/officeDocument/2006/relationships" id="269" r:id="R1239d433cde347b6"/>
-    <p:sldId xmlns:r="http://schemas.openxmlformats.org/officeDocument/2006/relationships" id="270" r:id="Re9663e37ba1941c9"/>
-    <p:sldId xmlns:r="http://schemas.openxmlformats.org/officeDocument/2006/relationships" id="271" r:id="R50f9e37537d74214"/>
-    <p:sldId xmlns:r="http://schemas.openxmlformats.org/officeDocument/2006/relationships" id="272" r:id="Rf98068bb5bb54a40"/>
+    <p:sldId xmlns:r="http://schemas.openxmlformats.org/officeDocument/2006/relationships" id="256" r:id="R4ef73f7dfd04439b"/>
+    <p:sldId xmlns:r="http://schemas.openxmlformats.org/officeDocument/2006/relationships" id="257" r:id="R828844c7993644f0"/>
+    <p:sldId xmlns:r="http://schemas.openxmlformats.org/officeDocument/2006/relationships" id="258" r:id="R0168a7a0690b4636"/>
+    <p:sldId xmlns:r="http://schemas.openxmlformats.org/officeDocument/2006/relationships" id="259" r:id="R4e9e660fc0b64cb3"/>
+    <p:sldId xmlns:r="http://schemas.openxmlformats.org/officeDocument/2006/relationships" id="260" r:id="R6ac3d9c0847b426b"/>
+    <p:sldId xmlns:r="http://schemas.openxmlformats.org/officeDocument/2006/relationships" id="261" r:id="Ra6016b7b064a4e73"/>
+    <p:sldId xmlns:r="http://schemas.openxmlformats.org/officeDocument/2006/relationships" id="262" r:id="Rf045b5cae085432c"/>
+    <p:sldId xmlns:r="http://schemas.openxmlformats.org/officeDocument/2006/relationships" id="263" r:id="Ref3a30c8689643e9"/>
+    <p:sldId xmlns:r="http://schemas.openxmlformats.org/officeDocument/2006/relationships" id="264" r:id="R217ece9637a2421a"/>
+    <p:sldId xmlns:r="http://schemas.openxmlformats.org/officeDocument/2006/relationships" id="265" r:id="R60974b0dd85345b5"/>
+    <p:sldId xmlns:r="http://schemas.openxmlformats.org/officeDocument/2006/relationships" id="266" r:id="R9f4295f9f6d54920"/>
+    <p:sldId xmlns:r="http://schemas.openxmlformats.org/officeDocument/2006/relationships" id="267" r:id="Rf62a6e3411f54117"/>
+    <p:sldId xmlns:r="http://schemas.openxmlformats.org/officeDocument/2006/relationships" id="268" r:id="R4053c0b46b964923"/>
+    <p:sldId xmlns:r="http://schemas.openxmlformats.org/officeDocument/2006/relationships" id="269" r:id="R17de315d998e4684"/>
+    <p:sldId xmlns:r="http://schemas.openxmlformats.org/officeDocument/2006/relationships" id="270" r:id="R6b0addeb0c934164"/>
+    <p:sldId xmlns:r="http://schemas.openxmlformats.org/officeDocument/2006/relationships" id="271" r:id="R8abf7a48b9cd4f80"/>
+    <p:sldId xmlns:r="http://schemas.openxmlformats.org/officeDocument/2006/relationships" id="272" r:id="R0cb4f6aa4065404a"/>
   </p:sldIdLst>
   <p:sldSz cx="12192000" cy="6858000"/>
   <p:notesSz cx="6858000" cy="9144000"/>
@@ -1408,12 +1408,12 @@
           <a:lstStyle xmlns:a="http://schemas.openxmlformats.org/drawingml/2006/main"/>
           <a:p xmlns:a="http://schemas.openxmlformats.org/drawingml/2006/main">
             <a:r>
-              <a:t>DIA 3 — Thuis: beslis eerst over de internetverbinding</a:t>
-            </a:r>
-          </a:p>
-          <a:p xmlns:a="http://schemas.openxmlformats.org/drawingml/2006/main">
-            <a:r>
-              <a:t>Duur: 55 seconden</a:t>
+              <a:t>DIA 3 — Thuis: mobiele data heeft de voorkeur, wifi blijft beschikbaar</a:t>
+            </a:r>
+          </a:p>
+          <a:p xmlns:a="http://schemas.openxmlformats.org/drawingml/2006/main">
+            <a:r>
+              <a:t>Duur: 75 seconden</a:t>
             </a:r>
           </a:p>
           <a:p xmlns:a="http://schemas.openxmlformats.org/drawingml/2006/main">
@@ -1423,7 +1423,7 @@
           </a:p>
           <a:p xmlns:a="http://schemas.openxmlformats.org/drawingml/2006/main">
             <a:r>
-              <a:t>Begin ruim vóór de activiteit met de zaalgegevens. Vraag hoeveel deelnemers ongeveer verwacht worden en of betrouwbare gastenwifi beschikbaar is. Is er wifi, noteer dan de exacte wifinaam en het wachtwoord en vraag of veel toestellen tegelijk mogen verbinden. Is er geen wifi, dan gebruiken deelnemers hun mobiele data. Controleer in dat geval vooraf of er in de zaal voldoende mobiel bereik is, liefst met toestellen van verschillende netwerken. Vermeld zo mogelijk al in de uitnodiging dat deelnemers een gsm met internet nodig hebben. Deze keuze bepaalt later wat er op het deelnemersbriefje verschijnt.</a:t>
+              <a:t>Begin ruim vóór de activiteit met de zaalgegevens. De eenvoudigste keuze is dat iedere deelnemer de eigen mobiele data gebruikt. Veel mensen zijn tegenwoordig voortdurend online en hebben een datapakket dat hiervoor ruim volstaat. Ze hoeven dan geen nieuw netwerk te kiezen of een wifiwachtwoord in te voeren. Is er gratis zaalwifi, bied die keuze dan toch aan op het briefje. Sommige deelnemers gebruiken liever wifi of hebben weinig mobiele data. De organisator test vooraf in de zaal beide mogelijkheden: de zaalwifi met meerdere toestellen én de mobiele ontvangst, liefst met verschillende mobiele netwerken. Is de mobiele ontvangst goed, zeg dan bij het onthaal dat de eigen mobiele data de gemakkelijkste keuze is. Is de mobiele ontvangst zwak of onbetrouwbaar, vraag deelnemers dan uitdrukkelijk de zaalwifi en de wifi-QR-code op hun briefje te gebruiken. Noteer daarom vooraf de exacte wifinaam en het wachtwoord. Zonder zaalwifi vermeldt het briefje alleen mobiele data. Deze voorbereiding en duidelijke communicatie voorkomen het grootste deel van het oponthoud bij de start.</a:t>
             </a:r>
           </a:p>
           <a:p xmlns:a="http://schemas.openxmlformats.org/drawingml/2006/main">
@@ -1433,7 +1433,7 @@
           </a:p>
           <a:p xmlns:a="http://schemas.openxmlformats.org/drawingml/2006/main">
             <a:r>
-              <a:t>Canva-aanwijzing: Laat een duidelijke splitsing zien: “Wifi beschikbaar” en “Geen wifi — mobiele data”.</a:t>
+              <a:t>Canva-aanwijzing: Zet “Voorkeur: eigen mobiele data” duidelijk bovenaan. Toon daarnaast “Gratis zaalwifi: vrije keuze en reserve”. Eindig met de beslisregel: goed mobiel bereik is mobiele data; slecht mobiel bereik is zaalwifi adviseren.</a:t>
             </a:r>
           </a:p>
         </p:txBody>
@@ -2071,7 +2071,7 @@
   </p:cSld>
   <p:clrMap bg1="lt1" tx1="dk1" bg2="lt2" tx2="dk2" accent1="accent1" accent2="accent2" accent3="accent3" accent4="accent4" accent5="accent5" accent6="accent6" hlink="hlink" folHlink="folHlink"/>
   <p:sldLayoutIdLst>
-    <p:sldLayoutId xmlns:r="http://schemas.openxmlformats.org/officeDocument/2006/relationships" id="2147483649" r:id="Rade02ae5dc3e4282"/>
+    <p:sldLayoutId xmlns:r="http://schemas.openxmlformats.org/officeDocument/2006/relationships" id="2147483649" r:id="Rfaa37bd060384da0"/>
   </p:sldLayoutIdLst>
   <p:txStyles>
     <p:titleStyle>
@@ -2690,7 +2690,7 @@
           <p:nvPr/>
         </p:nvPicPr>
         <p:blipFill>
-          <a:blip xmlns:r="http://schemas.openxmlformats.org/officeDocument/2006/relationships" xmlns:a="http://schemas.openxmlformats.org/drawingml/2006/main" r:embed="R1c9df6f6682049a5"/>
+          <a:blip xmlns:r="http://schemas.openxmlformats.org/officeDocument/2006/relationships" xmlns:a="http://schemas.openxmlformats.org/drawingml/2006/main" r:embed="R1f4929599dee4616"/>
           <a:stretch xmlns:a="http://schemas.openxmlformats.org/drawingml/2006/main"/>
         </p:blipFill>
         <p:spPr>
@@ -3403,7 +3403,7 @@
           <p:nvPr/>
         </p:nvPicPr>
         <p:blipFill>
-          <a:blip xmlns:r="http://schemas.openxmlformats.org/officeDocument/2006/relationships" xmlns:a="http://schemas.openxmlformats.org/drawingml/2006/main" r:embed="Rb9560657ab204366"/>
+          <a:blip xmlns:r="http://schemas.openxmlformats.org/officeDocument/2006/relationships" xmlns:a="http://schemas.openxmlformats.org/drawingml/2006/main" r:embed="R4626ff42f4484cba"/>
           <a:stretch xmlns:a="http://schemas.openxmlformats.org/drawingml/2006/main"/>
         </p:blipFill>
         <p:spPr>
@@ -4010,7 +4010,7 @@
           <p:nvPr/>
         </p:nvPicPr>
         <p:blipFill>
-          <a:blip xmlns:r="http://schemas.openxmlformats.org/officeDocument/2006/relationships" xmlns:a="http://schemas.openxmlformats.org/drawingml/2006/main" r:embed="Rb69f2c25fe934db6"/>
+          <a:blip xmlns:r="http://schemas.openxmlformats.org/officeDocument/2006/relationships" xmlns:a="http://schemas.openxmlformats.org/drawingml/2006/main" r:embed="R10764418a53e4a4d"/>
           <a:stretch xmlns:a="http://schemas.openxmlformats.org/drawingml/2006/main"/>
         </p:blipFill>
         <p:spPr>
@@ -4617,7 +4617,7 @@
           <p:nvPr/>
         </p:nvPicPr>
         <p:blipFill>
-          <a:blip xmlns:r="http://schemas.openxmlformats.org/officeDocument/2006/relationships" xmlns:a="http://schemas.openxmlformats.org/drawingml/2006/main" r:embed="R6cdb34a0e2ff4fc3"/>
+          <a:blip xmlns:r="http://schemas.openxmlformats.org/officeDocument/2006/relationships" xmlns:a="http://schemas.openxmlformats.org/drawingml/2006/main" r:embed="R59f591f7beea4a59"/>
           <a:stretch xmlns:a="http://schemas.openxmlformats.org/drawingml/2006/main"/>
         </p:blipFill>
         <p:spPr>
@@ -5224,7 +5224,7 @@
           <p:nvPr/>
         </p:nvPicPr>
         <p:blipFill>
-          <a:blip xmlns:r="http://schemas.openxmlformats.org/officeDocument/2006/relationships" xmlns:a="http://schemas.openxmlformats.org/drawingml/2006/main" r:embed="R95c051e9c0804143"/>
+          <a:blip xmlns:r="http://schemas.openxmlformats.org/officeDocument/2006/relationships" xmlns:a="http://schemas.openxmlformats.org/drawingml/2006/main" r:embed="Rcc70975d84dc49a8"/>
           <a:stretch xmlns:a="http://schemas.openxmlformats.org/drawingml/2006/main"/>
         </p:blipFill>
         <p:spPr>
@@ -5831,7 +5831,7 @@
           <p:nvPr/>
         </p:nvPicPr>
         <p:blipFill>
-          <a:blip xmlns:r="http://schemas.openxmlformats.org/officeDocument/2006/relationships" xmlns:a="http://schemas.openxmlformats.org/drawingml/2006/main" r:embed="Re25ceb16837c4337"/>
+          <a:blip xmlns:r="http://schemas.openxmlformats.org/officeDocument/2006/relationships" xmlns:a="http://schemas.openxmlformats.org/drawingml/2006/main" r:embed="R57aa18c8b00f4774"/>
           <a:stretch xmlns:a="http://schemas.openxmlformats.org/drawingml/2006/main"/>
         </p:blipFill>
         <p:spPr>
@@ -6438,7 +6438,7 @@
           <p:nvPr/>
         </p:nvPicPr>
         <p:blipFill>
-          <a:blip xmlns:r="http://schemas.openxmlformats.org/officeDocument/2006/relationships" xmlns:a="http://schemas.openxmlformats.org/drawingml/2006/main" r:embed="Rba7dd38ea8454812"/>
+          <a:blip xmlns:r="http://schemas.openxmlformats.org/officeDocument/2006/relationships" xmlns:a="http://schemas.openxmlformats.org/drawingml/2006/main" r:embed="R14248b6fa6e144fd"/>
           <a:stretch xmlns:a="http://schemas.openxmlformats.org/drawingml/2006/main"/>
         </p:blipFill>
         <p:spPr>
@@ -7045,7 +7045,7 @@
           <p:nvPr/>
         </p:nvPicPr>
         <p:blipFill>
-          <a:blip xmlns:r="http://schemas.openxmlformats.org/officeDocument/2006/relationships" xmlns:a="http://schemas.openxmlformats.org/drawingml/2006/main" r:embed="Re0a5dd34bb7046f4"/>
+          <a:blip xmlns:r="http://schemas.openxmlformats.org/officeDocument/2006/relationships" xmlns:a="http://schemas.openxmlformats.org/drawingml/2006/main" r:embed="R41efd44222614fff"/>
           <a:stretch xmlns:a="http://schemas.openxmlformats.org/drawingml/2006/main"/>
         </p:blipFill>
         <p:spPr>
@@ -7104,7 +7104,7 @@
           <p:nvPr/>
         </p:nvPicPr>
         <p:blipFill>
-          <a:blip xmlns:r="http://schemas.openxmlformats.org/officeDocument/2006/relationships" xmlns:a="http://schemas.openxmlformats.org/drawingml/2006/main" r:embed="R8c6fd230a5a04caf"/>
+          <a:blip xmlns:r="http://schemas.openxmlformats.org/officeDocument/2006/relationships" xmlns:a="http://schemas.openxmlformats.org/drawingml/2006/main" r:embed="Ra38db92191794243"/>
           <a:stretch xmlns:a="http://schemas.openxmlformats.org/drawingml/2006/main"/>
         </p:blipFill>
         <p:spPr>
@@ -7713,7 +7713,7 @@
           <p:nvPr/>
         </p:nvPicPr>
         <p:blipFill>
-          <a:blip xmlns:r="http://schemas.openxmlformats.org/officeDocument/2006/relationships" xmlns:a="http://schemas.openxmlformats.org/drawingml/2006/main" r:embed="R4ed6f12a3a424486"/>
+          <a:blip xmlns:r="http://schemas.openxmlformats.org/officeDocument/2006/relationships" xmlns:a="http://schemas.openxmlformats.org/drawingml/2006/main" r:embed="Rbb3a55755b01490e"/>
           <a:stretch xmlns:a="http://schemas.openxmlformats.org/drawingml/2006/main"/>
         </p:blipFill>
         <p:spPr>
@@ -8320,7 +8320,7 @@
           <p:nvPr/>
         </p:nvPicPr>
         <p:blipFill>
-          <a:blip xmlns:r="http://schemas.openxmlformats.org/officeDocument/2006/relationships" xmlns:a="http://schemas.openxmlformats.org/drawingml/2006/main" r:embed="R2d31937cbea54a5e"/>
+          <a:blip xmlns:r="http://schemas.openxmlformats.org/officeDocument/2006/relationships" xmlns:a="http://schemas.openxmlformats.org/drawingml/2006/main" r:embed="Rfb1a5e6494e24b55"/>
           <a:stretch xmlns:a="http://schemas.openxmlformats.org/drawingml/2006/main"/>
         </p:blipFill>
         <p:spPr>
@@ -8645,7 +8645,7 @@
                   <a:srgbClr val="17212D"/>
                 </a:solidFill>
               </a:rPr>
-              <a:t>Beslis eerst: zaalwifi of mobiele data</a:t>
+              <a:t>Gebruik bij voorkeur mobiele data; houd zaalwifi klaar</a:t>
             </a:r>
           </a:p>
         </p:txBody>
@@ -8727,7 +8727,7 @@
                   <a:srgbClr val="17212D"/>
                 </a:solidFill>
               </a:rPr>
-              <a:t>• Vraag wifinaam en wachtwoord vooraf op</a:t>
+              <a:t>• Eigen mobiele data is meestal het gemakkelijkst</a:t>
             </a:r>
           </a:p>
           <a:p xmlns:a="http://schemas.openxmlformats.org/drawingml/2006/main">
@@ -8745,7 +8745,7 @@
                   <a:srgbClr val="17212D"/>
                 </a:solidFill>
               </a:rPr>
-              <a:t>• Geen wifi? Test het mobiele bereik in de zaal</a:t>
+              <a:t>• Bied gratis zaalwifi aan als keuze en reserve</a:t>
             </a:r>
           </a:p>
           <a:p xmlns:a="http://schemas.openxmlformats.org/drawingml/2006/main">
@@ -8763,7 +8763,7 @@
                   <a:srgbClr val="17212D"/>
                 </a:solidFill>
               </a:rPr>
-              <a:t>• Meld vooraf dat deelnemers internet nodig hebben</a:t>
+              <a:t>• Test vooraf in de zaal beide verbindingen</a:t>
             </a:r>
           </a:p>
         </p:txBody>
@@ -8880,7 +8880,7 @@
                   <a:srgbClr val="168044"/>
                 </a:solidFill>
               </a:rPr>
-              <a:t>Deze keuze bepaalt wat later op het briefje staat.</a:t>
+              <a:t>Slecht mobiel bereik? Adviseer duidelijk de zaalwifi op het briefje.</a:t>
             </a:r>
           </a:p>
         </p:txBody>
@@ -8929,7 +8929,7 @@
           <p:nvPr/>
         </p:nvPicPr>
         <p:blipFill>
-          <a:blip xmlns:r="http://schemas.openxmlformats.org/officeDocument/2006/relationships" xmlns:a="http://schemas.openxmlformats.org/drawingml/2006/main" r:embed="Rcb1fc955256c4523"/>
+          <a:blip xmlns:r="http://schemas.openxmlformats.org/officeDocument/2006/relationships" xmlns:a="http://schemas.openxmlformats.org/drawingml/2006/main" r:embed="Re435baf76c374be8"/>
           <a:stretch xmlns:a="http://schemas.openxmlformats.org/drawingml/2006/main"/>
         </p:blipFill>
         <p:spPr>
@@ -9536,7 +9536,7 @@
           <p:nvPr/>
         </p:nvPicPr>
         <p:blipFill>
-          <a:blip xmlns:r="http://schemas.openxmlformats.org/officeDocument/2006/relationships" xmlns:a="http://schemas.openxmlformats.org/drawingml/2006/main" r:embed="R8e2e564c0fb14855"/>
+          <a:blip xmlns:r="http://schemas.openxmlformats.org/officeDocument/2006/relationships" xmlns:a="http://schemas.openxmlformats.org/drawingml/2006/main" r:embed="R492e9a25a6f54fee"/>
           <a:stretch xmlns:a="http://schemas.openxmlformats.org/drawingml/2006/main"/>
         </p:blipFill>
         <p:spPr>
@@ -10143,7 +10143,7 @@
           <p:nvPr/>
         </p:nvPicPr>
         <p:blipFill>
-          <a:blip xmlns:r="http://schemas.openxmlformats.org/officeDocument/2006/relationships" xmlns:a="http://schemas.openxmlformats.org/drawingml/2006/main" r:embed="R547b9d3ada6c4dbd"/>
+          <a:blip xmlns:r="http://schemas.openxmlformats.org/officeDocument/2006/relationships" xmlns:a="http://schemas.openxmlformats.org/drawingml/2006/main" r:embed="Raf1afa87b6c84ff7"/>
           <a:stretch xmlns:a="http://schemas.openxmlformats.org/drawingml/2006/main"/>
         </p:blipFill>
         <p:spPr>
@@ -10750,7 +10750,7 @@
           <p:nvPr/>
         </p:nvPicPr>
         <p:blipFill>
-          <a:blip xmlns:r="http://schemas.openxmlformats.org/officeDocument/2006/relationships" xmlns:a="http://schemas.openxmlformats.org/drawingml/2006/main" r:embed="Ra9d3a16b37a9412a"/>
+          <a:blip xmlns:r="http://schemas.openxmlformats.org/officeDocument/2006/relationships" xmlns:a="http://schemas.openxmlformats.org/drawingml/2006/main" r:embed="Rb86ceedaf67e4d24"/>
           <a:stretch xmlns:a="http://schemas.openxmlformats.org/drawingml/2006/main"/>
         </p:blipFill>
         <p:spPr>
@@ -11357,7 +11357,7 @@
           <p:nvPr/>
         </p:nvPicPr>
         <p:blipFill>
-          <a:blip xmlns:r="http://schemas.openxmlformats.org/officeDocument/2006/relationships" xmlns:a="http://schemas.openxmlformats.org/drawingml/2006/main" r:embed="R7d99d06bb42242ae"/>
+          <a:blip xmlns:r="http://schemas.openxmlformats.org/officeDocument/2006/relationships" xmlns:a="http://schemas.openxmlformats.org/drawingml/2006/main" r:embed="R8094aa1b181f4dc5"/>
           <a:stretch xmlns:a="http://schemas.openxmlformats.org/drawingml/2006/main"/>
         </p:blipFill>
         <p:spPr>
@@ -11964,7 +11964,7 @@
           <p:nvPr/>
         </p:nvPicPr>
         <p:blipFill>
-          <a:blip xmlns:r="http://schemas.openxmlformats.org/officeDocument/2006/relationships" xmlns:a="http://schemas.openxmlformats.org/drawingml/2006/main" r:embed="R7fef84a4096c479a"/>
+          <a:blip xmlns:r="http://schemas.openxmlformats.org/officeDocument/2006/relationships" xmlns:a="http://schemas.openxmlformats.org/drawingml/2006/main" r:embed="Rae24d146dc0c4b04"/>
           <a:stretch xmlns:a="http://schemas.openxmlformats.org/drawingml/2006/main"/>
         </p:blipFill>
         <p:spPr>
@@ -12571,7 +12571,7 @@
           <p:nvPr/>
         </p:nvPicPr>
         <p:blipFill>
-          <a:blip xmlns:r="http://schemas.openxmlformats.org/officeDocument/2006/relationships" xmlns:a="http://schemas.openxmlformats.org/drawingml/2006/main" r:embed="R84b0558be7f841e6"/>
+          <a:blip xmlns:r="http://schemas.openxmlformats.org/officeDocument/2006/relationships" xmlns:a="http://schemas.openxmlformats.org/drawingml/2006/main" r:embed="R758a520d65b3468a"/>
           <a:stretch xmlns:a="http://schemas.openxmlformats.org/drawingml/2006/main"/>
         </p:blipFill>
         <p:spPr>

</xml_diff>

<commit_message>
Voeg online deelname toe aan videohandleiding
</commit_message>
<xml_diff>
--- a/video-handleiding/Live-Diabetes-Quiz-storyboard.pptx
+++ b/video-handleiding/Live-Diabetes-Quiz-storyboard.pptx
@@ -2,29 +2,29 @@
 <file path=ppt/presentation.xml><?xml version="1.0" encoding="utf-8"?>
 <p:presentation xmlns:p="http://schemas.openxmlformats.org/presentationml/2006/main">
   <p:sldMasterIdLst>
-    <p:sldMasterId xmlns:r="http://schemas.openxmlformats.org/officeDocument/2006/relationships" id="2147483648" r:id="R98579b2fc6564d4f"/>
+    <p:sldMasterId xmlns:r="http://schemas.openxmlformats.org/officeDocument/2006/relationships" id="2147483648" r:id="R9d4fc0fa05cb44f7"/>
   </p:sldMasterIdLst>
   <p:notesMasterIdLst>
-    <p:notesMasterId xmlns:r="http://schemas.openxmlformats.org/officeDocument/2006/relationships" r:id="R5c8a452ddf874720"/>
+    <p:notesMasterId xmlns:r="http://schemas.openxmlformats.org/officeDocument/2006/relationships" r:id="R0a7a5d0931894351"/>
   </p:notesMasterIdLst>
   <p:sldIdLst>
-    <p:sldId xmlns:r="http://schemas.openxmlformats.org/officeDocument/2006/relationships" id="256" r:id="R4ef73f7dfd04439b"/>
-    <p:sldId xmlns:r="http://schemas.openxmlformats.org/officeDocument/2006/relationships" id="257" r:id="R828844c7993644f0"/>
-    <p:sldId xmlns:r="http://schemas.openxmlformats.org/officeDocument/2006/relationships" id="258" r:id="R0168a7a0690b4636"/>
-    <p:sldId xmlns:r="http://schemas.openxmlformats.org/officeDocument/2006/relationships" id="259" r:id="R4e9e660fc0b64cb3"/>
-    <p:sldId xmlns:r="http://schemas.openxmlformats.org/officeDocument/2006/relationships" id="260" r:id="R6ac3d9c0847b426b"/>
-    <p:sldId xmlns:r="http://schemas.openxmlformats.org/officeDocument/2006/relationships" id="261" r:id="Ra6016b7b064a4e73"/>
-    <p:sldId xmlns:r="http://schemas.openxmlformats.org/officeDocument/2006/relationships" id="262" r:id="Rf045b5cae085432c"/>
-    <p:sldId xmlns:r="http://schemas.openxmlformats.org/officeDocument/2006/relationships" id="263" r:id="Ref3a30c8689643e9"/>
-    <p:sldId xmlns:r="http://schemas.openxmlformats.org/officeDocument/2006/relationships" id="264" r:id="R217ece9637a2421a"/>
-    <p:sldId xmlns:r="http://schemas.openxmlformats.org/officeDocument/2006/relationships" id="265" r:id="R60974b0dd85345b5"/>
-    <p:sldId xmlns:r="http://schemas.openxmlformats.org/officeDocument/2006/relationships" id="266" r:id="R9f4295f9f6d54920"/>
-    <p:sldId xmlns:r="http://schemas.openxmlformats.org/officeDocument/2006/relationships" id="267" r:id="Rf62a6e3411f54117"/>
-    <p:sldId xmlns:r="http://schemas.openxmlformats.org/officeDocument/2006/relationships" id="268" r:id="R4053c0b46b964923"/>
-    <p:sldId xmlns:r="http://schemas.openxmlformats.org/officeDocument/2006/relationships" id="269" r:id="R17de315d998e4684"/>
-    <p:sldId xmlns:r="http://schemas.openxmlformats.org/officeDocument/2006/relationships" id="270" r:id="R6b0addeb0c934164"/>
-    <p:sldId xmlns:r="http://schemas.openxmlformats.org/officeDocument/2006/relationships" id="271" r:id="R8abf7a48b9cd4f80"/>
-    <p:sldId xmlns:r="http://schemas.openxmlformats.org/officeDocument/2006/relationships" id="272" r:id="R0cb4f6aa4065404a"/>
+    <p:sldId xmlns:r="http://schemas.openxmlformats.org/officeDocument/2006/relationships" id="256" r:id="R6679f57be33f45a6"/>
+    <p:sldId xmlns:r="http://schemas.openxmlformats.org/officeDocument/2006/relationships" id="257" r:id="R21bc507cce354957"/>
+    <p:sldId xmlns:r="http://schemas.openxmlformats.org/officeDocument/2006/relationships" id="258" r:id="Rc39b012a7abc4be9"/>
+    <p:sldId xmlns:r="http://schemas.openxmlformats.org/officeDocument/2006/relationships" id="259" r:id="R5ed882d4abce4ad3"/>
+    <p:sldId xmlns:r="http://schemas.openxmlformats.org/officeDocument/2006/relationships" id="260" r:id="R8ba08eb7ec224a3f"/>
+    <p:sldId xmlns:r="http://schemas.openxmlformats.org/officeDocument/2006/relationships" id="261" r:id="Rb481b613c0574e31"/>
+    <p:sldId xmlns:r="http://schemas.openxmlformats.org/officeDocument/2006/relationships" id="262" r:id="Rc59416387df74188"/>
+    <p:sldId xmlns:r="http://schemas.openxmlformats.org/officeDocument/2006/relationships" id="263" r:id="Rea5afa2e6e894c65"/>
+    <p:sldId xmlns:r="http://schemas.openxmlformats.org/officeDocument/2006/relationships" id="264" r:id="R3cbe5425e92d4932"/>
+    <p:sldId xmlns:r="http://schemas.openxmlformats.org/officeDocument/2006/relationships" id="265" r:id="Rcba4146ae1ea4ca8"/>
+    <p:sldId xmlns:r="http://schemas.openxmlformats.org/officeDocument/2006/relationships" id="266" r:id="Rbc36678657e74152"/>
+    <p:sldId xmlns:r="http://schemas.openxmlformats.org/officeDocument/2006/relationships" id="267" r:id="R1c4aa216fbcb4171"/>
+    <p:sldId xmlns:r="http://schemas.openxmlformats.org/officeDocument/2006/relationships" id="268" r:id="Rfd99431beaaf4238"/>
+    <p:sldId xmlns:r="http://schemas.openxmlformats.org/officeDocument/2006/relationships" id="269" r:id="Ra272475756694539"/>
+    <p:sldId xmlns:r="http://schemas.openxmlformats.org/officeDocument/2006/relationships" id="270" r:id="Rde4fac0e493149d9"/>
+    <p:sldId xmlns:r="http://schemas.openxmlformats.org/officeDocument/2006/relationships" id="271" r:id="R4cb717e3b57a48b4"/>
+    <p:sldId xmlns:r="http://schemas.openxmlformats.org/officeDocument/2006/relationships" id="272" r:id="R3bb79c71218c4ee4"/>
   </p:sldIdLst>
   <p:sldSz cx="12192000" cy="6858000"/>
   <p:notesSz cx="6858000" cy="9144000"/>
@@ -1218,12 +1218,12 @@
           <a:lstStyle xmlns:a="http://schemas.openxmlformats.org/drawingml/2006/main"/>
           <a:p xmlns:a="http://schemas.openxmlformats.org/drawingml/2006/main">
             <a:r>
-              <a:t>DIA 17 — Na afloop: dezelfde groep of een nieuwe activiteit</a:t>
-            </a:r>
-          </a:p>
-          <a:p xmlns:a="http://schemas.openxmlformats.org/drawingml/2006/main">
-            <a:r>
-              <a:t>Duur: 45 seconden</a:t>
+              <a:t>DIA 17 — Na afloop: herhalen of zaal en online samenbrengen</a:t>
+            </a:r>
+          </a:p>
+          <a:p xmlns:a="http://schemas.openxmlformats.org/drawingml/2006/main">
+            <a:r>
+              <a:t>Duur: 65 seconden</a:t>
             </a:r>
           </a:p>
           <a:p xmlns:a="http://schemas.openxmlformats.org/drawingml/2006/main">
@@ -1233,7 +1233,7 @@
           </a:p>
           <a:p xmlns:a="http://schemas.openxmlformats.org/drawingml/2006/main">
             <a:r>
-              <a:t>Wilt u met dezelfde aanwezige groep nog een quiz spelen, kies dan Nieuwe sessie voorbereiden. De gsm’s en het zaalscherm kunnen die nieuwe sessie automatisch volgen zolang iedereen verbonden blijft; nieuwe briefjes zijn dan niet nodig. Voor een activiteit op een andere dag begint u opnieuw bij de thuisvoorbereiding: controleer de zaalverbinding, maak na een eventuele proef de definitieve sessie en druk de daarbij horende briefjes af. Zo blijft de werkwijze iedere keer dezelfde en overzichtelijk.</a:t>
+              <a:t>Wilt u met dezelfde aanwezige groep nog een quiz spelen, kies dan Nieuwe sessie voorbereiden. De gsm’s en het zaalscherm kunnen die nieuwe sessie automatisch volgen zolang iedereen verbonden blijft; nieuwe briefjes zijn dan niet nodig. Omdat de quiz volledig via internet werkt, kunnen ook mensen deelnemen die de voorafgaande infosessie online volgen. Deel vlak vóór de quiz de deelnemerslink en de driecijferige code via de online vergaderchat of stuur die informatie vooraf mee. De online deelnemer opent de quiz op een gsm, tablet of tweede browservenster en ziet daar dezelfde vragen en antwoorden. De quizmaster hoeft geen aparte sessie te maken: zaal- en online deelnemers verschijnen samen in de tellers voor verbonden deelnemers en ontvangen antwoorden. Zo kan de quiz een vaste gezamenlijke afsluiter worden na iedere infosessie. Voor een activiteit op een andere dag begint u opnieuw bij de thuisvoorbereiding en maakt u een nieuwe definitieve sessie met nieuwe briefjes.</a:t>
             </a:r>
           </a:p>
           <a:p xmlns:a="http://schemas.openxmlformats.org/drawingml/2006/main">
@@ -1243,7 +1243,7 @@
           </a:p>
           <a:p xmlns:a="http://schemas.openxmlformats.org/drawingml/2006/main">
             <a:r>
-              <a:t>Canva-aanwijzing: Toon twee routes: “dezelfde groep — geen nieuwe briefjes” en “nieuwe dag — opnieuw thuis voorbereiden”.</a:t>
+              <a:t>Canva-aanwijzing: Toon eerst “dezelfde groep — geen nieuwe briefjes”. Voeg daarna “zaal + online in dezelfde quiz” toe met één gedeelde teller. Eindig met “nieuwe dag — opnieuw thuis voorbereiden”.</a:t>
             </a:r>
           </a:p>
         </p:txBody>
@@ -2071,7 +2071,7 @@
   </p:cSld>
   <p:clrMap bg1="lt1" tx1="dk1" bg2="lt2" tx2="dk2" accent1="accent1" accent2="accent2" accent3="accent3" accent4="accent4" accent5="accent5" accent6="accent6" hlink="hlink" folHlink="folHlink"/>
   <p:sldLayoutIdLst>
-    <p:sldLayoutId xmlns:r="http://schemas.openxmlformats.org/officeDocument/2006/relationships" id="2147483649" r:id="Rfaa37bd060384da0"/>
+    <p:sldLayoutId xmlns:r="http://schemas.openxmlformats.org/officeDocument/2006/relationships" id="2147483649" r:id="R44f192e26c1c4321"/>
   </p:sldLayoutIdLst>
   <p:txStyles>
     <p:titleStyle>
@@ -2690,7 +2690,7 @@
           <p:nvPr/>
         </p:nvPicPr>
         <p:blipFill>
-          <a:blip xmlns:r="http://schemas.openxmlformats.org/officeDocument/2006/relationships" xmlns:a="http://schemas.openxmlformats.org/drawingml/2006/main" r:embed="R1f4929599dee4616"/>
+          <a:blip xmlns:r="http://schemas.openxmlformats.org/officeDocument/2006/relationships" xmlns:a="http://schemas.openxmlformats.org/drawingml/2006/main" r:embed="R487636f390fc4593"/>
           <a:stretch xmlns:a="http://schemas.openxmlformats.org/drawingml/2006/main"/>
         </p:blipFill>
         <p:spPr>
@@ -3403,7 +3403,7 @@
           <p:nvPr/>
         </p:nvPicPr>
         <p:blipFill>
-          <a:blip xmlns:r="http://schemas.openxmlformats.org/officeDocument/2006/relationships" xmlns:a="http://schemas.openxmlformats.org/drawingml/2006/main" r:embed="R4626ff42f4484cba"/>
+          <a:blip xmlns:r="http://schemas.openxmlformats.org/officeDocument/2006/relationships" xmlns:a="http://schemas.openxmlformats.org/drawingml/2006/main" r:embed="Re6e8aac3a6da44bc"/>
           <a:stretch xmlns:a="http://schemas.openxmlformats.org/drawingml/2006/main"/>
         </p:blipFill>
         <p:spPr>
@@ -4010,7 +4010,7 @@
           <p:nvPr/>
         </p:nvPicPr>
         <p:blipFill>
-          <a:blip xmlns:r="http://schemas.openxmlformats.org/officeDocument/2006/relationships" xmlns:a="http://schemas.openxmlformats.org/drawingml/2006/main" r:embed="R10764418a53e4a4d"/>
+          <a:blip xmlns:r="http://schemas.openxmlformats.org/officeDocument/2006/relationships" xmlns:a="http://schemas.openxmlformats.org/drawingml/2006/main" r:embed="Rdd80812efb4b483f"/>
           <a:stretch xmlns:a="http://schemas.openxmlformats.org/drawingml/2006/main"/>
         </p:blipFill>
         <p:spPr>
@@ -4617,7 +4617,7 @@
           <p:nvPr/>
         </p:nvPicPr>
         <p:blipFill>
-          <a:blip xmlns:r="http://schemas.openxmlformats.org/officeDocument/2006/relationships" xmlns:a="http://schemas.openxmlformats.org/drawingml/2006/main" r:embed="R59f591f7beea4a59"/>
+          <a:blip xmlns:r="http://schemas.openxmlformats.org/officeDocument/2006/relationships" xmlns:a="http://schemas.openxmlformats.org/drawingml/2006/main" r:embed="Rb900b415c9a747e7"/>
           <a:stretch xmlns:a="http://schemas.openxmlformats.org/drawingml/2006/main"/>
         </p:blipFill>
         <p:spPr>
@@ -5224,7 +5224,7 @@
           <p:nvPr/>
         </p:nvPicPr>
         <p:blipFill>
-          <a:blip xmlns:r="http://schemas.openxmlformats.org/officeDocument/2006/relationships" xmlns:a="http://schemas.openxmlformats.org/drawingml/2006/main" r:embed="Rcc70975d84dc49a8"/>
+          <a:blip xmlns:r="http://schemas.openxmlformats.org/officeDocument/2006/relationships" xmlns:a="http://schemas.openxmlformats.org/drawingml/2006/main" r:embed="Ra9c9fb39aff2459b"/>
           <a:stretch xmlns:a="http://schemas.openxmlformats.org/drawingml/2006/main"/>
         </p:blipFill>
         <p:spPr>
@@ -5831,7 +5831,7 @@
           <p:nvPr/>
         </p:nvPicPr>
         <p:blipFill>
-          <a:blip xmlns:r="http://schemas.openxmlformats.org/officeDocument/2006/relationships" xmlns:a="http://schemas.openxmlformats.org/drawingml/2006/main" r:embed="R57aa18c8b00f4774"/>
+          <a:blip xmlns:r="http://schemas.openxmlformats.org/officeDocument/2006/relationships" xmlns:a="http://schemas.openxmlformats.org/drawingml/2006/main" r:embed="R5153dbcebb8a41c0"/>
           <a:stretch xmlns:a="http://schemas.openxmlformats.org/drawingml/2006/main"/>
         </p:blipFill>
         <p:spPr>
@@ -6438,7 +6438,7 @@
           <p:nvPr/>
         </p:nvPicPr>
         <p:blipFill>
-          <a:blip xmlns:r="http://schemas.openxmlformats.org/officeDocument/2006/relationships" xmlns:a="http://schemas.openxmlformats.org/drawingml/2006/main" r:embed="R14248b6fa6e144fd"/>
+          <a:blip xmlns:r="http://schemas.openxmlformats.org/officeDocument/2006/relationships" xmlns:a="http://schemas.openxmlformats.org/drawingml/2006/main" r:embed="Rabf601b5514748ed"/>
           <a:stretch xmlns:a="http://schemas.openxmlformats.org/drawingml/2006/main"/>
         </p:blipFill>
         <p:spPr>
@@ -7045,7 +7045,7 @@
           <p:nvPr/>
         </p:nvPicPr>
         <p:blipFill>
-          <a:blip xmlns:r="http://schemas.openxmlformats.org/officeDocument/2006/relationships" xmlns:a="http://schemas.openxmlformats.org/drawingml/2006/main" r:embed="R41efd44222614fff"/>
+          <a:blip xmlns:r="http://schemas.openxmlformats.org/officeDocument/2006/relationships" xmlns:a="http://schemas.openxmlformats.org/drawingml/2006/main" r:embed="R9da353e6a0b74497"/>
           <a:stretch xmlns:a="http://schemas.openxmlformats.org/drawingml/2006/main"/>
         </p:blipFill>
         <p:spPr>
@@ -7104,7 +7104,7 @@
           <p:nvPr/>
         </p:nvPicPr>
         <p:blipFill>
-          <a:blip xmlns:r="http://schemas.openxmlformats.org/officeDocument/2006/relationships" xmlns:a="http://schemas.openxmlformats.org/drawingml/2006/main" r:embed="Ra38db92191794243"/>
+          <a:blip xmlns:r="http://schemas.openxmlformats.org/officeDocument/2006/relationships" xmlns:a="http://schemas.openxmlformats.org/drawingml/2006/main" r:embed="R40770438d39c423d"/>
           <a:stretch xmlns:a="http://schemas.openxmlformats.org/drawingml/2006/main"/>
         </p:blipFill>
         <p:spPr>
@@ -7378,7 +7378,7 @@
                   <a:srgbClr val="075678"/>
                 </a:solidFill>
               </a:rPr>
-              <a:t>NA AFLOOP</a:t>
+              <a:t>NA AFLOOP · OOK ONLINE</a:t>
             </a:r>
           </a:p>
         </p:txBody>
@@ -7429,7 +7429,7 @@
                   <a:srgbClr val="17212D"/>
                 </a:solidFill>
               </a:rPr>
-              <a:t>Dezelfde groep of een volledig nieuwe activiteit</a:t>
+              <a:t>Ook online volgers kunnen tegelijk deelnemen</a:t>
             </a:r>
           </a:p>
         </p:txBody>
@@ -7511,7 +7511,7 @@
                   <a:srgbClr val="17212D"/>
                 </a:solidFill>
               </a:rPr>
-              <a:t>• Dezelfde groep: gsm’s kunnen verbonden blijven</a:t>
+              <a:t>• Dezelfde groep: gsm’s blijven verbonden</a:t>
             </a:r>
           </a:p>
           <a:p xmlns:a="http://schemas.openxmlformats.org/drawingml/2006/main">
@@ -7529,7 +7529,7 @@
                   <a:srgbClr val="17212D"/>
                 </a:solidFill>
               </a:rPr>
-              <a:t>• Nieuwe dag: thuis een nieuwe sessie maken</a:t>
+              <a:t>• Online volgers: deel link en code via de chat</a:t>
             </a:r>
           </a:p>
           <a:p xmlns:a="http://schemas.openxmlformats.org/drawingml/2006/main">
@@ -7547,7 +7547,7 @@
                   <a:srgbClr val="17212D"/>
                 </a:solidFill>
               </a:rPr>
-              <a:t>• Bij een nieuwe code horen nieuwe briefjes</a:t>
+              <a:t>• Nieuwe dag: nieuwe sessie en nieuwe briefjes</a:t>
             </a:r>
           </a:p>
         </p:txBody>
@@ -7664,7 +7664,7 @@
                   <a:srgbClr val="168044"/>
                 </a:solidFill>
               </a:rPr>
-              <a:t>Volg bij iedere nieuwe activiteit opnieuw dezelfde tijdlijn.</a:t>
+              <a:t>Zaal- en online deelnemers spelen mee in dezelfde quiz en tellers.</a:t>
             </a:r>
           </a:p>
         </p:txBody>
@@ -7713,7 +7713,7 @@
           <p:nvPr/>
         </p:nvPicPr>
         <p:blipFill>
-          <a:blip xmlns:r="http://schemas.openxmlformats.org/officeDocument/2006/relationships" xmlns:a="http://schemas.openxmlformats.org/drawingml/2006/main" r:embed="Rbb3a55755b01490e"/>
+          <a:blip xmlns:r="http://schemas.openxmlformats.org/officeDocument/2006/relationships" xmlns:a="http://schemas.openxmlformats.org/drawingml/2006/main" r:embed="R248810e909994356"/>
           <a:stretch xmlns:a="http://schemas.openxmlformats.org/drawingml/2006/main"/>
         </p:blipFill>
         <p:spPr>
@@ -8320,7 +8320,7 @@
           <p:nvPr/>
         </p:nvPicPr>
         <p:blipFill>
-          <a:blip xmlns:r="http://schemas.openxmlformats.org/officeDocument/2006/relationships" xmlns:a="http://schemas.openxmlformats.org/drawingml/2006/main" r:embed="Rfb1a5e6494e24b55"/>
+          <a:blip xmlns:r="http://schemas.openxmlformats.org/officeDocument/2006/relationships" xmlns:a="http://schemas.openxmlformats.org/drawingml/2006/main" r:embed="R97720649de5b447a"/>
           <a:stretch xmlns:a="http://schemas.openxmlformats.org/drawingml/2006/main"/>
         </p:blipFill>
         <p:spPr>
@@ -8929,7 +8929,7 @@
           <p:nvPr/>
         </p:nvPicPr>
         <p:blipFill>
-          <a:blip xmlns:r="http://schemas.openxmlformats.org/officeDocument/2006/relationships" xmlns:a="http://schemas.openxmlformats.org/drawingml/2006/main" r:embed="Re435baf76c374be8"/>
+          <a:blip xmlns:r="http://schemas.openxmlformats.org/officeDocument/2006/relationships" xmlns:a="http://schemas.openxmlformats.org/drawingml/2006/main" r:embed="R8f264e1f19c041b5"/>
           <a:stretch xmlns:a="http://schemas.openxmlformats.org/drawingml/2006/main"/>
         </p:blipFill>
         <p:spPr>
@@ -9536,7 +9536,7 @@
           <p:nvPr/>
         </p:nvPicPr>
         <p:blipFill>
-          <a:blip xmlns:r="http://schemas.openxmlformats.org/officeDocument/2006/relationships" xmlns:a="http://schemas.openxmlformats.org/drawingml/2006/main" r:embed="R492e9a25a6f54fee"/>
+          <a:blip xmlns:r="http://schemas.openxmlformats.org/officeDocument/2006/relationships" xmlns:a="http://schemas.openxmlformats.org/drawingml/2006/main" r:embed="R0cae6bcd03914ddd"/>
           <a:stretch xmlns:a="http://schemas.openxmlformats.org/drawingml/2006/main"/>
         </p:blipFill>
         <p:spPr>
@@ -10143,7 +10143,7 @@
           <p:nvPr/>
         </p:nvPicPr>
         <p:blipFill>
-          <a:blip xmlns:r="http://schemas.openxmlformats.org/officeDocument/2006/relationships" xmlns:a="http://schemas.openxmlformats.org/drawingml/2006/main" r:embed="Raf1afa87b6c84ff7"/>
+          <a:blip xmlns:r="http://schemas.openxmlformats.org/officeDocument/2006/relationships" xmlns:a="http://schemas.openxmlformats.org/drawingml/2006/main" r:embed="R5ec43c2adafb4076"/>
           <a:stretch xmlns:a="http://schemas.openxmlformats.org/drawingml/2006/main"/>
         </p:blipFill>
         <p:spPr>
@@ -10750,7 +10750,7 @@
           <p:nvPr/>
         </p:nvPicPr>
         <p:blipFill>
-          <a:blip xmlns:r="http://schemas.openxmlformats.org/officeDocument/2006/relationships" xmlns:a="http://schemas.openxmlformats.org/drawingml/2006/main" r:embed="Rb86ceedaf67e4d24"/>
+          <a:blip xmlns:r="http://schemas.openxmlformats.org/officeDocument/2006/relationships" xmlns:a="http://schemas.openxmlformats.org/drawingml/2006/main" r:embed="Rbfe6dfb33606455d"/>
           <a:stretch xmlns:a="http://schemas.openxmlformats.org/drawingml/2006/main"/>
         </p:blipFill>
         <p:spPr>
@@ -11357,7 +11357,7 @@
           <p:nvPr/>
         </p:nvPicPr>
         <p:blipFill>
-          <a:blip xmlns:r="http://schemas.openxmlformats.org/officeDocument/2006/relationships" xmlns:a="http://schemas.openxmlformats.org/drawingml/2006/main" r:embed="R8094aa1b181f4dc5"/>
+          <a:blip xmlns:r="http://schemas.openxmlformats.org/officeDocument/2006/relationships" xmlns:a="http://schemas.openxmlformats.org/drawingml/2006/main" r:embed="Rb5433dbc9ef2416b"/>
           <a:stretch xmlns:a="http://schemas.openxmlformats.org/drawingml/2006/main"/>
         </p:blipFill>
         <p:spPr>
@@ -11964,7 +11964,7 @@
           <p:nvPr/>
         </p:nvPicPr>
         <p:blipFill>
-          <a:blip xmlns:r="http://schemas.openxmlformats.org/officeDocument/2006/relationships" xmlns:a="http://schemas.openxmlformats.org/drawingml/2006/main" r:embed="Rae24d146dc0c4b04"/>
+          <a:blip xmlns:r="http://schemas.openxmlformats.org/officeDocument/2006/relationships" xmlns:a="http://schemas.openxmlformats.org/drawingml/2006/main" r:embed="R04dbfb6a7be74c6f"/>
           <a:stretch xmlns:a="http://schemas.openxmlformats.org/drawingml/2006/main"/>
         </p:blipFill>
         <p:spPr>
@@ -12571,7 +12571,7 @@
           <p:nvPr/>
         </p:nvPicPr>
         <p:blipFill>
-          <a:blip xmlns:r="http://schemas.openxmlformats.org/officeDocument/2006/relationships" xmlns:a="http://schemas.openxmlformats.org/drawingml/2006/main" r:embed="R758a520d65b3468a"/>
+          <a:blip xmlns:r="http://schemas.openxmlformats.org/officeDocument/2006/relationships" xmlns:a="http://schemas.openxmlformats.org/drawingml/2006/main" r:embed="Re3122906ed6c43b1"/>
           <a:stretch xmlns:a="http://schemas.openxmlformats.org/drawingml/2006/main"/>
         </p:blipFill>
         <p:spPr>

</xml_diff>

<commit_message>
Verduidelijk proefquiz en technische zaalcontrole
</commit_message>
<xml_diff>
--- a/video-handleiding/Live-Diabetes-Quiz-storyboard.pptx
+++ b/video-handleiding/Live-Diabetes-Quiz-storyboard.pptx
@@ -2,29 +2,29 @@
 <file path=ppt/presentation.xml><?xml version="1.0" encoding="utf-8"?>
 <p:presentation xmlns:p="http://schemas.openxmlformats.org/presentationml/2006/main">
   <p:sldMasterIdLst>
-    <p:sldMasterId xmlns:r="http://schemas.openxmlformats.org/officeDocument/2006/relationships" id="2147483648" r:id="R9d4fc0fa05cb44f7"/>
+    <p:sldMasterId xmlns:r="http://schemas.openxmlformats.org/officeDocument/2006/relationships" id="2147483648" r:id="R7920d49001ff4ff7"/>
   </p:sldMasterIdLst>
   <p:notesMasterIdLst>
-    <p:notesMasterId xmlns:r="http://schemas.openxmlformats.org/officeDocument/2006/relationships" r:id="R0a7a5d0931894351"/>
+    <p:notesMasterId xmlns:r="http://schemas.openxmlformats.org/officeDocument/2006/relationships" r:id="R1ae549f3e8dc4c54"/>
   </p:notesMasterIdLst>
   <p:sldIdLst>
-    <p:sldId xmlns:r="http://schemas.openxmlformats.org/officeDocument/2006/relationships" id="256" r:id="R6679f57be33f45a6"/>
-    <p:sldId xmlns:r="http://schemas.openxmlformats.org/officeDocument/2006/relationships" id="257" r:id="R21bc507cce354957"/>
-    <p:sldId xmlns:r="http://schemas.openxmlformats.org/officeDocument/2006/relationships" id="258" r:id="Rc39b012a7abc4be9"/>
-    <p:sldId xmlns:r="http://schemas.openxmlformats.org/officeDocument/2006/relationships" id="259" r:id="R5ed882d4abce4ad3"/>
-    <p:sldId xmlns:r="http://schemas.openxmlformats.org/officeDocument/2006/relationships" id="260" r:id="R8ba08eb7ec224a3f"/>
-    <p:sldId xmlns:r="http://schemas.openxmlformats.org/officeDocument/2006/relationships" id="261" r:id="Rb481b613c0574e31"/>
-    <p:sldId xmlns:r="http://schemas.openxmlformats.org/officeDocument/2006/relationships" id="262" r:id="Rc59416387df74188"/>
-    <p:sldId xmlns:r="http://schemas.openxmlformats.org/officeDocument/2006/relationships" id="263" r:id="Rea5afa2e6e894c65"/>
-    <p:sldId xmlns:r="http://schemas.openxmlformats.org/officeDocument/2006/relationships" id="264" r:id="R3cbe5425e92d4932"/>
-    <p:sldId xmlns:r="http://schemas.openxmlformats.org/officeDocument/2006/relationships" id="265" r:id="Rcba4146ae1ea4ca8"/>
-    <p:sldId xmlns:r="http://schemas.openxmlformats.org/officeDocument/2006/relationships" id="266" r:id="Rbc36678657e74152"/>
-    <p:sldId xmlns:r="http://schemas.openxmlformats.org/officeDocument/2006/relationships" id="267" r:id="R1c4aa216fbcb4171"/>
-    <p:sldId xmlns:r="http://schemas.openxmlformats.org/officeDocument/2006/relationships" id="268" r:id="Rfd99431beaaf4238"/>
-    <p:sldId xmlns:r="http://schemas.openxmlformats.org/officeDocument/2006/relationships" id="269" r:id="Ra272475756694539"/>
-    <p:sldId xmlns:r="http://schemas.openxmlformats.org/officeDocument/2006/relationships" id="270" r:id="Rde4fac0e493149d9"/>
-    <p:sldId xmlns:r="http://schemas.openxmlformats.org/officeDocument/2006/relationships" id="271" r:id="R4cb717e3b57a48b4"/>
-    <p:sldId xmlns:r="http://schemas.openxmlformats.org/officeDocument/2006/relationships" id="272" r:id="R3bb79c71218c4ee4"/>
+    <p:sldId xmlns:r="http://schemas.openxmlformats.org/officeDocument/2006/relationships" id="256" r:id="R154543e8109041ca"/>
+    <p:sldId xmlns:r="http://schemas.openxmlformats.org/officeDocument/2006/relationships" id="257" r:id="Re7c8fb88879e4eb6"/>
+    <p:sldId xmlns:r="http://schemas.openxmlformats.org/officeDocument/2006/relationships" id="258" r:id="Raedbb410f4a84a53"/>
+    <p:sldId xmlns:r="http://schemas.openxmlformats.org/officeDocument/2006/relationships" id="259" r:id="Rec0033fbd22343d5"/>
+    <p:sldId xmlns:r="http://schemas.openxmlformats.org/officeDocument/2006/relationships" id="260" r:id="Rcf9f8e54c6714930"/>
+    <p:sldId xmlns:r="http://schemas.openxmlformats.org/officeDocument/2006/relationships" id="261" r:id="R8bd9f978f9f74d28"/>
+    <p:sldId xmlns:r="http://schemas.openxmlformats.org/officeDocument/2006/relationships" id="262" r:id="R74b3cd7428bd45d4"/>
+    <p:sldId xmlns:r="http://schemas.openxmlformats.org/officeDocument/2006/relationships" id="263" r:id="R09b96fe0bc754742"/>
+    <p:sldId xmlns:r="http://schemas.openxmlformats.org/officeDocument/2006/relationships" id="264" r:id="Rdb1a6ba1518441ef"/>
+    <p:sldId xmlns:r="http://schemas.openxmlformats.org/officeDocument/2006/relationships" id="265" r:id="Rcd0463dc472f41e2"/>
+    <p:sldId xmlns:r="http://schemas.openxmlformats.org/officeDocument/2006/relationships" id="266" r:id="Rd0a2b5b8c3c44ae9"/>
+    <p:sldId xmlns:r="http://schemas.openxmlformats.org/officeDocument/2006/relationships" id="267" r:id="R94fb47c1c6774775"/>
+    <p:sldId xmlns:r="http://schemas.openxmlformats.org/officeDocument/2006/relationships" id="268" r:id="R616c6772796e4b8b"/>
+    <p:sldId xmlns:r="http://schemas.openxmlformats.org/officeDocument/2006/relationships" id="269" r:id="Rff8ee698940f4d82"/>
+    <p:sldId xmlns:r="http://schemas.openxmlformats.org/officeDocument/2006/relationships" id="270" r:id="R71e8367cef2d46f2"/>
+    <p:sldId xmlns:r="http://schemas.openxmlformats.org/officeDocument/2006/relationships" id="271" r:id="R3865decdb8004190"/>
+    <p:sldId xmlns:r="http://schemas.openxmlformats.org/officeDocument/2006/relationships" id="272" r:id="R2afe408c205b4a32"/>
   </p:sldIdLst>
   <p:sldSz cx="12192000" cy="6858000"/>
   <p:notesSz cx="6858000" cy="9144000"/>
@@ -648,12 +648,12 @@
           <a:lstStyle xmlns:a="http://schemas.openxmlformats.org/drawingml/2006/main"/>
           <a:p xmlns:a="http://schemas.openxmlformats.org/drawingml/2006/main">
             <a:r>
-              <a:t>DIA 11 — In de zaal: test alleen tot aan de wachtkamer</a:t>
-            </a:r>
-          </a:p>
-          <a:p xmlns:a="http://schemas.openxmlformats.org/drawingml/2006/main">
-            <a:r>
-              <a:t>Duur: 45 seconden</a:t>
+              <a:t>DIA 11 — In de zaal: alleen technisch controleren, geen vragen starten</a:t>
+            </a:r>
+          </a:p>
+          <a:p xmlns:a="http://schemas.openxmlformats.org/drawingml/2006/main">
+            <a:r>
+              <a:t>Duur: 50 seconden</a:t>
             </a:r>
           </a:p>
           <a:p xmlns:a="http://schemas.openxmlformats.org/drawingml/2006/main">
@@ -663,7 +663,7 @@
           </a:p>
           <a:p xmlns:a="http://schemas.openxmlformats.org/drawingml/2006/main">
             <a:r>
-              <a:t>Neem één reservebriefje en scan het met uw eigen gsm. Maak verbinding zoals een deelnemer en controleer of de wachtkamer met U bent verbonden verschijnt. Kijk daarna of de teller op de laptop en het zaalscherm met één deelnemer stijgt. Start de definitieve quiz nog niet als proef. Een volledige proefquiz is thuis al met de tijdelijke sessie uitgevoerd. Nu controleert u alleen de echte toegang, de verbinding en de projectie.</a:t>
+              <a:t>Neem één reservebriefje en scan het met uw eigen gsm. Controleer of de juiste definitieve code opent, of de wachtkamer met U bent verbonden verschijnt en of de deelnemersteller op de laptop en het zaalscherm met één stijgt. Kijk ook of de projectie goed leesbaar is. Stop de controle daar: start geen enkele quizvraag. De volledige proefquiz werd thuis of op kantoor met een tijdelijke sessie uitgevoerd. De sessie die nu openstaat is de definitieve zaalquiz waarvan de code op alle afgedrukte briefjes staat. Die wordt pas gestart wanneer de deelnemers aanwezig en verbonden zijn.</a:t>
             </a:r>
           </a:p>
           <a:p xmlns:a="http://schemas.openxmlformats.org/drawingml/2006/main">
@@ -673,7 +673,7 @@
           </a:p>
           <a:p xmlns:a="http://schemas.openxmlformats.org/drawingml/2006/main">
             <a:r>
-              <a:t>Canva-aanwijzing: Toon de scan, de wachtkamer en teller één. Plaats een duidelijk stopsymbool bij “quiz nog niet starten”.</a:t>
+              <a:t>Canva-aanwijzing: Toon codecontrole, wachtkamer, teller één en leesbare projectie. Plaats daarna een duidelijk stopsymbool bij “geen vragen starten”.</a:t>
             </a:r>
           </a:p>
         </p:txBody>
@@ -1503,12 +1503,12 @@
           <a:lstStyle xmlns:a="http://schemas.openxmlformats.org/drawingml/2006/main"/>
           <a:p xmlns:a="http://schemas.openxmlformats.org/drawingml/2006/main">
             <a:r>
-              <a:t>DIA 4 — Thuis: oefen vóór u de definitieve sessie maakt</a:t>
-            </a:r>
-          </a:p>
-          <a:p xmlns:a="http://schemas.openxmlformats.org/drawingml/2006/main">
-            <a:r>
-              <a:t>Duur: 45 seconden</a:t>
+              <a:t>DIA 4 — Thuis of op kantoor: voer eerst de volledige proefquiz uit</a:t>
+            </a:r>
+          </a:p>
+          <a:p xmlns:a="http://schemas.openxmlformats.org/drawingml/2006/main">
+            <a:r>
+              <a:t>Duur: 50 seconden</a:t>
             </a:r>
           </a:p>
           <a:p xmlns:a="http://schemas.openxmlformats.org/drawingml/2006/main">
@@ -1518,7 +1518,7 @@
           </a:p>
           <a:p xmlns:a="http://schemas.openxmlformats.org/drawingml/2006/main">
             <a:r>
-              <a:t>Wilt u de volledige werking vooraf testen, doe dat dan nu met een tijdelijke sessie van vijf vragen en bijvoorbeeld enkele bestuursleden. Doorloop samen de wachtkamer, een paar vragen, de antwoordtellers en de eindanalyse. Maak na deze oefening pas de definitieve sessie voor de zaal. Dat is belangrijk: iedere nieuwe sessie krijgt een nieuwe quizcode. Briefjes die al gedrukt zijn voor een oude of tijdelijke sessie zouden daardoor niet meer bij de definitieve quiz passen.</a:t>
+              <a:t>Wilt u de volledige werking testen, doe dat dan thuis of op kantoor, vóór u de definitieve sessie maakt en vóór u deelnemersbriefjes afdrukt. Maak een tijdelijke sessie van vijf vragen en oefen bijvoorbeeld met enkele bestuursleden. Doorloop de wachtkamer, de vragen, de antwoordtellers, de oplossingen en de eindanalyse. Dit is de volledige functionele proefquiz. Rond deze tijdelijke proef af. Maak pas daarna de definitieve sessie voor de echte zaalactiviteit. Iedere nieuwe sessie krijgt namelijk een andere quizcode; daarom mogen er voor de tijdelijke proef nog geen definitieve briefjes worden afgedrukt.</a:t>
             </a:r>
           </a:p>
           <a:p xmlns:a="http://schemas.openxmlformats.org/drawingml/2006/main">
@@ -1528,7 +1528,7 @@
           </a:p>
           <a:p xmlns:a="http://schemas.openxmlformats.org/drawingml/2006/main">
             <a:r>
-              <a:t>Canva-aanwijzing: Toon “5 vragen — demonstratie”, daarna “proef afronden” en pas dan “definitieve sessie”.</a:t>
+              <a:t>Canva-aanwijzing: Toon duidelijk “thuis of kantoor”, vervolgens “tijdelijke proef — 5 vragen”, “volledig doorlopen” en pas daarna “definitieve sessie”.</a:t>
             </a:r>
           </a:p>
         </p:txBody>
@@ -1598,12 +1598,12 @@
           <a:lstStyle xmlns:a="http://schemas.openxmlformats.org/drawingml/2006/main"/>
           <a:p xmlns:a="http://schemas.openxmlformats.org/drawingml/2006/main">
             <a:r>
-              <a:t>DIA 5 — Thuis: maak de definitieve quizsessie</a:t>
-            </a:r>
-          </a:p>
-          <a:p xmlns:a="http://schemas.openxmlformats.org/drawingml/2006/main">
-            <a:r>
-              <a:t>Duur: 45 seconden</a:t>
+              <a:t>DIA 5 — Na de proef: maak de definitieve quizsessie en code</a:t>
+            </a:r>
+          </a:p>
+          <a:p xmlns:a="http://schemas.openxmlformats.org/drawingml/2006/main">
+            <a:r>
+              <a:t>Duur: 50 seconden</a:t>
             </a:r>
           </a:p>
           <a:p xmlns:a="http://schemas.openxmlformats.org/drawingml/2006/main">
@@ -1613,7 +1613,7 @@
           </a:p>
           <a:p xmlns:a="http://schemas.openxmlformats.org/drawingml/2006/main">
             <a:r>
-              <a:t>Gebruik de laptop en de gewone browser die u later in de zaal meeneemt. Open Nieuwe quiz starten en kies het gewenste aantal vragen. Tien vragen is aanbevolen voor een gewone activiteit en twintig is het aanbevolen maximum. Klik daarna op Nieuwe quizsessie maken. Nu ontstaat de definitieve driecijferige quizcode. Wis vanaf dit moment geen browsergegevens en maak niet nogmaals een nieuwe sessie. Anders verandert de code en kloppen de briefjes niet meer.</a:t>
+              <a:t>Is de volledige proefquiz afgerond en werkt alles zoals verwacht, maak dan op de laptop en in de gewone browser die later meegaan de definitieve zaalquiz. Kies het gewenste aantal vragen. Tien vragen is aanbevolen voor een gewone activiteit en twintig is het aanbevolen maximum. Klik op Nieuwe quizsessie maken. Nu ontstaat de definitieve driecijferige code die straks op alle deelnemersbriefjes komt. Vanaf dit moment maakt u geen nieuwe sessie meer en wist u geen browsergegevens. Anders verandert de code en komen de vooraf afgedrukte briefjes niet meer overeen met de zaalquiz.</a:t>
             </a:r>
           </a:p>
           <a:p xmlns:a="http://schemas.openxmlformats.org/drawingml/2006/main">
@@ -1623,7 +1623,7 @@
           </a:p>
           <a:p xmlns:a="http://schemas.openxmlformats.org/drawingml/2006/main">
             <a:r>
-              <a:t>Canva-aanwijzing: Markeer de keuzelijst, daarna Nieuwe quizsessie maken en ten slotte de driecijferige code.</a:t>
+              <a:t>Canva-aanwijzing: Begin met “proef geslaagd”, markeer daarna de keuzelijst, Nieuwe quizsessie maken en ten slotte “definitieve code voor de briefjes”.</a:t>
             </a:r>
           </a:p>
         </p:txBody>
@@ -2071,7 +2071,7 @@
   </p:cSld>
   <p:clrMap bg1="lt1" tx1="dk1" bg2="lt2" tx2="dk2" accent1="accent1" accent2="accent2" accent3="accent3" accent4="accent4" accent5="accent5" accent6="accent6" hlink="hlink" folHlink="folHlink"/>
   <p:sldLayoutIdLst>
-    <p:sldLayoutId xmlns:r="http://schemas.openxmlformats.org/officeDocument/2006/relationships" id="2147483649" r:id="R44f192e26c1c4321"/>
+    <p:sldLayoutId xmlns:r="http://schemas.openxmlformats.org/officeDocument/2006/relationships" id="2147483649" r:id="R194cbd28c0c94f46"/>
   </p:sldLayoutIdLst>
   <p:txStyles>
     <p:titleStyle>
@@ -2690,7 +2690,7 @@
           <p:nvPr/>
         </p:nvPicPr>
         <p:blipFill>
-          <a:blip xmlns:r="http://schemas.openxmlformats.org/officeDocument/2006/relationships" xmlns:a="http://schemas.openxmlformats.org/drawingml/2006/main" r:embed="R487636f390fc4593"/>
+          <a:blip xmlns:r="http://schemas.openxmlformats.org/officeDocument/2006/relationships" xmlns:a="http://schemas.openxmlformats.org/drawingml/2006/main" r:embed="R649acbbaf6cb4b3f"/>
           <a:stretch xmlns:a="http://schemas.openxmlformats.org/drawingml/2006/main"/>
         </p:blipFill>
         <p:spPr>
@@ -3403,7 +3403,7 @@
           <p:nvPr/>
         </p:nvPicPr>
         <p:blipFill>
-          <a:blip xmlns:r="http://schemas.openxmlformats.org/officeDocument/2006/relationships" xmlns:a="http://schemas.openxmlformats.org/drawingml/2006/main" r:embed="Re6e8aac3a6da44bc"/>
+          <a:blip xmlns:r="http://schemas.openxmlformats.org/officeDocument/2006/relationships" xmlns:a="http://schemas.openxmlformats.org/drawingml/2006/main" r:embed="R42d036dd05584c59"/>
           <a:stretch xmlns:a="http://schemas.openxmlformats.org/drawingml/2006/main"/>
         </p:blipFill>
         <p:spPr>
@@ -3675,7 +3675,7 @@
                   <a:srgbClr val="075678"/>
                 </a:solidFill>
               </a:rPr>
-              <a:t>FASE 2 · LAATSTE CONTROLE</a:t>
+              <a:t>FASE 2 · TECHNISCHE ZAALCONTROLE</a:t>
             </a:r>
           </a:p>
         </p:txBody>
@@ -3726,7 +3726,7 @@
                   <a:srgbClr val="17212D"/>
                 </a:solidFill>
               </a:rPr>
-              <a:t>Test alleen de toegang tot de wachtkamer</a:t>
+              <a:t>Controleer de wachtkamer, maar start geen vragen</a:t>
             </a:r>
           </a:p>
         </p:txBody>
@@ -3808,7 +3808,7 @@
                   <a:srgbClr val="17212D"/>
                 </a:solidFill>
               </a:rPr>
-              <a:t>• Scan één echt reservebriefje</a:t>
+              <a:t>• Scan één definitief reservebriefje</a:t>
             </a:r>
           </a:p>
           <a:p xmlns:a="http://schemas.openxmlformats.org/drawingml/2006/main">
@@ -3826,7 +3826,7 @@
                   <a:srgbClr val="17212D"/>
                 </a:solidFill>
               </a:rPr>
-              <a:t>• Controleer “U bent verbonden”</a:t>
+              <a:t>• Controleer wachtkamer, teller en projectie</a:t>
             </a:r>
           </a:p>
           <a:p xmlns:a="http://schemas.openxmlformats.org/drawingml/2006/main">
@@ -3844,7 +3844,7 @@
                   <a:srgbClr val="17212D"/>
                 </a:solidFill>
               </a:rPr>
-              <a:t>• Kijk of de deelnemersteller stijgt</a:t>
+              <a:t>• Stop vóór de eerste quizvraag</a:t>
             </a:r>
           </a:p>
         </p:txBody>
@@ -3961,7 +3961,7 @@
                   <a:srgbClr val="168044"/>
                 </a:solidFill>
               </a:rPr>
-              <a:t>Start de definitieve quiz nu nog niet als proef.</a:t>
+              <a:t>De definitieve zaalquiz start pas wanneer het publiek klaarzit.</a:t>
             </a:r>
           </a:p>
         </p:txBody>
@@ -4010,7 +4010,7 @@
           <p:nvPr/>
         </p:nvPicPr>
         <p:blipFill>
-          <a:blip xmlns:r="http://schemas.openxmlformats.org/officeDocument/2006/relationships" xmlns:a="http://schemas.openxmlformats.org/drawingml/2006/main" r:embed="Rdd80812efb4b483f"/>
+          <a:blip xmlns:r="http://schemas.openxmlformats.org/officeDocument/2006/relationships" xmlns:a="http://schemas.openxmlformats.org/drawingml/2006/main" r:embed="Rd3b524e3239b48be"/>
           <a:stretch xmlns:a="http://schemas.openxmlformats.org/drawingml/2006/main"/>
         </p:blipFill>
         <p:spPr>
@@ -4617,7 +4617,7 @@
           <p:nvPr/>
         </p:nvPicPr>
         <p:blipFill>
-          <a:blip xmlns:r="http://schemas.openxmlformats.org/officeDocument/2006/relationships" xmlns:a="http://schemas.openxmlformats.org/drawingml/2006/main" r:embed="Rb900b415c9a747e7"/>
+          <a:blip xmlns:r="http://schemas.openxmlformats.org/officeDocument/2006/relationships" xmlns:a="http://schemas.openxmlformats.org/drawingml/2006/main" r:embed="R929eefec3d724baf"/>
           <a:stretch xmlns:a="http://schemas.openxmlformats.org/drawingml/2006/main"/>
         </p:blipFill>
         <p:spPr>
@@ -5224,7 +5224,7 @@
           <p:nvPr/>
         </p:nvPicPr>
         <p:blipFill>
-          <a:blip xmlns:r="http://schemas.openxmlformats.org/officeDocument/2006/relationships" xmlns:a="http://schemas.openxmlformats.org/drawingml/2006/main" r:embed="Ra9c9fb39aff2459b"/>
+          <a:blip xmlns:r="http://schemas.openxmlformats.org/officeDocument/2006/relationships" xmlns:a="http://schemas.openxmlformats.org/drawingml/2006/main" r:embed="R07154d8d3ccc4000"/>
           <a:stretch xmlns:a="http://schemas.openxmlformats.org/drawingml/2006/main"/>
         </p:blipFill>
         <p:spPr>
@@ -5831,7 +5831,7 @@
           <p:nvPr/>
         </p:nvPicPr>
         <p:blipFill>
-          <a:blip xmlns:r="http://schemas.openxmlformats.org/officeDocument/2006/relationships" xmlns:a="http://schemas.openxmlformats.org/drawingml/2006/main" r:embed="R5153dbcebb8a41c0"/>
+          <a:blip xmlns:r="http://schemas.openxmlformats.org/officeDocument/2006/relationships" xmlns:a="http://schemas.openxmlformats.org/drawingml/2006/main" r:embed="Ra2fc31fb03a747f4"/>
           <a:stretch xmlns:a="http://schemas.openxmlformats.org/drawingml/2006/main"/>
         </p:blipFill>
         <p:spPr>
@@ -6438,7 +6438,7 @@
           <p:nvPr/>
         </p:nvPicPr>
         <p:blipFill>
-          <a:blip xmlns:r="http://schemas.openxmlformats.org/officeDocument/2006/relationships" xmlns:a="http://schemas.openxmlformats.org/drawingml/2006/main" r:embed="Rabf601b5514748ed"/>
+          <a:blip xmlns:r="http://schemas.openxmlformats.org/officeDocument/2006/relationships" xmlns:a="http://schemas.openxmlformats.org/drawingml/2006/main" r:embed="R7e92e69a383a4448"/>
           <a:stretch xmlns:a="http://schemas.openxmlformats.org/drawingml/2006/main"/>
         </p:blipFill>
         <p:spPr>
@@ -7045,7 +7045,7 @@
           <p:nvPr/>
         </p:nvPicPr>
         <p:blipFill>
-          <a:blip xmlns:r="http://schemas.openxmlformats.org/officeDocument/2006/relationships" xmlns:a="http://schemas.openxmlformats.org/drawingml/2006/main" r:embed="R9da353e6a0b74497"/>
+          <a:blip xmlns:r="http://schemas.openxmlformats.org/officeDocument/2006/relationships" xmlns:a="http://schemas.openxmlformats.org/drawingml/2006/main" r:embed="Rd6ff9459d3d64ac1"/>
           <a:stretch xmlns:a="http://schemas.openxmlformats.org/drawingml/2006/main"/>
         </p:blipFill>
         <p:spPr>
@@ -7104,7 +7104,7 @@
           <p:nvPr/>
         </p:nvPicPr>
         <p:blipFill>
-          <a:blip xmlns:r="http://schemas.openxmlformats.org/officeDocument/2006/relationships" xmlns:a="http://schemas.openxmlformats.org/drawingml/2006/main" r:embed="R40770438d39c423d"/>
+          <a:blip xmlns:r="http://schemas.openxmlformats.org/officeDocument/2006/relationships" xmlns:a="http://schemas.openxmlformats.org/drawingml/2006/main" r:embed="Rdf2802bd387b4d61"/>
           <a:stretch xmlns:a="http://schemas.openxmlformats.org/drawingml/2006/main"/>
         </p:blipFill>
         <p:spPr>
@@ -7713,7 +7713,7 @@
           <p:nvPr/>
         </p:nvPicPr>
         <p:blipFill>
-          <a:blip xmlns:r="http://schemas.openxmlformats.org/officeDocument/2006/relationships" xmlns:a="http://schemas.openxmlformats.org/drawingml/2006/main" r:embed="R248810e909994356"/>
+          <a:blip xmlns:r="http://schemas.openxmlformats.org/officeDocument/2006/relationships" xmlns:a="http://schemas.openxmlformats.org/drawingml/2006/main" r:embed="R9e91d34e3ec643c5"/>
           <a:stretch xmlns:a="http://schemas.openxmlformats.org/drawingml/2006/main"/>
         </p:blipFill>
         <p:spPr>
@@ -8320,7 +8320,7 @@
           <p:nvPr/>
         </p:nvPicPr>
         <p:blipFill>
-          <a:blip xmlns:r="http://schemas.openxmlformats.org/officeDocument/2006/relationships" xmlns:a="http://schemas.openxmlformats.org/drawingml/2006/main" r:embed="R97720649de5b447a"/>
+          <a:blip xmlns:r="http://schemas.openxmlformats.org/officeDocument/2006/relationships" xmlns:a="http://schemas.openxmlformats.org/drawingml/2006/main" r:embed="R70a0cf8d9a7141bc"/>
           <a:stretch xmlns:a="http://schemas.openxmlformats.org/drawingml/2006/main"/>
         </p:blipFill>
         <p:spPr>
@@ -8929,7 +8929,7 @@
           <p:nvPr/>
         </p:nvPicPr>
         <p:blipFill>
-          <a:blip xmlns:r="http://schemas.openxmlformats.org/officeDocument/2006/relationships" xmlns:a="http://schemas.openxmlformats.org/drawingml/2006/main" r:embed="R8f264e1f19c041b5"/>
+          <a:blip xmlns:r="http://schemas.openxmlformats.org/officeDocument/2006/relationships" xmlns:a="http://schemas.openxmlformats.org/drawingml/2006/main" r:embed="R78194f9bef994801"/>
           <a:stretch xmlns:a="http://schemas.openxmlformats.org/drawingml/2006/main"/>
         </p:blipFill>
         <p:spPr>
@@ -9201,7 +9201,7 @@
                   <a:srgbClr val="075678"/>
                 </a:solidFill>
               </a:rPr>
-              <a:t>FASE 1 · EERST OEFENEN</a:t>
+              <a:t>FASE 1 · VOLLEDIGE PROEF THUIS</a:t>
             </a:r>
           </a:p>
         </p:txBody>
@@ -9252,7 +9252,7 @@
                   <a:srgbClr val="17212D"/>
                 </a:solidFill>
               </a:rPr>
-              <a:t>Test met een tijdelijke sessie van 5 vragen</a:t>
+              <a:t>Voer thuis eerst de volledige proefquiz uit</a:t>
             </a:r>
           </a:p>
         </p:txBody>
@@ -9334,7 +9334,7 @@
                   <a:srgbClr val="17212D"/>
                 </a:solidFill>
               </a:rPr>
-              <a:t>• Doorloop vooraf de volledige werking</a:t>
+              <a:t>• Tijdelijke sessie met 5 vragen</a:t>
             </a:r>
           </a:p>
           <a:p xmlns:a="http://schemas.openxmlformats.org/drawingml/2006/main">
@@ -9352,7 +9352,7 @@
                   <a:srgbClr val="17212D"/>
                 </a:solidFill>
               </a:rPr>
-              <a:t>• Oefen met enkele bestuursleden</a:t>
+              <a:t>• Doorloop vragen, tellers en eindanalyse</a:t>
             </a:r>
           </a:p>
           <a:p xmlns:a="http://schemas.openxmlformats.org/drawingml/2006/main">
@@ -9370,7 +9370,7 @@
                   <a:srgbClr val="17212D"/>
                 </a:solidFill>
               </a:rPr>
-              <a:t>• Maak daarna pas de definitieve sessie</a:t>
+              <a:t>• Druk voor deze proef nog geen briefjes af</a:t>
             </a:r>
           </a:p>
         </p:txBody>
@@ -9487,7 +9487,7 @@
                   <a:srgbClr val="168044"/>
                 </a:solidFill>
               </a:rPr>
-              <a:t>Nog geen definitieve briefjes afdrukken tijdens de proef.</a:t>
+              <a:t>Eerst volledig oefenen; daarna pas de definitieve sessie maken.</a:t>
             </a:r>
           </a:p>
         </p:txBody>
@@ -9536,7 +9536,7 @@
           <p:nvPr/>
         </p:nvPicPr>
         <p:blipFill>
-          <a:blip xmlns:r="http://schemas.openxmlformats.org/officeDocument/2006/relationships" xmlns:a="http://schemas.openxmlformats.org/drawingml/2006/main" r:embed="R0cae6bcd03914ddd"/>
+          <a:blip xmlns:r="http://schemas.openxmlformats.org/officeDocument/2006/relationships" xmlns:a="http://schemas.openxmlformats.org/drawingml/2006/main" r:embed="R008cc798349e45b8"/>
           <a:stretch xmlns:a="http://schemas.openxmlformats.org/drawingml/2006/main"/>
         </p:blipFill>
         <p:spPr>
@@ -9808,7 +9808,7 @@
                   <a:srgbClr val="075678"/>
                 </a:solidFill>
               </a:rPr>
-              <a:t>FASE 1 · DEFINITIEVE SESSIE</a:t>
+              <a:t>FASE 1 · NA DE GESLAAGDE PROEF</a:t>
             </a:r>
           </a:p>
         </p:txBody>
@@ -9859,7 +9859,7 @@
                   <a:srgbClr val="17212D"/>
                 </a:solidFill>
               </a:rPr>
-              <a:t>Maak thuis de sessie voor de echte zaalquiz</a:t>
+              <a:t>Maak nu de definitieve sessie en code</a:t>
             </a:r>
           </a:p>
         </p:txBody>
@@ -9959,7 +9959,7 @@
                   <a:srgbClr val="17212D"/>
                 </a:solidFill>
               </a:rPr>
-              <a:t>• 10 vragen aanbevolen; 20 aanbevolen maximum</a:t>
+              <a:t>• Kies het aantal vragen voor de echte quiz</a:t>
             </a:r>
           </a:p>
           <a:p xmlns:a="http://schemas.openxmlformats.org/drawingml/2006/main">
@@ -9977,7 +9977,7 @@
                   <a:srgbClr val="17212D"/>
                 </a:solidFill>
               </a:rPr>
-              <a:t>• Bewaar de definitieve driecijferige code</a:t>
+              <a:t>• Deze code komt op alle deelnemersbriefjes</a:t>
             </a:r>
           </a:p>
         </p:txBody>
@@ -10094,7 +10094,7 @@
                   <a:srgbClr val="168044"/>
                 </a:solidFill>
               </a:rPr>
-              <a:t>Vanaf nu geen nieuwe sessie en geen browsergegevens wissen.</a:t>
+              <a:t>Na het afdrukken geen nieuwe sessie of code meer maken.</a:t>
             </a:r>
           </a:p>
         </p:txBody>
@@ -10143,7 +10143,7 @@
           <p:nvPr/>
         </p:nvPicPr>
         <p:blipFill>
-          <a:blip xmlns:r="http://schemas.openxmlformats.org/officeDocument/2006/relationships" xmlns:a="http://schemas.openxmlformats.org/drawingml/2006/main" r:embed="R5ec43c2adafb4076"/>
+          <a:blip xmlns:r="http://schemas.openxmlformats.org/officeDocument/2006/relationships" xmlns:a="http://schemas.openxmlformats.org/drawingml/2006/main" r:embed="R2baedfd4c7a14b15"/>
           <a:stretch xmlns:a="http://schemas.openxmlformats.org/drawingml/2006/main"/>
         </p:blipFill>
         <p:spPr>
@@ -10750,7 +10750,7 @@
           <p:nvPr/>
         </p:nvPicPr>
         <p:blipFill>
-          <a:blip xmlns:r="http://schemas.openxmlformats.org/officeDocument/2006/relationships" xmlns:a="http://schemas.openxmlformats.org/drawingml/2006/main" r:embed="Rbfe6dfb33606455d"/>
+          <a:blip xmlns:r="http://schemas.openxmlformats.org/officeDocument/2006/relationships" xmlns:a="http://schemas.openxmlformats.org/drawingml/2006/main" r:embed="Rb7ad9c35d26b4de4"/>
           <a:stretch xmlns:a="http://schemas.openxmlformats.org/drawingml/2006/main"/>
         </p:blipFill>
         <p:spPr>
@@ -11357,7 +11357,7 @@
           <p:nvPr/>
         </p:nvPicPr>
         <p:blipFill>
-          <a:blip xmlns:r="http://schemas.openxmlformats.org/officeDocument/2006/relationships" xmlns:a="http://schemas.openxmlformats.org/drawingml/2006/main" r:embed="Rb5433dbc9ef2416b"/>
+          <a:blip xmlns:r="http://schemas.openxmlformats.org/officeDocument/2006/relationships" xmlns:a="http://schemas.openxmlformats.org/drawingml/2006/main" r:embed="R2b1b32c9ac5a4bb1"/>
           <a:stretch xmlns:a="http://schemas.openxmlformats.org/drawingml/2006/main"/>
         </p:blipFill>
         <p:spPr>
@@ -11964,7 +11964,7 @@
           <p:nvPr/>
         </p:nvPicPr>
         <p:blipFill>
-          <a:blip xmlns:r="http://schemas.openxmlformats.org/officeDocument/2006/relationships" xmlns:a="http://schemas.openxmlformats.org/drawingml/2006/main" r:embed="R04dbfb6a7be74c6f"/>
+          <a:blip xmlns:r="http://schemas.openxmlformats.org/officeDocument/2006/relationships" xmlns:a="http://schemas.openxmlformats.org/drawingml/2006/main" r:embed="R2bf21794baf74b2d"/>
           <a:stretch xmlns:a="http://schemas.openxmlformats.org/drawingml/2006/main"/>
         </p:blipFill>
         <p:spPr>
@@ -12571,7 +12571,7 @@
           <p:nvPr/>
         </p:nvPicPr>
         <p:blipFill>
-          <a:blip xmlns:r="http://schemas.openxmlformats.org/officeDocument/2006/relationships" xmlns:a="http://schemas.openxmlformats.org/drawingml/2006/main" r:embed="Re3122906ed6c43b1"/>
+          <a:blip xmlns:r="http://schemas.openxmlformats.org/officeDocument/2006/relationships" xmlns:a="http://schemas.openxmlformats.org/drawingml/2006/main" r:embed="R2c44c759035240a6"/>
           <a:stretch xmlns:a="http://schemas.openxmlformats.org/drawingml/2006/main"/>
         </p:blipFill>
         <p:spPr>

</xml_diff>